<commit_message>
Template fixes after Google Slides import test: cover logo, no line shadows, tile tints, pillar title size
Co-Authored-By: Claude Sonnet 5.5 <noreply@anthropic.com>
</commit_message>
<xml_diff>
--- a/templates/Shift-Projects-Template.pptx
+++ b/templates/Shift-Projects-Template.pptx
@@ -3251,869 +3251,16 @@
           </a:p>
         </p:txBody>
       </p:sp>
-    </p:spTree>
-  </p:cSld>
-  <p:clrMapOvr>
-    <a:masterClrMapping/>
-  </p:clrMapOvr>
-</p:sld>
-</file>
-
-<file path=ppt/slides/slide10.xml><?xml version="1.0" encoding="utf-8"?>
-<p:sld xmlns:a="http://schemas.openxmlformats.org/drawingml/2006/main" xmlns:p="http://schemas.openxmlformats.org/presentationml/2006/main" xmlns:r="http://schemas.openxmlformats.org/officeDocument/2006/relationships">
-  <p:cSld>
-    <p:spTree>
-      <p:nvGrpSpPr>
-        <p:cNvPr id="1" name=""/>
-        <p:cNvGrpSpPr/>
-        <p:nvPr/>
-      </p:nvGrpSpPr>
-      <p:grpSpPr/>
-      <p:sp>
-        <p:nvSpPr>
-          <p:cNvPr id="2" name="Eyebrow section"/>
-          <p:cNvSpPr txBox="1"/>
-          <p:nvPr/>
-        </p:nvSpPr>
-        <p:spPr>
-          <a:xfrm>
-            <a:off x="505966" y="505966"/>
-            <a:ext cx="1828795" cy="243839"/>
-          </a:xfrm>
-          <a:prstGeom prst="rect">
-            <a:avLst/>
-          </a:prstGeom>
-          <a:noFill/>
-        </p:spPr>
-        <p:txBody>
-          <a:bodyPr wrap="square" lIns="0" rIns="0" tIns="0" bIns="0" anchor="t">
-            <a:spAutoFit/>
-          </a:bodyPr>
-          <a:lstStyle/>
-          <a:p>
-            <a:pPr algn="l"/>
-            <a:r>
-              <a:rPr sz="1000" b="1" spc="160">
-                <a:solidFill>
-                  <a:schemeClr val="tx1"/>
-                </a:solidFill>
-              </a:rPr>
-              <a:t>SECTION</a:t>
-            </a:r>
-          </a:p>
-        </p:txBody>
-      </p:sp>
-      <p:cxnSp>
-        <p:nvCxnSpPr>
-          <p:cNvPr id="3" name="Eyebrow rule"/>
-          <p:cNvCxnSpPr/>
-          <p:nvPr/>
-        </p:nvCxnSpPr>
-        <p:spPr>
-          <a:xfrm>
-            <a:off x="2420105" y="560830"/>
-            <a:ext cx="938782" cy="0"/>
-          </a:xfrm>
-          <a:prstGeom prst="line">
-            <a:avLst/>
-          </a:prstGeom>
-          <a:ln w="12700">
-            <a:solidFill>
-              <a:schemeClr val="tx1"/>
-            </a:solidFill>
-          </a:ln>
-        </p:spPr>
-        <p:style>
-          <a:lnRef idx="2">
-            <a:schemeClr val="accent1"/>
-          </a:lnRef>
-          <a:fillRef idx="0">
-            <a:schemeClr val="accent1"/>
-          </a:fillRef>
-          <a:effectRef idx="1">
-            <a:schemeClr val="accent1"/>
-          </a:effectRef>
-          <a:fontRef idx="minor">
-            <a:schemeClr val="tx1"/>
-          </a:fontRef>
-        </p:style>
-      </p:cxnSp>
-      <p:sp>
-        <p:nvSpPr>
-          <p:cNvPr id="4" name="Eyebrow subsection"/>
-          <p:cNvSpPr txBox="1"/>
-          <p:nvPr/>
-        </p:nvSpPr>
-        <p:spPr>
-          <a:xfrm>
-            <a:off x="4328149" y="505966"/>
-            <a:ext cx="4876787" cy="243839"/>
-          </a:xfrm>
-          <a:prstGeom prst="rect">
-            <a:avLst/>
-          </a:prstGeom>
-          <a:noFill/>
-        </p:spPr>
-        <p:txBody>
-          <a:bodyPr wrap="square" lIns="0" rIns="0" tIns="0" bIns="0" anchor="t">
-            <a:spAutoFit/>
-          </a:bodyPr>
-          <a:lstStyle/>
-          <a:p>
-            <a:pPr algn="l"/>
-            <a:r>
-              <a:rPr sz="1000" b="1" spc="160">
-                <a:solidFill>
-                  <a:schemeClr val="tx1"/>
-                </a:solidFill>
-              </a:rPr>
-              <a:t>PROCESS AND PROJECTS</a:t>
-            </a:r>
-          </a:p>
-        </p:txBody>
-      </p:sp>
-      <p:sp>
-        <p:nvSpPr>
-          <p:cNvPr id="5" name="Photo tile 1"/>
+      <p:sp>
+        <p:nvSpPr>
+          <p:cNvPr id="4" name="Shift icon"/>
           <p:cNvSpPr/>
           <p:nvPr/>
         </p:nvSpPr>
         <p:spPr>
           <a:xfrm>
-            <a:off x="505966" y="1414268"/>
-            <a:ext cx="2950456" cy="4511028"/>
-          </a:xfrm>
-          <a:prstGeom prst="rect">
-            <a:avLst/>
-          </a:prstGeom>
-          <a:solidFill>
-            <a:schemeClr val="tx1">
-              <a:lumMod val="22000"/>
-              <a:lumOff val="78000"/>
-            </a:schemeClr>
-          </a:solidFill>
-          <a:ln>
-            <a:noFill/>
-          </a:ln>
-          <a:effectLst/>
-        </p:spPr>
-        <p:style>
-          <a:lnRef idx="1">
-            <a:schemeClr val="accent1"/>
-          </a:lnRef>
-          <a:fillRef idx="3">
-            <a:schemeClr val="accent1"/>
-          </a:fillRef>
-          <a:effectRef idx="2">
-            <a:schemeClr val="accent1"/>
-          </a:effectRef>
-          <a:fontRef idx="minor">
-            <a:schemeClr val="lt1"/>
-          </a:fontRef>
-        </p:style>
-        <p:txBody>
-          <a:bodyPr rtlCol="0" anchor="ctr"/>
-          <a:lstStyle/>
-          <a:p>
-            <a:pPr algn="ctr"/>
-          </a:p>
-        </p:txBody>
-      </p:sp>
-      <p:sp>
-        <p:nvSpPr>
-          <p:cNvPr id="6" name="Tile 1 label"/>
-          <p:cNvSpPr txBox="1"/>
-          <p:nvPr/>
-        </p:nvSpPr>
-        <p:spPr>
-          <a:xfrm>
-            <a:off x="627886" y="5608305"/>
-            <a:ext cx="1828795" cy="243839"/>
-          </a:xfrm>
-          <a:prstGeom prst="rect">
-            <a:avLst/>
-          </a:prstGeom>
-          <a:noFill/>
-        </p:spPr>
-        <p:txBody>
-          <a:bodyPr wrap="square" lIns="0" rIns="0" tIns="0" bIns="0" anchor="t">
-            <a:spAutoFit/>
-          </a:bodyPr>
-          <a:lstStyle/>
-          <a:p>
-            <a:pPr algn="l"/>
-            <a:r>
-              <a:rPr sz="1000" b="1" spc="160">
-                <a:solidFill>
-                  <a:schemeClr val="tx1">
-                    <a:lumMod val="60000"/>
-                    <a:lumOff val="40000"/>
-                  </a:schemeClr>
-                </a:solidFill>
-              </a:rPr>
-              <a:t>PROCESS</a:t>
-            </a:r>
-          </a:p>
-        </p:txBody>
-      </p:sp>
-      <p:sp>
-        <p:nvSpPr>
-          <p:cNvPr id="7" name="Photo tile 2"/>
-          <p:cNvSpPr/>
-          <p:nvPr/>
-        </p:nvSpPr>
-        <p:spPr>
-          <a:xfrm>
-            <a:off x="3639302" y="1414268"/>
-            <a:ext cx="2365242" cy="1381350"/>
-          </a:xfrm>
-          <a:prstGeom prst="rect">
-            <a:avLst/>
-          </a:prstGeom>
-          <a:solidFill>
-            <a:schemeClr val="tx1">
-              <a:lumMod val="22000"/>
-              <a:lumOff val="78000"/>
-            </a:schemeClr>
-          </a:solidFill>
-          <a:ln>
-            <a:noFill/>
-          </a:ln>
-          <a:effectLst/>
-        </p:spPr>
-        <p:style>
-          <a:lnRef idx="1">
-            <a:schemeClr val="accent1"/>
-          </a:lnRef>
-          <a:fillRef idx="3">
-            <a:schemeClr val="accent1"/>
-          </a:fillRef>
-          <a:effectRef idx="2">
-            <a:schemeClr val="accent1"/>
-          </a:effectRef>
-          <a:fontRef idx="minor">
-            <a:schemeClr val="lt1"/>
-          </a:fontRef>
-        </p:style>
-        <p:txBody>
-          <a:bodyPr rtlCol="0" anchor="ctr"/>
-          <a:lstStyle/>
-          <a:p>
-            <a:pPr algn="ctr"/>
-          </a:p>
-        </p:txBody>
-      </p:sp>
-      <p:sp>
-        <p:nvSpPr>
-          <p:cNvPr id="8" name="Tile 2 label"/>
-          <p:cNvSpPr txBox="1"/>
-          <p:nvPr/>
-        </p:nvSpPr>
-        <p:spPr>
-          <a:xfrm>
-            <a:off x="3761222" y="2478627"/>
-            <a:ext cx="1828795" cy="243839"/>
-          </a:xfrm>
-          <a:prstGeom prst="rect">
-            <a:avLst/>
-          </a:prstGeom>
-          <a:noFill/>
-        </p:spPr>
-        <p:txBody>
-          <a:bodyPr wrap="square" lIns="0" rIns="0" tIns="0" bIns="0" anchor="t">
-            <a:spAutoFit/>
-          </a:bodyPr>
-          <a:lstStyle/>
-          <a:p>
-            <a:pPr algn="l"/>
-            <a:r>
-              <a:rPr sz="1000" b="1" spc="160">
-                <a:solidFill>
-                  <a:schemeClr val="tx1">
-                    <a:lumMod val="60000"/>
-                    <a:lumOff val="40000"/>
-                  </a:schemeClr>
-                </a:solidFill>
-              </a:rPr>
-              <a:t>PROCESS</a:t>
-            </a:r>
-          </a:p>
-        </p:txBody>
-      </p:sp>
-      <p:sp>
-        <p:nvSpPr>
-          <p:cNvPr id="9" name="Photo tile 3"/>
-          <p:cNvSpPr/>
-          <p:nvPr/>
-        </p:nvSpPr>
-        <p:spPr>
-          <a:xfrm>
-            <a:off x="3639302" y="2978498"/>
-            <a:ext cx="2365242" cy="2946799"/>
-          </a:xfrm>
-          <a:prstGeom prst="rect">
-            <a:avLst/>
-          </a:prstGeom>
-          <a:solidFill>
-            <a:schemeClr val="tx1">
-              <a:lumMod val="22000"/>
-              <a:lumOff val="78000"/>
-            </a:schemeClr>
-          </a:solidFill>
-          <a:ln>
-            <a:noFill/>
-          </a:ln>
-          <a:effectLst/>
-        </p:spPr>
-        <p:style>
-          <a:lnRef idx="1">
-            <a:schemeClr val="accent1"/>
-          </a:lnRef>
-          <a:fillRef idx="3">
-            <a:schemeClr val="accent1"/>
-          </a:fillRef>
-          <a:effectRef idx="2">
-            <a:schemeClr val="accent1"/>
-          </a:effectRef>
-          <a:fontRef idx="minor">
-            <a:schemeClr val="lt1"/>
-          </a:fontRef>
-        </p:style>
-        <p:txBody>
-          <a:bodyPr rtlCol="0" anchor="ctr"/>
-          <a:lstStyle/>
-          <a:p>
-            <a:pPr algn="ctr"/>
-          </a:p>
-        </p:txBody>
-      </p:sp>
-      <p:sp>
-        <p:nvSpPr>
-          <p:cNvPr id="10" name="Tile 3 label"/>
-          <p:cNvSpPr txBox="1"/>
-          <p:nvPr/>
-        </p:nvSpPr>
-        <p:spPr>
-          <a:xfrm>
-            <a:off x="3761222" y="5608305"/>
-            <a:ext cx="1828795" cy="243839"/>
-          </a:xfrm>
-          <a:prstGeom prst="rect">
-            <a:avLst/>
-          </a:prstGeom>
-          <a:noFill/>
-        </p:spPr>
-        <p:txBody>
-          <a:bodyPr wrap="square" lIns="0" rIns="0" tIns="0" bIns="0" anchor="t">
-            <a:spAutoFit/>
-          </a:bodyPr>
-          <a:lstStyle/>
-          <a:p>
-            <a:pPr algn="l"/>
-            <a:r>
-              <a:rPr sz="1000" b="1" spc="160">
-                <a:solidFill>
-                  <a:schemeClr val="tx1">
-                    <a:lumMod val="60000"/>
-                    <a:lumOff val="40000"/>
-                  </a:schemeClr>
-                </a:solidFill>
-              </a:rPr>
-              <a:t>PROCESS</a:t>
-            </a:r>
-          </a:p>
-        </p:txBody>
-      </p:sp>
-      <p:sp>
-        <p:nvSpPr>
-          <p:cNvPr id="11" name="Photo tile 4"/>
-          <p:cNvSpPr/>
-          <p:nvPr/>
-        </p:nvSpPr>
-        <p:spPr>
-          <a:xfrm>
-            <a:off x="6187424" y="1414268"/>
-            <a:ext cx="1767835" cy="2824879"/>
-          </a:xfrm>
-          <a:prstGeom prst="rect">
-            <a:avLst/>
-          </a:prstGeom>
-          <a:solidFill>
-            <a:schemeClr val="tx1">
-              <a:lumMod val="12000"/>
-              <a:lumOff val="88000"/>
-            </a:schemeClr>
-          </a:solidFill>
-          <a:ln>
-            <a:noFill/>
-          </a:ln>
-          <a:effectLst/>
-        </p:spPr>
-        <p:style>
-          <a:lnRef idx="1">
-            <a:schemeClr val="accent1"/>
-          </a:lnRef>
-          <a:fillRef idx="3">
-            <a:schemeClr val="accent1"/>
-          </a:fillRef>
-          <a:effectRef idx="2">
-            <a:schemeClr val="accent1"/>
-          </a:effectRef>
-          <a:fontRef idx="minor">
-            <a:schemeClr val="lt1"/>
-          </a:fontRef>
-        </p:style>
-        <p:txBody>
-          <a:bodyPr rtlCol="0" anchor="ctr"/>
-          <a:lstStyle/>
-          <a:p>
-            <a:pPr algn="ctr"/>
-          </a:p>
-        </p:txBody>
-      </p:sp>
-      <p:sp>
-        <p:nvSpPr>
-          <p:cNvPr id="12" name="Tile 4 label"/>
-          <p:cNvSpPr txBox="1"/>
-          <p:nvPr/>
-        </p:nvSpPr>
-        <p:spPr>
-          <a:xfrm>
-            <a:off x="6309344" y="3922156"/>
-            <a:ext cx="1828795" cy="243839"/>
-          </a:xfrm>
-          <a:prstGeom prst="rect">
-            <a:avLst/>
-          </a:prstGeom>
-          <a:noFill/>
-        </p:spPr>
-        <p:txBody>
-          <a:bodyPr wrap="square" lIns="0" rIns="0" tIns="0" bIns="0" anchor="t">
-            <a:spAutoFit/>
-          </a:bodyPr>
-          <a:lstStyle/>
-          <a:p>
-            <a:pPr algn="l"/>
-            <a:r>
-              <a:rPr sz="1000" b="1" spc="160">
-                <a:solidFill>
-                  <a:schemeClr val="tx1">
-                    <a:lumMod val="60000"/>
-                    <a:lumOff val="40000"/>
-                  </a:schemeClr>
-                </a:solidFill>
-              </a:rPr>
-              <a:t>PROJECT</a:t>
-            </a:r>
-          </a:p>
-        </p:txBody>
-      </p:sp>
-      <p:sp>
-        <p:nvSpPr>
-          <p:cNvPr id="13" name="Photo tile 5"/>
-          <p:cNvSpPr/>
-          <p:nvPr/>
-        </p:nvSpPr>
-        <p:spPr>
-          <a:xfrm>
-            <a:off x="8138139" y="1414268"/>
-            <a:ext cx="3547863" cy="2824879"/>
-          </a:xfrm>
-          <a:prstGeom prst="rect">
-            <a:avLst/>
-          </a:prstGeom>
-          <a:solidFill>
-            <a:schemeClr val="tx1">
-              <a:lumMod val="12000"/>
-              <a:lumOff val="88000"/>
-            </a:schemeClr>
-          </a:solidFill>
-          <a:ln>
-            <a:noFill/>
-          </a:ln>
-          <a:effectLst/>
-        </p:spPr>
-        <p:style>
-          <a:lnRef idx="1">
-            <a:schemeClr val="accent1"/>
-          </a:lnRef>
-          <a:fillRef idx="3">
-            <a:schemeClr val="accent1"/>
-          </a:fillRef>
-          <a:effectRef idx="2">
-            <a:schemeClr val="accent1"/>
-          </a:effectRef>
-          <a:fontRef idx="minor">
-            <a:schemeClr val="lt1"/>
-          </a:fontRef>
-        </p:style>
-        <p:txBody>
-          <a:bodyPr rtlCol="0" anchor="ctr"/>
-          <a:lstStyle/>
-          <a:p>
-            <a:pPr algn="ctr"/>
-          </a:p>
-        </p:txBody>
-      </p:sp>
-      <p:sp>
-        <p:nvSpPr>
-          <p:cNvPr id="14" name="Tile 5 label"/>
-          <p:cNvSpPr txBox="1"/>
-          <p:nvPr/>
-        </p:nvSpPr>
-        <p:spPr>
-          <a:xfrm>
-            <a:off x="8260059" y="3922156"/>
-            <a:ext cx="1828795" cy="243839"/>
-          </a:xfrm>
-          <a:prstGeom prst="rect">
-            <a:avLst/>
-          </a:prstGeom>
-          <a:noFill/>
-        </p:spPr>
-        <p:txBody>
-          <a:bodyPr wrap="square" lIns="0" rIns="0" tIns="0" bIns="0" anchor="t">
-            <a:spAutoFit/>
-          </a:bodyPr>
-          <a:lstStyle/>
-          <a:p>
-            <a:pPr algn="l"/>
-            <a:r>
-              <a:rPr sz="1000" b="1" spc="160">
-                <a:solidFill>
-                  <a:schemeClr val="tx1">
-                    <a:lumMod val="60000"/>
-                    <a:lumOff val="40000"/>
-                  </a:schemeClr>
-                </a:solidFill>
-              </a:rPr>
-              <a:t>PROJECT</a:t>
-            </a:r>
-          </a:p>
-        </p:txBody>
-      </p:sp>
-      <p:sp>
-        <p:nvSpPr>
-          <p:cNvPr id="15" name="Photo tile 6"/>
-          <p:cNvSpPr/>
-          <p:nvPr/>
-        </p:nvSpPr>
-        <p:spPr>
-          <a:xfrm>
-            <a:off x="6187424" y="4401300"/>
-            <a:ext cx="5498578" cy="1523996"/>
-          </a:xfrm>
-          <a:prstGeom prst="rect">
-            <a:avLst/>
-          </a:prstGeom>
-          <a:solidFill>
-            <a:schemeClr val="tx1">
-              <a:lumMod val="12000"/>
-              <a:lumOff val="88000"/>
-            </a:schemeClr>
-          </a:solidFill>
-          <a:ln>
-            <a:noFill/>
-          </a:ln>
-          <a:effectLst/>
-        </p:spPr>
-        <p:style>
-          <a:lnRef idx="1">
-            <a:schemeClr val="accent1"/>
-          </a:lnRef>
-          <a:fillRef idx="3">
-            <a:schemeClr val="accent1"/>
-          </a:fillRef>
-          <a:effectRef idx="2">
-            <a:schemeClr val="accent1"/>
-          </a:effectRef>
-          <a:fontRef idx="minor">
-            <a:schemeClr val="lt1"/>
-          </a:fontRef>
-        </p:style>
-        <p:txBody>
-          <a:bodyPr rtlCol="0" anchor="ctr"/>
-          <a:lstStyle/>
-          <a:p>
-            <a:pPr algn="ctr"/>
-          </a:p>
-        </p:txBody>
-      </p:sp>
-      <p:sp>
-        <p:nvSpPr>
-          <p:cNvPr id="16" name="Tile 6 label"/>
-          <p:cNvSpPr txBox="1"/>
-          <p:nvPr/>
-        </p:nvSpPr>
-        <p:spPr>
-          <a:xfrm>
-            <a:off x="6309344" y="5608305"/>
-            <a:ext cx="1828795" cy="243839"/>
-          </a:xfrm>
-          <a:prstGeom prst="rect">
-            <a:avLst/>
-          </a:prstGeom>
-          <a:noFill/>
-        </p:spPr>
-        <p:txBody>
-          <a:bodyPr wrap="square" lIns="0" rIns="0" tIns="0" bIns="0" anchor="t">
-            <a:spAutoFit/>
-          </a:bodyPr>
-          <a:lstStyle/>
-          <a:p>
-            <a:pPr algn="l"/>
-            <a:r>
-              <a:rPr sz="1000" b="1" spc="160">
-                <a:solidFill>
-                  <a:schemeClr val="tx1">
-                    <a:lumMod val="60000"/>
-                    <a:lumOff val="40000"/>
-                  </a:schemeClr>
-                </a:solidFill>
-              </a:rPr>
-              <a:t>PROJECT</a:t>
-            </a:r>
-          </a:p>
-        </p:txBody>
-      </p:sp>
-    </p:spTree>
-  </p:cSld>
-  <p:clrMapOvr>
-    <a:masterClrMapping/>
-  </p:clrMapOvr>
-</p:sld>
-</file>
-
-<file path=ppt/slides/slide11.xml><?xml version="1.0" encoding="utf-8"?>
-<p:sld xmlns:a="http://schemas.openxmlformats.org/drawingml/2006/main" xmlns:p="http://schemas.openxmlformats.org/presentationml/2006/main" xmlns:r="http://schemas.openxmlformats.org/officeDocument/2006/relationships">
-  <p:cSld>
-    <p:spTree>
-      <p:nvGrpSpPr>
-        <p:cNvPr id="1" name=""/>
-        <p:cNvGrpSpPr/>
-        <p:nvPr/>
-      </p:nvGrpSpPr>
-      <p:grpSpPr/>
-      <p:sp>
-        <p:nvSpPr>
-          <p:cNvPr id="2" name="Eyebrow section"/>
-          <p:cNvSpPr txBox="1"/>
-          <p:nvPr/>
-        </p:nvSpPr>
-        <p:spPr>
-          <a:xfrm>
-            <a:off x="505966" y="505966"/>
-            <a:ext cx="1828795" cy="243839"/>
-          </a:xfrm>
-          <a:prstGeom prst="rect">
-            <a:avLst/>
-          </a:prstGeom>
-          <a:noFill/>
-        </p:spPr>
-        <p:txBody>
-          <a:bodyPr wrap="square" lIns="0" rIns="0" tIns="0" bIns="0" anchor="t">
-            <a:spAutoFit/>
-          </a:bodyPr>
-          <a:lstStyle/>
-          <a:p>
-            <a:pPr algn="l"/>
-            <a:r>
-              <a:rPr sz="1000" b="1" spc="160">
-                <a:solidFill>
-                  <a:schemeClr val="tx1"/>
-                </a:solidFill>
-              </a:rPr>
-              <a:t>SECTION</a:t>
-            </a:r>
-          </a:p>
-        </p:txBody>
-      </p:sp>
-      <p:cxnSp>
-        <p:nvCxnSpPr>
-          <p:cNvPr id="3" name="Eyebrow rule"/>
-          <p:cNvCxnSpPr/>
-          <p:nvPr/>
-        </p:nvCxnSpPr>
-        <p:spPr>
-          <a:xfrm>
-            <a:off x="2420105" y="560830"/>
-            <a:ext cx="938782" cy="0"/>
-          </a:xfrm>
-          <a:prstGeom prst="line">
-            <a:avLst/>
-          </a:prstGeom>
-          <a:ln w="12700">
-            <a:solidFill>
-              <a:schemeClr val="tx1"/>
-            </a:solidFill>
-          </a:ln>
-        </p:spPr>
-        <p:style>
-          <a:lnRef idx="2">
-            <a:schemeClr val="accent1"/>
-          </a:lnRef>
-          <a:fillRef idx="0">
-            <a:schemeClr val="accent1"/>
-          </a:fillRef>
-          <a:effectRef idx="1">
-            <a:schemeClr val="accent1"/>
-          </a:effectRef>
-          <a:fontRef idx="minor">
-            <a:schemeClr val="tx1"/>
-          </a:fontRef>
-        </p:style>
-      </p:cxnSp>
-      <p:sp>
-        <p:nvSpPr>
-          <p:cNvPr id="4" name="Eyebrow subsection"/>
-          <p:cNvSpPr txBox="1"/>
-          <p:nvPr/>
-        </p:nvSpPr>
-        <p:spPr>
-          <a:xfrm>
-            <a:off x="4328149" y="505966"/>
-            <a:ext cx="4876787" cy="243839"/>
-          </a:xfrm>
-          <a:prstGeom prst="rect">
-            <a:avLst/>
-          </a:prstGeom>
-          <a:noFill/>
-        </p:spPr>
-        <p:txBody>
-          <a:bodyPr wrap="square" lIns="0" rIns="0" tIns="0" bIns="0" anchor="t">
-            <a:spAutoFit/>
-          </a:bodyPr>
-          <a:lstStyle/>
-          <a:p>
-            <a:pPr algn="l"/>
-            <a:r>
-              <a:rPr sz="1000" b="1" spc="160">
-                <a:solidFill>
-                  <a:schemeClr val="tx1"/>
-                </a:solidFill>
-              </a:rPr>
-              <a:t>IN THEIR WORDS</a:t>
-            </a:r>
-          </a:p>
-        </p:txBody>
-      </p:sp>
-      <p:sp>
-        <p:nvSpPr>
-          <p:cNvPr id="5" name="Quote"/>
-          <p:cNvSpPr txBox="1"/>
-          <p:nvPr/>
-        </p:nvSpPr>
-        <p:spPr>
-          <a:xfrm>
-            <a:off x="505966" y="1402076"/>
-            <a:ext cx="9997415" cy="3657590"/>
-          </a:xfrm>
-          <a:prstGeom prst="rect">
-            <a:avLst/>
-          </a:prstGeom>
-          <a:noFill/>
-        </p:spPr>
-        <p:txBody>
-          <a:bodyPr wrap="square" lIns="0" rIns="0" tIns="0" bIns="0" anchor="t">
-            <a:spAutoFit/>
-          </a:bodyPr>
-          <a:lstStyle/>
-          <a:p>
-            <a:pPr algn="l">
-              <a:lnSpc>
-                <a:spcPct val="98000"/>
-              </a:lnSpc>
-            </a:pPr>
-            <a:r>
-              <a:rPr sz="4800" b="0" spc="-50">
-                <a:solidFill>
-                  <a:schemeClr val="tx1"/>
-                </a:solidFill>
-                <a:latin typeface="+mj-lt"/>
-              </a:rPr>
-              <a:t>“They treated our home like it was theirs, and told us the truth at every step.”</a:t>
-            </a:r>
-          </a:p>
-        </p:txBody>
-      </p:sp>
-      <p:sp>
-        <p:nvSpPr>
-          <p:cNvPr id="6" name="Attribution"/>
-          <p:cNvSpPr txBox="1"/>
-          <p:nvPr/>
-        </p:nvSpPr>
-        <p:spPr>
-          <a:xfrm>
-            <a:off x="505966" y="5059667"/>
-            <a:ext cx="4876787" cy="243839"/>
-          </a:xfrm>
-          <a:prstGeom prst="rect">
-            <a:avLst/>
-          </a:prstGeom>
-          <a:noFill/>
-        </p:spPr>
-        <p:txBody>
-          <a:bodyPr wrap="square" lIns="0" rIns="0" tIns="0" bIns="0" anchor="t">
-            <a:spAutoFit/>
-          </a:bodyPr>
-          <a:lstStyle/>
-          <a:p>
-            <a:pPr algn="l"/>
-            <a:r>
-              <a:rPr sz="1100" b="1" spc="160">
-                <a:solidFill>
-                  <a:schemeClr val="tx1"/>
-                </a:solidFill>
-              </a:rPr>
-              <a:t>CLIENT NAME</a:t>
-            </a:r>
-          </a:p>
-        </p:txBody>
-      </p:sp>
-      <p:sp>
-        <p:nvSpPr>
-          <p:cNvPr id="7" name="Attribution detail"/>
-          <p:cNvSpPr txBox="1"/>
-          <p:nvPr/>
-        </p:nvSpPr>
-        <p:spPr>
-          <a:xfrm>
-            <a:off x="505966" y="5364466"/>
-            <a:ext cx="4876787" cy="365759"/>
-          </a:xfrm>
-          <a:prstGeom prst="rect">
-            <a:avLst/>
-          </a:prstGeom>
-          <a:noFill/>
-        </p:spPr>
-        <p:txBody>
-          <a:bodyPr wrap="square" lIns="0" rIns="0" tIns="0" bIns="0" anchor="t">
-            <a:spAutoFit/>
-          </a:bodyPr>
-          <a:lstStyle/>
-          <a:p>
-            <a:pPr algn="l"/>
-            <a:r>
-              <a:rPr sz="1400" b="0">
-                <a:solidFill>
-                  <a:schemeClr val="tx1"/>
-                </a:solidFill>
-              </a:rPr>
-              <a:t>Project, neighbourhood</a:t>
-            </a:r>
-          </a:p>
-        </p:txBody>
-      </p:sp>
-      <p:sp>
-        <p:nvSpPr>
-          <p:cNvPr id="8" name="Shift icon"/>
-          <p:cNvSpPr/>
-          <p:nvPr/>
-        </p:nvSpPr>
-        <p:spPr>
-          <a:xfrm>
-            <a:off x="10893524" y="5303506"/>
-            <a:ext cx="792478" cy="661247"/>
+            <a:off x="11027636" y="505966"/>
+            <a:ext cx="658366" cy="549344"/>
           </a:xfrm>
           <a:custGeom>
             <a:avLst/>
@@ -4305,7 +3452,7 @@
 </p:sld>
 </file>
 
-<file path=ppt/slides/slide12.xml><?xml version="1.0" encoding="utf-8"?>
+<file path=ppt/slides/slide10.xml><?xml version="1.0" encoding="utf-8"?>
 <p:sld xmlns:a="http://schemas.openxmlformats.org/drawingml/2006/main" xmlns:p="http://schemas.openxmlformats.org/presentationml/2006/main" xmlns:r="http://schemas.openxmlformats.org/officeDocument/2006/relationships">
   <p:cSld>
     <p:spTree>
@@ -4369,20 +3516,6 @@
             </a:solidFill>
           </a:ln>
         </p:spPr>
-        <p:style>
-          <a:lnRef idx="2">
-            <a:schemeClr val="accent1"/>
-          </a:lnRef>
-          <a:fillRef idx="0">
-            <a:schemeClr val="accent1"/>
-          </a:fillRef>
-          <a:effectRef idx="1">
-            <a:schemeClr val="accent1"/>
-          </a:effectRef>
-          <a:fontRef idx="minor">
-            <a:schemeClr val="tx1"/>
-          </a:fontRef>
-        </p:style>
       </p:cxnSp>
       <p:sp>
         <p:nvSpPr>
@@ -4413,185 +3546,29 @@
                   <a:schemeClr val="tx1"/>
                 </a:solidFill>
               </a:rPr>
-              <a:t>4.1 TONE DIALS</a:t>
-            </a:r>
-          </a:p>
-        </p:txBody>
-      </p:sp>
-      <p:sp>
-        <p:nvSpPr>
-          <p:cNvPr id="5" name="Heading"/>
-          <p:cNvSpPr txBox="1"/>
-          <p:nvPr/>
-        </p:nvSpPr>
-        <p:spPr>
-          <a:xfrm>
-            <a:off x="505966" y="1402076"/>
-            <a:ext cx="4145269" cy="2438393"/>
-          </a:xfrm>
-          <a:prstGeom prst="rect">
-            <a:avLst/>
-          </a:prstGeom>
-          <a:noFill/>
-        </p:spPr>
-        <p:txBody>
-          <a:bodyPr wrap="square" lIns="0" rIns="0" tIns="0" bIns="0" anchor="t">
-            <a:spAutoFit/>
-          </a:bodyPr>
-          <a:lstStyle/>
-          <a:p>
-            <a:pPr algn="l">
-              <a:lnSpc>
-                <a:spcPct val="92000"/>
-              </a:lnSpc>
-            </a:pPr>
-            <a:r>
-              <a:rPr sz="4800" b="0" spc="-50">
-                <a:solidFill>
-                  <a:schemeClr val="tx1"/>
-                </a:solidFill>
-                <a:latin typeface="+mj-lt"/>
-              </a:rPr>
-              <a:t>How do we</a:t>
-            </a:r>
-          </a:p>
-          <a:p>
-            <a:pPr algn="l">
-              <a:lnSpc>
-                <a:spcPct val="92000"/>
-              </a:lnSpc>
-            </a:pPr>
-            <a:r>
-              <a:rPr sz="4800" b="0" spc="-50">
-                <a:solidFill>
-                  <a:schemeClr val="tx1"/>
-                </a:solidFill>
-                <a:latin typeface="+mj-lt"/>
-              </a:rPr>
-              <a:t>speak?</a:t>
-            </a:r>
-          </a:p>
-        </p:txBody>
-      </p:sp>
-      <p:sp>
-        <p:nvSpPr>
-          <p:cNvPr id="6" name="Dial 1 left"/>
-          <p:cNvSpPr txBox="1"/>
-          <p:nvPr/>
-        </p:nvSpPr>
-        <p:spPr>
-          <a:xfrm>
-            <a:off x="6217904" y="1414268"/>
-            <a:ext cx="2682233" cy="243839"/>
-          </a:xfrm>
-          <a:prstGeom prst="rect">
-            <a:avLst/>
-          </a:prstGeom>
-          <a:noFill/>
-        </p:spPr>
-        <p:txBody>
-          <a:bodyPr wrap="square" lIns="0" rIns="0" tIns="0" bIns="0" anchor="t">
-            <a:spAutoFit/>
-          </a:bodyPr>
-          <a:lstStyle/>
-          <a:p>
-            <a:pPr algn="l"/>
-            <a:r>
-              <a:rPr sz="1000" b="1" spc="160">
-                <a:solidFill>
-                  <a:schemeClr val="tx1"/>
-                </a:solidFill>
-              </a:rPr>
-              <a:t>CASUAL</a:t>
-            </a:r>
-          </a:p>
-        </p:txBody>
-      </p:sp>
-      <p:sp>
-        <p:nvSpPr>
-          <p:cNvPr id="7" name="Dial 1 right"/>
-          <p:cNvSpPr txBox="1"/>
-          <p:nvPr/>
-        </p:nvSpPr>
-        <p:spPr>
-          <a:xfrm>
-            <a:off x="9003769" y="1414268"/>
-            <a:ext cx="2682233" cy="243839"/>
-          </a:xfrm>
-          <a:prstGeom prst="rect">
-            <a:avLst/>
-          </a:prstGeom>
-          <a:noFill/>
-        </p:spPr>
-        <p:txBody>
-          <a:bodyPr wrap="square" lIns="0" rIns="0" tIns="0" bIns="0" anchor="t">
-            <a:spAutoFit/>
-          </a:bodyPr>
-          <a:lstStyle/>
-          <a:p>
-            <a:pPr algn="r"/>
-            <a:r>
-              <a:rPr sz="1000" b="1" spc="160">
-                <a:solidFill>
-                  <a:schemeClr val="tx1"/>
-                </a:solidFill>
-              </a:rPr>
-              <a:t>FORMAL</a:t>
-            </a:r>
-          </a:p>
-        </p:txBody>
-      </p:sp>
-      <p:cxnSp>
-        <p:nvCxnSpPr>
-          <p:cNvPr id="8" name="Dial 1 line"/>
-          <p:cNvCxnSpPr/>
-          <p:nvPr/>
-        </p:nvCxnSpPr>
-        <p:spPr>
-          <a:xfrm>
-            <a:off x="6217904" y="1804411"/>
-            <a:ext cx="5468098" cy="0"/>
-          </a:xfrm>
-          <a:prstGeom prst="line">
-            <a:avLst/>
-          </a:prstGeom>
-          <a:ln w="9525">
-            <a:solidFill>
-              <a:schemeClr val="tx1"/>
-            </a:solidFill>
-          </a:ln>
-        </p:spPr>
-        <p:style>
-          <a:lnRef idx="2">
-            <a:schemeClr val="accent1"/>
-          </a:lnRef>
-          <a:fillRef idx="0">
-            <a:schemeClr val="accent1"/>
-          </a:fillRef>
-          <a:effectRef idx="1">
-            <a:schemeClr val="accent1"/>
-          </a:effectRef>
-          <a:fontRef idx="minor">
-            <a:schemeClr val="tx1"/>
-          </a:fontRef>
-        </p:style>
-      </p:cxnSp>
-      <p:sp>
-        <p:nvSpPr>
-          <p:cNvPr id="9" name="Dial 1 dot"/>
+              <a:t>PROCESS AND PROJECTS</a:t>
+            </a:r>
+          </a:p>
+        </p:txBody>
+      </p:sp>
+      <p:sp>
+        <p:nvSpPr>
+          <p:cNvPr id="5" name="Photo tile 1"/>
           <p:cNvSpPr/>
           <p:nvPr/>
         </p:nvSpPr>
         <p:spPr>
           <a:xfrm>
-            <a:off x="9307105" y="1722115"/>
-            <a:ext cx="164591" cy="164591"/>
-          </a:xfrm>
-          <a:prstGeom prst="ellipse">
+            <a:off x="505966" y="1414268"/>
+            <a:ext cx="2950456" cy="4511028"/>
+          </a:xfrm>
+          <a:prstGeom prst="rect">
             <a:avLst/>
           </a:prstGeom>
           <a:solidFill>
-            <a:schemeClr val="accent3"/>
+            <a:schemeClr val="bg1">
+              <a:lumMod val="80000"/>
+            </a:schemeClr>
           </a:solidFill>
           <a:ln>
             <a:noFill/>
@@ -4622,14 +3599,14 @@
       </p:sp>
       <p:sp>
         <p:nvSpPr>
-          <p:cNvPr id="10" name="Dial 2 left"/>
-          <p:cNvSpPr txBox="1"/>
-          <p:nvPr/>
-        </p:nvSpPr>
-        <p:spPr>
-          <a:xfrm>
-            <a:off x="6217904" y="2182362"/>
-            <a:ext cx="2682233" cy="243839"/>
+          <p:cNvPr id="6" name="Tile 1 label"/>
+          <p:cNvSpPr txBox="1"/>
+          <p:nvPr/>
+        </p:nvSpPr>
+        <p:spPr>
+          <a:xfrm>
+            <a:off x="627886" y="5608305"/>
+            <a:ext cx="1828795" cy="243839"/>
           </a:xfrm>
           <a:prstGeom prst="rect">
             <a:avLst/>
@@ -4646,99 +3623,35 @@
             <a:r>
               <a:rPr sz="1000" b="1" spc="160">
                 <a:solidFill>
-                  <a:schemeClr val="tx1"/>
-                </a:solidFill>
-              </a:rPr>
-              <a:t>FUN</a:t>
-            </a:r>
-          </a:p>
-        </p:txBody>
-      </p:sp>
-      <p:sp>
-        <p:nvSpPr>
-          <p:cNvPr id="11" name="Dial 2 right"/>
-          <p:cNvSpPr txBox="1"/>
-          <p:nvPr/>
-        </p:nvSpPr>
-        <p:spPr>
-          <a:xfrm>
-            <a:off x="9003769" y="2182362"/>
-            <a:ext cx="2682233" cy="243839"/>
-          </a:xfrm>
-          <a:prstGeom prst="rect">
-            <a:avLst/>
-          </a:prstGeom>
-          <a:noFill/>
-        </p:spPr>
-        <p:txBody>
-          <a:bodyPr wrap="square" lIns="0" rIns="0" tIns="0" bIns="0" anchor="t">
-            <a:spAutoFit/>
-          </a:bodyPr>
-          <a:lstStyle/>
-          <a:p>
-            <a:pPr algn="r"/>
-            <a:r>
-              <a:rPr sz="1000" b="1" spc="160">
-                <a:solidFill>
-                  <a:schemeClr val="tx1"/>
-                </a:solidFill>
-              </a:rPr>
-              <a:t>SERIOUS</a:t>
-            </a:r>
-          </a:p>
-        </p:txBody>
-      </p:sp>
-      <p:cxnSp>
-        <p:nvCxnSpPr>
-          <p:cNvPr id="12" name="Dial 2 line"/>
-          <p:cNvCxnSpPr/>
-          <p:nvPr/>
-        </p:nvCxnSpPr>
-        <p:spPr>
-          <a:xfrm>
-            <a:off x="6217904" y="2572505"/>
-            <a:ext cx="5468098" cy="0"/>
-          </a:xfrm>
-          <a:prstGeom prst="line">
-            <a:avLst/>
-          </a:prstGeom>
-          <a:ln w="9525">
-            <a:solidFill>
-              <a:schemeClr val="tx1"/>
-            </a:solidFill>
-          </a:ln>
-        </p:spPr>
-        <p:style>
-          <a:lnRef idx="2">
-            <a:schemeClr val="accent1"/>
-          </a:lnRef>
-          <a:fillRef idx="0">
-            <a:schemeClr val="accent1"/>
-          </a:fillRef>
-          <a:effectRef idx="1">
-            <a:schemeClr val="accent1"/>
-          </a:effectRef>
-          <a:fontRef idx="minor">
-            <a:schemeClr val="tx1"/>
-          </a:fontRef>
-        </p:style>
-      </p:cxnSp>
-      <p:sp>
-        <p:nvSpPr>
-          <p:cNvPr id="13" name="Dial 2 dot"/>
+                  <a:schemeClr val="tx1">
+                    <a:lumMod val="60000"/>
+                    <a:lumOff val="40000"/>
+                  </a:schemeClr>
+                </a:solidFill>
+              </a:rPr>
+              <a:t>PROCESS</a:t>
+            </a:r>
+          </a:p>
+        </p:txBody>
+      </p:sp>
+      <p:sp>
+        <p:nvSpPr>
+          <p:cNvPr id="7" name="Photo tile 2"/>
           <p:cNvSpPr/>
           <p:nvPr/>
         </p:nvSpPr>
         <p:spPr>
           <a:xfrm>
-            <a:off x="9416467" y="2490209"/>
-            <a:ext cx="164591" cy="164591"/>
-          </a:xfrm>
-          <a:prstGeom prst="ellipse">
+            <a:off x="3639302" y="1414268"/>
+            <a:ext cx="2365242" cy="1381350"/>
+          </a:xfrm>
+          <a:prstGeom prst="rect">
             <a:avLst/>
           </a:prstGeom>
           <a:solidFill>
-            <a:schemeClr val="accent4"/>
+            <a:schemeClr val="bg1">
+              <a:lumMod val="80000"/>
+            </a:schemeClr>
           </a:solidFill>
           <a:ln>
             <a:noFill/>
@@ -4769,14 +3682,14 @@
       </p:sp>
       <p:sp>
         <p:nvSpPr>
-          <p:cNvPr id="14" name="Dial 3 left"/>
-          <p:cNvSpPr txBox="1"/>
-          <p:nvPr/>
-        </p:nvSpPr>
-        <p:spPr>
-          <a:xfrm>
-            <a:off x="6217904" y="2950456"/>
-            <a:ext cx="2682233" cy="243839"/>
+          <p:cNvPr id="8" name="Tile 2 label"/>
+          <p:cNvSpPr txBox="1"/>
+          <p:nvPr/>
+        </p:nvSpPr>
+        <p:spPr>
+          <a:xfrm>
+            <a:off x="3761222" y="2478627"/>
+            <a:ext cx="1828795" cy="243839"/>
           </a:xfrm>
           <a:prstGeom prst="rect">
             <a:avLst/>
@@ -4793,99 +3706,35 @@
             <a:r>
               <a:rPr sz="1000" b="1" spc="160">
                 <a:solidFill>
-                  <a:schemeClr val="tx1"/>
-                </a:solidFill>
-              </a:rPr>
-              <a:t>REALISTIC</a:t>
-            </a:r>
-          </a:p>
-        </p:txBody>
-      </p:sp>
-      <p:sp>
-        <p:nvSpPr>
-          <p:cNvPr id="15" name="Dial 3 right"/>
-          <p:cNvSpPr txBox="1"/>
-          <p:nvPr/>
-        </p:nvSpPr>
-        <p:spPr>
-          <a:xfrm>
-            <a:off x="9003769" y="2950456"/>
-            <a:ext cx="2682233" cy="243839"/>
-          </a:xfrm>
-          <a:prstGeom prst="rect">
-            <a:avLst/>
-          </a:prstGeom>
-          <a:noFill/>
-        </p:spPr>
-        <p:txBody>
-          <a:bodyPr wrap="square" lIns="0" rIns="0" tIns="0" bIns="0" anchor="t">
-            <a:spAutoFit/>
-          </a:bodyPr>
-          <a:lstStyle/>
-          <a:p>
-            <a:pPr algn="r"/>
-            <a:r>
-              <a:rPr sz="1000" b="1" spc="160">
-                <a:solidFill>
-                  <a:schemeClr val="tx1"/>
-                </a:solidFill>
-              </a:rPr>
-              <a:t>IDEALISTIC</a:t>
-            </a:r>
-          </a:p>
-        </p:txBody>
-      </p:sp>
-      <p:cxnSp>
-        <p:nvCxnSpPr>
-          <p:cNvPr id="16" name="Dial 3 line"/>
-          <p:cNvCxnSpPr/>
-          <p:nvPr/>
-        </p:nvCxnSpPr>
-        <p:spPr>
-          <a:xfrm>
-            <a:off x="6217904" y="3340599"/>
-            <a:ext cx="5468098" cy="0"/>
-          </a:xfrm>
-          <a:prstGeom prst="line">
-            <a:avLst/>
-          </a:prstGeom>
-          <a:ln w="9525">
-            <a:solidFill>
-              <a:schemeClr val="tx1"/>
-            </a:solidFill>
-          </a:ln>
-        </p:spPr>
-        <p:style>
-          <a:lnRef idx="2">
-            <a:schemeClr val="accent1"/>
-          </a:lnRef>
-          <a:fillRef idx="0">
-            <a:schemeClr val="accent1"/>
-          </a:fillRef>
-          <a:effectRef idx="1">
-            <a:schemeClr val="accent1"/>
-          </a:effectRef>
-          <a:fontRef idx="minor">
-            <a:schemeClr val="tx1"/>
-          </a:fontRef>
-        </p:style>
-      </p:cxnSp>
-      <p:sp>
-        <p:nvSpPr>
-          <p:cNvPr id="17" name="Dial 3 dot"/>
+                  <a:schemeClr val="tx1">
+                    <a:lumMod val="60000"/>
+                    <a:lumOff val="40000"/>
+                  </a:schemeClr>
+                </a:solidFill>
+              </a:rPr>
+              <a:t>PROCESS</a:t>
+            </a:r>
+          </a:p>
+        </p:txBody>
+      </p:sp>
+      <p:sp>
+        <p:nvSpPr>
+          <p:cNvPr id="9" name="Photo tile 3"/>
           <p:cNvSpPr/>
           <p:nvPr/>
         </p:nvSpPr>
         <p:spPr>
           <a:xfrm>
-            <a:off x="10072639" y="3258303"/>
-            <a:ext cx="164591" cy="164591"/>
-          </a:xfrm>
-          <a:prstGeom prst="ellipse">
+            <a:off x="3639302" y="2978498"/>
+            <a:ext cx="2365242" cy="2946799"/>
+          </a:xfrm>
+          <a:prstGeom prst="rect">
             <a:avLst/>
           </a:prstGeom>
           <a:solidFill>
-            <a:schemeClr val="accent1"/>
+            <a:schemeClr val="bg1">
+              <a:lumMod val="80000"/>
+            </a:schemeClr>
           </a:solidFill>
           <a:ln>
             <a:noFill/>
@@ -4916,14 +3765,14 @@
       </p:sp>
       <p:sp>
         <p:nvSpPr>
-          <p:cNvPr id="18" name="Dial 4 left"/>
-          <p:cNvSpPr txBox="1"/>
-          <p:nvPr/>
-        </p:nvSpPr>
-        <p:spPr>
-          <a:xfrm>
-            <a:off x="6217904" y="3718550"/>
-            <a:ext cx="2682233" cy="243839"/>
+          <p:cNvPr id="10" name="Tile 3 label"/>
+          <p:cNvSpPr txBox="1"/>
+          <p:nvPr/>
+        </p:nvSpPr>
+        <p:spPr>
+          <a:xfrm>
+            <a:off x="3761222" y="5608305"/>
+            <a:ext cx="1828795" cy="243839"/>
           </a:xfrm>
           <a:prstGeom prst="rect">
             <a:avLst/>
@@ -4940,99 +3789,35 @@
             <a:r>
               <a:rPr sz="1000" b="1" spc="160">
                 <a:solidFill>
-                  <a:schemeClr val="tx1"/>
-                </a:solidFill>
-              </a:rPr>
-              <a:t>APPROACHABLE</a:t>
-            </a:r>
-          </a:p>
-        </p:txBody>
-      </p:sp>
-      <p:sp>
-        <p:nvSpPr>
-          <p:cNvPr id="19" name="Dial 4 right"/>
-          <p:cNvSpPr txBox="1"/>
-          <p:nvPr/>
-        </p:nvSpPr>
-        <p:spPr>
-          <a:xfrm>
-            <a:off x="9003769" y="3718550"/>
-            <a:ext cx="2682233" cy="243839"/>
-          </a:xfrm>
-          <a:prstGeom prst="rect">
-            <a:avLst/>
-          </a:prstGeom>
-          <a:noFill/>
-        </p:spPr>
-        <p:txBody>
-          <a:bodyPr wrap="square" lIns="0" rIns="0" tIns="0" bIns="0" anchor="t">
-            <a:spAutoFit/>
-          </a:bodyPr>
-          <a:lstStyle/>
-          <a:p>
-            <a:pPr algn="r"/>
-            <a:r>
-              <a:rPr sz="1000" b="1" spc="160">
-                <a:solidFill>
-                  <a:schemeClr val="tx1"/>
-                </a:solidFill>
-              </a:rPr>
-              <a:t>EXCLUSIVE</a:t>
-            </a:r>
-          </a:p>
-        </p:txBody>
-      </p:sp>
-      <p:cxnSp>
-        <p:nvCxnSpPr>
-          <p:cNvPr id="20" name="Dial 4 line"/>
-          <p:cNvCxnSpPr/>
-          <p:nvPr/>
-        </p:nvCxnSpPr>
-        <p:spPr>
-          <a:xfrm>
-            <a:off x="6217904" y="4108693"/>
-            <a:ext cx="5468098" cy="0"/>
-          </a:xfrm>
-          <a:prstGeom prst="line">
-            <a:avLst/>
-          </a:prstGeom>
-          <a:ln w="9525">
-            <a:solidFill>
-              <a:schemeClr val="tx1"/>
-            </a:solidFill>
-          </a:ln>
-        </p:spPr>
-        <p:style>
-          <a:lnRef idx="2">
-            <a:schemeClr val="accent1"/>
-          </a:lnRef>
-          <a:fillRef idx="0">
-            <a:schemeClr val="accent1"/>
-          </a:fillRef>
-          <a:effectRef idx="1">
-            <a:schemeClr val="accent1"/>
-          </a:effectRef>
-          <a:fontRef idx="minor">
-            <a:schemeClr val="tx1"/>
-          </a:fontRef>
-        </p:style>
-      </p:cxnSp>
-      <p:sp>
-        <p:nvSpPr>
-          <p:cNvPr id="21" name="Dial 4 dot"/>
+                  <a:schemeClr val="tx1">
+                    <a:lumMod val="60000"/>
+                    <a:lumOff val="40000"/>
+                  </a:schemeClr>
+                </a:solidFill>
+              </a:rPr>
+              <a:t>PROCESS</a:t>
+            </a:r>
+          </a:p>
+        </p:txBody>
+      </p:sp>
+      <p:sp>
+        <p:nvSpPr>
+          <p:cNvPr id="11" name="Photo tile 4"/>
           <p:cNvSpPr/>
           <p:nvPr/>
         </p:nvSpPr>
         <p:spPr>
           <a:xfrm>
-            <a:off x="9361786" y="4026397"/>
-            <a:ext cx="164591" cy="164591"/>
-          </a:xfrm>
-          <a:prstGeom prst="ellipse">
+            <a:off x="6187424" y="1414268"/>
+            <a:ext cx="1767835" cy="2824879"/>
+          </a:xfrm>
+          <a:prstGeom prst="rect">
             <a:avLst/>
           </a:prstGeom>
           <a:solidFill>
-            <a:schemeClr val="accent2"/>
+            <a:schemeClr val="bg1">
+              <a:lumMod val="91000"/>
+            </a:schemeClr>
           </a:solidFill>
           <a:ln>
             <a:noFill/>
@@ -5063,14 +3848,14 @@
       </p:sp>
       <p:sp>
         <p:nvSpPr>
-          <p:cNvPr id="22" name="Dial 5 left"/>
-          <p:cNvSpPr txBox="1"/>
-          <p:nvPr/>
-        </p:nvSpPr>
-        <p:spPr>
-          <a:xfrm>
-            <a:off x="6217904" y="4486644"/>
-            <a:ext cx="2682233" cy="243839"/>
+          <p:cNvPr id="12" name="Tile 4 label"/>
+          <p:cNvSpPr txBox="1"/>
+          <p:nvPr/>
+        </p:nvSpPr>
+        <p:spPr>
+          <a:xfrm>
+            <a:off x="6309344" y="3922156"/>
+            <a:ext cx="1828795" cy="243839"/>
           </a:xfrm>
           <a:prstGeom prst="rect">
             <a:avLst/>
@@ -5087,99 +3872,35 @@
             <a:r>
               <a:rPr sz="1000" b="1" spc="160">
                 <a:solidFill>
-                  <a:schemeClr val="tx1"/>
-                </a:solidFill>
-              </a:rPr>
-              <a:t>TRADITIONAL</a:t>
-            </a:r>
-          </a:p>
-        </p:txBody>
-      </p:sp>
-      <p:sp>
-        <p:nvSpPr>
-          <p:cNvPr id="23" name="Dial 5 right"/>
-          <p:cNvSpPr txBox="1"/>
-          <p:nvPr/>
-        </p:nvSpPr>
-        <p:spPr>
-          <a:xfrm>
-            <a:off x="9003769" y="4486644"/>
-            <a:ext cx="2682233" cy="243839"/>
-          </a:xfrm>
-          <a:prstGeom prst="rect">
-            <a:avLst/>
-          </a:prstGeom>
-          <a:noFill/>
-        </p:spPr>
-        <p:txBody>
-          <a:bodyPr wrap="square" lIns="0" rIns="0" tIns="0" bIns="0" anchor="t">
-            <a:spAutoFit/>
-          </a:bodyPr>
-          <a:lstStyle/>
-          <a:p>
-            <a:pPr algn="r"/>
-            <a:r>
-              <a:rPr sz="1000" b="1" spc="160">
-                <a:solidFill>
-                  <a:schemeClr val="tx1"/>
-                </a:solidFill>
-              </a:rPr>
-              <a:t>NONTRADITIONAL</a:t>
-            </a:r>
-          </a:p>
-        </p:txBody>
-      </p:sp>
-      <p:cxnSp>
-        <p:nvCxnSpPr>
-          <p:cNvPr id="24" name="Dial 5 line"/>
-          <p:cNvCxnSpPr/>
-          <p:nvPr/>
-        </p:nvCxnSpPr>
-        <p:spPr>
-          <a:xfrm>
-            <a:off x="6217904" y="4876787"/>
-            <a:ext cx="5468098" cy="0"/>
-          </a:xfrm>
-          <a:prstGeom prst="line">
-            <a:avLst/>
-          </a:prstGeom>
-          <a:ln w="9525">
-            <a:solidFill>
-              <a:schemeClr val="tx1"/>
-            </a:solidFill>
-          </a:ln>
-        </p:spPr>
-        <p:style>
-          <a:lnRef idx="2">
-            <a:schemeClr val="accent1"/>
-          </a:lnRef>
-          <a:fillRef idx="0">
-            <a:schemeClr val="accent1"/>
-          </a:fillRef>
-          <a:effectRef idx="1">
-            <a:schemeClr val="accent1"/>
-          </a:effectRef>
-          <a:fontRef idx="minor">
-            <a:schemeClr val="tx1"/>
-          </a:fontRef>
-        </p:style>
-      </p:cxnSp>
-      <p:sp>
-        <p:nvSpPr>
-          <p:cNvPr id="25" name="Dial 5 dot"/>
+                  <a:schemeClr val="tx1">
+                    <a:lumMod val="60000"/>
+                    <a:lumOff val="40000"/>
+                  </a:schemeClr>
+                </a:solidFill>
+              </a:rPr>
+              <a:t>PROJECT</a:t>
+            </a:r>
+          </a:p>
+        </p:txBody>
+      </p:sp>
+      <p:sp>
+        <p:nvSpPr>
+          <p:cNvPr id="13" name="Photo tile 5"/>
           <p:cNvSpPr/>
           <p:nvPr/>
         </p:nvSpPr>
         <p:spPr>
           <a:xfrm>
-            <a:off x="9908596" y="4794492"/>
-            <a:ext cx="164591" cy="164591"/>
-          </a:xfrm>
-          <a:prstGeom prst="ellipse">
+            <a:off x="8138139" y="1414268"/>
+            <a:ext cx="3547863" cy="2824879"/>
+          </a:xfrm>
+          <a:prstGeom prst="rect">
             <a:avLst/>
           </a:prstGeom>
           <a:solidFill>
-            <a:schemeClr val="accent3"/>
+            <a:schemeClr val="bg1">
+              <a:lumMod val="91000"/>
+            </a:schemeClr>
           </a:solidFill>
           <a:ln>
             <a:noFill/>
@@ -5210,14 +3931,14 @@
       </p:sp>
       <p:sp>
         <p:nvSpPr>
-          <p:cNvPr id="26" name="Dial 6 left"/>
-          <p:cNvSpPr txBox="1"/>
-          <p:nvPr/>
-        </p:nvSpPr>
-        <p:spPr>
-          <a:xfrm>
-            <a:off x="6217904" y="5254738"/>
-            <a:ext cx="2682233" cy="243839"/>
+          <p:cNvPr id="14" name="Tile 5 label"/>
+          <p:cNvSpPr txBox="1"/>
+          <p:nvPr/>
+        </p:nvSpPr>
+        <p:spPr>
+          <a:xfrm>
+            <a:off x="8260059" y="3922156"/>
+            <a:ext cx="1828795" cy="243839"/>
           </a:xfrm>
           <a:prstGeom prst="rect">
             <a:avLst/>
@@ -5234,57 +3955,746 @@
             <a:r>
               <a:rPr sz="1000" b="1" spc="160">
                 <a:solidFill>
-                  <a:schemeClr val="tx1"/>
-                </a:solidFill>
-              </a:rPr>
-              <a:t>FRIENDLY</a:t>
-            </a:r>
-          </a:p>
-        </p:txBody>
-      </p:sp>
-      <p:sp>
-        <p:nvSpPr>
-          <p:cNvPr id="27" name="Dial 6 right"/>
-          <p:cNvSpPr txBox="1"/>
-          <p:nvPr/>
-        </p:nvSpPr>
-        <p:spPr>
-          <a:xfrm>
-            <a:off x="9003769" y="5254738"/>
-            <a:ext cx="2682233" cy="243839"/>
-          </a:xfrm>
-          <a:prstGeom prst="rect">
-            <a:avLst/>
-          </a:prstGeom>
-          <a:noFill/>
-        </p:spPr>
-        <p:txBody>
-          <a:bodyPr wrap="square" lIns="0" rIns="0" tIns="0" bIns="0" anchor="t">
-            <a:spAutoFit/>
-          </a:bodyPr>
-          <a:lstStyle/>
-          <a:p>
-            <a:pPr algn="r"/>
+                  <a:schemeClr val="tx1">
+                    <a:lumMod val="60000"/>
+                    <a:lumOff val="40000"/>
+                  </a:schemeClr>
+                </a:solidFill>
+              </a:rPr>
+              <a:t>PROJECT</a:t>
+            </a:r>
+          </a:p>
+        </p:txBody>
+      </p:sp>
+      <p:sp>
+        <p:nvSpPr>
+          <p:cNvPr id="15" name="Photo tile 6"/>
+          <p:cNvSpPr/>
+          <p:nvPr/>
+        </p:nvSpPr>
+        <p:spPr>
+          <a:xfrm>
+            <a:off x="6187424" y="4401300"/>
+            <a:ext cx="5498578" cy="1523996"/>
+          </a:xfrm>
+          <a:prstGeom prst="rect">
+            <a:avLst/>
+          </a:prstGeom>
+          <a:solidFill>
+            <a:schemeClr val="bg1">
+              <a:lumMod val="91000"/>
+            </a:schemeClr>
+          </a:solidFill>
+          <a:ln>
+            <a:noFill/>
+          </a:ln>
+          <a:effectLst/>
+        </p:spPr>
+        <p:style>
+          <a:lnRef idx="1">
+            <a:schemeClr val="accent1"/>
+          </a:lnRef>
+          <a:fillRef idx="3">
+            <a:schemeClr val="accent1"/>
+          </a:fillRef>
+          <a:effectRef idx="2">
+            <a:schemeClr val="accent1"/>
+          </a:effectRef>
+          <a:fontRef idx="minor">
+            <a:schemeClr val="lt1"/>
+          </a:fontRef>
+        </p:style>
+        <p:txBody>
+          <a:bodyPr rtlCol="0" anchor="ctr"/>
+          <a:lstStyle/>
+          <a:p>
+            <a:pPr algn="ctr"/>
+          </a:p>
+        </p:txBody>
+      </p:sp>
+      <p:sp>
+        <p:nvSpPr>
+          <p:cNvPr id="16" name="Tile 6 label"/>
+          <p:cNvSpPr txBox="1"/>
+          <p:nvPr/>
+        </p:nvSpPr>
+        <p:spPr>
+          <a:xfrm>
+            <a:off x="6309344" y="5608305"/>
+            <a:ext cx="1828795" cy="243839"/>
+          </a:xfrm>
+          <a:prstGeom prst="rect">
+            <a:avLst/>
+          </a:prstGeom>
+          <a:noFill/>
+        </p:spPr>
+        <p:txBody>
+          <a:bodyPr wrap="square" lIns="0" rIns="0" tIns="0" bIns="0" anchor="t">
+            <a:spAutoFit/>
+          </a:bodyPr>
+          <a:lstStyle/>
+          <a:p>
+            <a:pPr algn="l"/>
             <a:r>
               <a:rPr sz="1000" b="1" spc="160">
                 <a:solidFill>
-                  <a:schemeClr val="tx1"/>
-                </a:solidFill>
-              </a:rPr>
-              <a:t>PROFESSIONAL</a:t>
+                  <a:schemeClr val="tx1">
+                    <a:lumMod val="60000"/>
+                    <a:lumOff val="40000"/>
+                  </a:schemeClr>
+                </a:solidFill>
+              </a:rPr>
+              <a:t>PROJECT</a:t>
+            </a:r>
+          </a:p>
+        </p:txBody>
+      </p:sp>
+    </p:spTree>
+  </p:cSld>
+  <p:clrMapOvr>
+    <a:masterClrMapping/>
+  </p:clrMapOvr>
+</p:sld>
+</file>
+
+<file path=ppt/slides/slide11.xml><?xml version="1.0" encoding="utf-8"?>
+<p:sld xmlns:a="http://schemas.openxmlformats.org/drawingml/2006/main" xmlns:p="http://schemas.openxmlformats.org/presentationml/2006/main" xmlns:r="http://schemas.openxmlformats.org/officeDocument/2006/relationships">
+  <p:cSld>
+    <p:spTree>
+      <p:nvGrpSpPr>
+        <p:cNvPr id="1" name=""/>
+        <p:cNvGrpSpPr/>
+        <p:nvPr/>
+      </p:nvGrpSpPr>
+      <p:grpSpPr/>
+      <p:sp>
+        <p:nvSpPr>
+          <p:cNvPr id="2" name="Eyebrow section"/>
+          <p:cNvSpPr txBox="1"/>
+          <p:nvPr/>
+        </p:nvSpPr>
+        <p:spPr>
+          <a:xfrm>
+            <a:off x="505966" y="505966"/>
+            <a:ext cx="1828795" cy="243839"/>
+          </a:xfrm>
+          <a:prstGeom prst="rect">
+            <a:avLst/>
+          </a:prstGeom>
+          <a:noFill/>
+        </p:spPr>
+        <p:txBody>
+          <a:bodyPr wrap="square" lIns="0" rIns="0" tIns="0" bIns="0" anchor="t">
+            <a:spAutoFit/>
+          </a:bodyPr>
+          <a:lstStyle/>
+          <a:p>
+            <a:pPr algn="l"/>
+            <a:r>
+              <a:rPr sz="1000" b="1" spc="160">
+                <a:solidFill>
+                  <a:schemeClr val="tx1"/>
+                </a:solidFill>
+              </a:rPr>
+              <a:t>SECTION</a:t>
             </a:r>
           </a:p>
         </p:txBody>
       </p:sp>
       <p:cxnSp>
         <p:nvCxnSpPr>
-          <p:cNvPr id="28" name="Dial 6 line"/>
+          <p:cNvPr id="3" name="Eyebrow rule"/>
           <p:cNvCxnSpPr/>
           <p:nvPr/>
         </p:nvCxnSpPr>
         <p:spPr>
           <a:xfrm>
-            <a:off x="6217904" y="5644881"/>
+            <a:off x="2420105" y="560830"/>
+            <a:ext cx="938782" cy="0"/>
+          </a:xfrm>
+          <a:prstGeom prst="line">
+            <a:avLst/>
+          </a:prstGeom>
+          <a:ln w="12700">
+            <a:solidFill>
+              <a:schemeClr val="tx1"/>
+            </a:solidFill>
+          </a:ln>
+        </p:spPr>
+      </p:cxnSp>
+      <p:sp>
+        <p:nvSpPr>
+          <p:cNvPr id="4" name="Eyebrow subsection"/>
+          <p:cNvSpPr txBox="1"/>
+          <p:nvPr/>
+        </p:nvSpPr>
+        <p:spPr>
+          <a:xfrm>
+            <a:off x="4328149" y="505966"/>
+            <a:ext cx="4876787" cy="243839"/>
+          </a:xfrm>
+          <a:prstGeom prst="rect">
+            <a:avLst/>
+          </a:prstGeom>
+          <a:noFill/>
+        </p:spPr>
+        <p:txBody>
+          <a:bodyPr wrap="square" lIns="0" rIns="0" tIns="0" bIns="0" anchor="t">
+            <a:spAutoFit/>
+          </a:bodyPr>
+          <a:lstStyle/>
+          <a:p>
+            <a:pPr algn="l"/>
+            <a:r>
+              <a:rPr sz="1000" b="1" spc="160">
+                <a:solidFill>
+                  <a:schemeClr val="tx1"/>
+                </a:solidFill>
+              </a:rPr>
+              <a:t>IN THEIR WORDS</a:t>
+            </a:r>
+          </a:p>
+        </p:txBody>
+      </p:sp>
+      <p:sp>
+        <p:nvSpPr>
+          <p:cNvPr id="5" name="Quote"/>
+          <p:cNvSpPr txBox="1"/>
+          <p:nvPr/>
+        </p:nvSpPr>
+        <p:spPr>
+          <a:xfrm>
+            <a:off x="505966" y="1402076"/>
+            <a:ext cx="9997415" cy="3657590"/>
+          </a:xfrm>
+          <a:prstGeom prst="rect">
+            <a:avLst/>
+          </a:prstGeom>
+          <a:noFill/>
+        </p:spPr>
+        <p:txBody>
+          <a:bodyPr wrap="square" lIns="0" rIns="0" tIns="0" bIns="0" anchor="t">
+            <a:spAutoFit/>
+          </a:bodyPr>
+          <a:lstStyle/>
+          <a:p>
+            <a:pPr algn="l">
+              <a:lnSpc>
+                <a:spcPct val="98000"/>
+              </a:lnSpc>
+            </a:pPr>
+            <a:r>
+              <a:rPr sz="4800" b="0" spc="-50">
+                <a:solidFill>
+                  <a:schemeClr val="tx1"/>
+                </a:solidFill>
+                <a:latin typeface="+mj-lt"/>
+              </a:rPr>
+              <a:t>“They treated our home like it was theirs, and told us the truth at every step.”</a:t>
+            </a:r>
+          </a:p>
+        </p:txBody>
+      </p:sp>
+      <p:sp>
+        <p:nvSpPr>
+          <p:cNvPr id="6" name="Attribution"/>
+          <p:cNvSpPr txBox="1"/>
+          <p:nvPr/>
+        </p:nvSpPr>
+        <p:spPr>
+          <a:xfrm>
+            <a:off x="505966" y="5059667"/>
+            <a:ext cx="4876787" cy="243839"/>
+          </a:xfrm>
+          <a:prstGeom prst="rect">
+            <a:avLst/>
+          </a:prstGeom>
+          <a:noFill/>
+        </p:spPr>
+        <p:txBody>
+          <a:bodyPr wrap="square" lIns="0" rIns="0" tIns="0" bIns="0" anchor="t">
+            <a:spAutoFit/>
+          </a:bodyPr>
+          <a:lstStyle/>
+          <a:p>
+            <a:pPr algn="l"/>
+            <a:r>
+              <a:rPr sz="1100" b="1" spc="160">
+                <a:solidFill>
+                  <a:schemeClr val="tx1"/>
+                </a:solidFill>
+              </a:rPr>
+              <a:t>CLIENT NAME</a:t>
+            </a:r>
+          </a:p>
+        </p:txBody>
+      </p:sp>
+      <p:sp>
+        <p:nvSpPr>
+          <p:cNvPr id="7" name="Attribution detail"/>
+          <p:cNvSpPr txBox="1"/>
+          <p:nvPr/>
+        </p:nvSpPr>
+        <p:spPr>
+          <a:xfrm>
+            <a:off x="505966" y="5364466"/>
+            <a:ext cx="4876787" cy="365759"/>
+          </a:xfrm>
+          <a:prstGeom prst="rect">
+            <a:avLst/>
+          </a:prstGeom>
+          <a:noFill/>
+        </p:spPr>
+        <p:txBody>
+          <a:bodyPr wrap="square" lIns="0" rIns="0" tIns="0" bIns="0" anchor="t">
+            <a:spAutoFit/>
+          </a:bodyPr>
+          <a:lstStyle/>
+          <a:p>
+            <a:pPr algn="l"/>
+            <a:r>
+              <a:rPr sz="1400" b="0">
+                <a:solidFill>
+                  <a:schemeClr val="tx1"/>
+                </a:solidFill>
+              </a:rPr>
+              <a:t>Project, neighbourhood</a:t>
+            </a:r>
+          </a:p>
+        </p:txBody>
+      </p:sp>
+      <p:sp>
+        <p:nvSpPr>
+          <p:cNvPr id="8" name="Shift icon"/>
+          <p:cNvSpPr/>
+          <p:nvPr/>
+        </p:nvSpPr>
+        <p:spPr>
+          <a:xfrm>
+            <a:off x="10893524" y="5303506"/>
+            <a:ext cx="792478" cy="661247"/>
+          </a:xfrm>
+          <a:custGeom>
+            <a:avLst/>
+            <a:gdLst/>
+            <a:ahLst/>
+            <a:cxnLst/>
+            <a:rect l="0" t="0" r="r" b="b"/>
+            <a:pathLst>
+              <a:path w="31100" h="25950">
+                <a:moveTo>
+                  <a:pt x="23195" y="5625"/>
+                </a:moveTo>
+                <a:lnTo>
+                  <a:pt x="18380" y="5613"/>
+                </a:lnTo>
+                <a:cubicBezTo>
+                  <a:pt x="17807" y="5612"/>
+                  <a:pt x="17285" y="5945"/>
+                  <a:pt x="17045" y="6466"/>
+                </a:cubicBezTo>
+                <a:lnTo>
+                  <a:pt x="15815" y="9133"/>
+                </a:lnTo>
+                <a:cubicBezTo>
+                  <a:pt x="15453" y="9916"/>
+                  <a:pt x="14668" y="10418"/>
+                  <a:pt x="13805" y="10416"/>
+                </a:cubicBezTo>
+                <a:lnTo>
+                  <a:pt x="7799" y="10400"/>
+                </a:lnTo>
+                <a:cubicBezTo>
+                  <a:pt x="6310" y="10397"/>
+                  <a:pt x="5108" y="9154"/>
+                  <a:pt x="5168" y="7652"/>
+                </a:cubicBezTo>
+                <a:cubicBezTo>
+                  <a:pt x="5226" y="6223"/>
+                  <a:pt x="6448" y="5117"/>
+                  <a:pt x="7878" y="5120"/>
+                </a:cubicBezTo>
+                <a:lnTo>
+                  <a:pt x="17523" y="5145"/>
+                </a:lnTo>
+                <a:cubicBezTo>
+                  <a:pt x="17780" y="5145"/>
+                  <a:pt x="18015" y="4996"/>
+                  <a:pt x="18122" y="4762"/>
+                </a:cubicBezTo>
+                <a:lnTo>
+                  <a:pt x="20314" y="9"/>
+                </a:lnTo>
+                <a:lnTo>
+                  <a:pt x="7924" y="7"/>
+                </a:lnTo>
+                <a:cubicBezTo>
+                  <a:pt x="3655" y="-4"/>
+                  <a:pt x="105" y="3396"/>
+                  <a:pt x="53" y="7664"/>
+                </a:cubicBezTo>
+                <a:cubicBezTo>
+                  <a:pt x="0" y="11975"/>
+                  <a:pt x="3486" y="15504"/>
+                  <a:pt x="7787" y="15514"/>
+                </a:cubicBezTo>
+                <a:lnTo>
+                  <a:pt x="12364" y="15525"/>
+                </a:lnTo>
+                <a:cubicBezTo>
+                  <a:pt x="12847" y="15527"/>
+                  <a:pt x="13287" y="15246"/>
+                  <a:pt x="13490" y="14807"/>
+                </a:cubicBezTo>
+                <a:lnTo>
+                  <a:pt x="14781" y="12006"/>
+                </a:lnTo>
+                <a:cubicBezTo>
+                  <a:pt x="15143" y="11222"/>
+                  <a:pt x="15928" y="10721"/>
+                  <a:pt x="16791" y="10723"/>
+                </a:cubicBezTo>
+                <a:lnTo>
+                  <a:pt x="23236" y="10739"/>
+                </a:lnTo>
+                <a:cubicBezTo>
+                  <a:pt x="24665" y="10743"/>
+                  <a:pt x="25882" y="11855"/>
+                  <a:pt x="25933" y="13284"/>
+                </a:cubicBezTo>
+                <a:cubicBezTo>
+                  <a:pt x="25986" y="14786"/>
+                  <a:pt x="24777" y="16023"/>
+                  <a:pt x="23288" y="16020"/>
+                </a:cubicBezTo>
+                <a:lnTo>
+                  <a:pt x="13392" y="15995"/>
+                </a:lnTo>
+                <a:cubicBezTo>
+                  <a:pt x="12940" y="15994"/>
+                  <a:pt x="12530" y="16256"/>
+                  <a:pt x="12341" y="16666"/>
+                </a:cubicBezTo>
+                <a:lnTo>
+                  <a:pt x="10940" y="19703"/>
+                </a:lnTo>
+                <a:cubicBezTo>
+                  <a:pt x="10621" y="20395"/>
+                  <a:pt x="9927" y="20838"/>
+                  <a:pt x="9164" y="20836"/>
+                </a:cubicBezTo>
+                <a:lnTo>
+                  <a:pt x="3836" y="20823"/>
+                </a:lnTo>
+                <a:cubicBezTo>
+                  <a:pt x="3526" y="20822"/>
+                  <a:pt x="3245" y="21002"/>
+                  <a:pt x="3115" y="21283"/>
+                </a:cubicBezTo>
+                <a:lnTo>
+                  <a:pt x="968" y="25929"/>
+                </a:lnTo>
+                <a:lnTo>
+                  <a:pt x="6622" y="25943"/>
+                </a:lnTo>
+                <a:cubicBezTo>
+                  <a:pt x="7672" y="25946"/>
+                  <a:pt x="8628" y="25336"/>
+                  <a:pt x="9069" y="24382"/>
+                </a:cubicBezTo>
+                <a:lnTo>
+                  <a:pt x="10057" y="22238"/>
+                </a:lnTo>
+                <a:cubicBezTo>
+                  <a:pt x="10376" y="21545"/>
+                  <a:pt x="11069" y="21127"/>
+                  <a:pt x="11831" y="21129"/>
+                </a:cubicBezTo>
+                <a:lnTo>
+                  <a:pt x="23275" y="21129"/>
+                </a:lnTo>
+                <a:cubicBezTo>
+                  <a:pt x="27590" y="21139"/>
+                  <a:pt x="31100" y="17611"/>
+                  <a:pt x="31047" y="13282"/>
+                </a:cubicBezTo>
+                <a:cubicBezTo>
+                  <a:pt x="30995" y="9026"/>
+                  <a:pt x="27452" y="5636"/>
+                  <a:pt x="23195" y="5625"/>
+                </a:cubicBezTo>
+              </a:path>
+            </a:pathLst>
+          </a:custGeom>
+          <a:solidFill>
+            <a:schemeClr val="tx1"/>
+          </a:solidFill>
+          <a:ln>
+            <a:noFill/>
+          </a:ln>
+          <a:effectLst/>
+        </p:spPr>
+        <p:style>
+          <a:lnRef idx="1">
+            <a:schemeClr val="accent1"/>
+          </a:lnRef>
+          <a:fillRef idx="3">
+            <a:schemeClr val="accent1"/>
+          </a:fillRef>
+          <a:effectRef idx="2">
+            <a:schemeClr val="accent1"/>
+          </a:effectRef>
+          <a:fontRef idx="minor">
+            <a:schemeClr val="lt1"/>
+          </a:fontRef>
+        </p:style>
+        <p:txBody>
+          <a:bodyPr rtlCol="0" anchor="ctr"/>
+          <a:lstStyle/>
+          <a:p>
+            <a:pPr algn="ctr"/>
+          </a:p>
+        </p:txBody>
+      </p:sp>
+    </p:spTree>
+  </p:cSld>
+  <p:clrMapOvr>
+    <a:masterClrMapping/>
+  </p:clrMapOvr>
+</p:sld>
+</file>
+
+<file path=ppt/slides/slide12.xml><?xml version="1.0" encoding="utf-8"?>
+<p:sld xmlns:a="http://schemas.openxmlformats.org/drawingml/2006/main" xmlns:p="http://schemas.openxmlformats.org/presentationml/2006/main" xmlns:r="http://schemas.openxmlformats.org/officeDocument/2006/relationships">
+  <p:cSld>
+    <p:spTree>
+      <p:nvGrpSpPr>
+        <p:cNvPr id="1" name=""/>
+        <p:cNvGrpSpPr/>
+        <p:nvPr/>
+      </p:nvGrpSpPr>
+      <p:grpSpPr/>
+      <p:sp>
+        <p:nvSpPr>
+          <p:cNvPr id="2" name="Eyebrow section"/>
+          <p:cNvSpPr txBox="1"/>
+          <p:nvPr/>
+        </p:nvSpPr>
+        <p:spPr>
+          <a:xfrm>
+            <a:off x="505966" y="505966"/>
+            <a:ext cx="1828795" cy="243839"/>
+          </a:xfrm>
+          <a:prstGeom prst="rect">
+            <a:avLst/>
+          </a:prstGeom>
+          <a:noFill/>
+        </p:spPr>
+        <p:txBody>
+          <a:bodyPr wrap="square" lIns="0" rIns="0" tIns="0" bIns="0" anchor="t">
+            <a:spAutoFit/>
+          </a:bodyPr>
+          <a:lstStyle/>
+          <a:p>
+            <a:pPr algn="l"/>
+            <a:r>
+              <a:rPr sz="1000" b="1" spc="160">
+                <a:solidFill>
+                  <a:schemeClr val="tx1"/>
+                </a:solidFill>
+              </a:rPr>
+              <a:t>SECTION</a:t>
+            </a:r>
+          </a:p>
+        </p:txBody>
+      </p:sp>
+      <p:cxnSp>
+        <p:nvCxnSpPr>
+          <p:cNvPr id="3" name="Eyebrow rule"/>
+          <p:cNvCxnSpPr/>
+          <p:nvPr/>
+        </p:nvCxnSpPr>
+        <p:spPr>
+          <a:xfrm>
+            <a:off x="2420105" y="560830"/>
+            <a:ext cx="938782" cy="0"/>
+          </a:xfrm>
+          <a:prstGeom prst="line">
+            <a:avLst/>
+          </a:prstGeom>
+          <a:ln w="12700">
+            <a:solidFill>
+              <a:schemeClr val="tx1"/>
+            </a:solidFill>
+          </a:ln>
+        </p:spPr>
+      </p:cxnSp>
+      <p:sp>
+        <p:nvSpPr>
+          <p:cNvPr id="4" name="Eyebrow subsection"/>
+          <p:cNvSpPr txBox="1"/>
+          <p:nvPr/>
+        </p:nvSpPr>
+        <p:spPr>
+          <a:xfrm>
+            <a:off x="4328149" y="505966"/>
+            <a:ext cx="4876787" cy="243839"/>
+          </a:xfrm>
+          <a:prstGeom prst="rect">
+            <a:avLst/>
+          </a:prstGeom>
+          <a:noFill/>
+        </p:spPr>
+        <p:txBody>
+          <a:bodyPr wrap="square" lIns="0" rIns="0" tIns="0" bIns="0" anchor="t">
+            <a:spAutoFit/>
+          </a:bodyPr>
+          <a:lstStyle/>
+          <a:p>
+            <a:pPr algn="l"/>
+            <a:r>
+              <a:rPr sz="1000" b="1" spc="160">
+                <a:solidFill>
+                  <a:schemeClr val="tx1"/>
+                </a:solidFill>
+              </a:rPr>
+              <a:t>4.1 TONE DIALS</a:t>
+            </a:r>
+          </a:p>
+        </p:txBody>
+      </p:sp>
+      <p:sp>
+        <p:nvSpPr>
+          <p:cNvPr id="5" name="Heading"/>
+          <p:cNvSpPr txBox="1"/>
+          <p:nvPr/>
+        </p:nvSpPr>
+        <p:spPr>
+          <a:xfrm>
+            <a:off x="505966" y="1402076"/>
+            <a:ext cx="4145269" cy="2438393"/>
+          </a:xfrm>
+          <a:prstGeom prst="rect">
+            <a:avLst/>
+          </a:prstGeom>
+          <a:noFill/>
+        </p:spPr>
+        <p:txBody>
+          <a:bodyPr wrap="square" lIns="0" rIns="0" tIns="0" bIns="0" anchor="t">
+            <a:spAutoFit/>
+          </a:bodyPr>
+          <a:lstStyle/>
+          <a:p>
+            <a:pPr algn="l">
+              <a:lnSpc>
+                <a:spcPct val="92000"/>
+              </a:lnSpc>
+            </a:pPr>
+            <a:r>
+              <a:rPr sz="4800" b="0" spc="-50">
+                <a:solidFill>
+                  <a:schemeClr val="tx1"/>
+                </a:solidFill>
+                <a:latin typeface="+mj-lt"/>
+              </a:rPr>
+              <a:t>How do we</a:t>
+            </a:r>
+          </a:p>
+          <a:p>
+            <a:pPr algn="l">
+              <a:lnSpc>
+                <a:spcPct val="92000"/>
+              </a:lnSpc>
+            </a:pPr>
+            <a:r>
+              <a:rPr sz="4800" b="0" spc="-50">
+                <a:solidFill>
+                  <a:schemeClr val="tx1"/>
+                </a:solidFill>
+                <a:latin typeface="+mj-lt"/>
+              </a:rPr>
+              <a:t>speak?</a:t>
+            </a:r>
+          </a:p>
+        </p:txBody>
+      </p:sp>
+      <p:sp>
+        <p:nvSpPr>
+          <p:cNvPr id="6" name="Dial 1 left"/>
+          <p:cNvSpPr txBox="1"/>
+          <p:nvPr/>
+        </p:nvSpPr>
+        <p:spPr>
+          <a:xfrm>
+            <a:off x="6217904" y="1414268"/>
+            <a:ext cx="2682233" cy="243839"/>
+          </a:xfrm>
+          <a:prstGeom prst="rect">
+            <a:avLst/>
+          </a:prstGeom>
+          <a:noFill/>
+        </p:spPr>
+        <p:txBody>
+          <a:bodyPr wrap="square" lIns="0" rIns="0" tIns="0" bIns="0" anchor="t">
+            <a:spAutoFit/>
+          </a:bodyPr>
+          <a:lstStyle/>
+          <a:p>
+            <a:pPr algn="l"/>
+            <a:r>
+              <a:rPr sz="1000" b="1" spc="160">
+                <a:solidFill>
+                  <a:schemeClr val="tx1"/>
+                </a:solidFill>
+              </a:rPr>
+              <a:t>CASUAL</a:t>
+            </a:r>
+          </a:p>
+        </p:txBody>
+      </p:sp>
+      <p:sp>
+        <p:nvSpPr>
+          <p:cNvPr id="7" name="Dial 1 right"/>
+          <p:cNvSpPr txBox="1"/>
+          <p:nvPr/>
+        </p:nvSpPr>
+        <p:spPr>
+          <a:xfrm>
+            <a:off x="9003769" y="1414268"/>
+            <a:ext cx="2682233" cy="243839"/>
+          </a:xfrm>
+          <a:prstGeom prst="rect">
+            <a:avLst/>
+          </a:prstGeom>
+          <a:noFill/>
+        </p:spPr>
+        <p:txBody>
+          <a:bodyPr wrap="square" lIns="0" rIns="0" tIns="0" bIns="0" anchor="t">
+            <a:spAutoFit/>
+          </a:bodyPr>
+          <a:lstStyle/>
+          <a:p>
+            <a:pPr algn="r"/>
+            <a:r>
+              <a:rPr sz="1000" b="1" spc="160">
+                <a:solidFill>
+                  <a:schemeClr val="tx1"/>
+                </a:solidFill>
+              </a:rPr>
+              <a:t>FORMAL</a:t>
+            </a:r>
+          </a:p>
+        </p:txBody>
+      </p:sp>
+      <p:cxnSp>
+        <p:nvCxnSpPr>
+          <p:cNvPr id="8" name="Dial 1 line"/>
+          <p:cNvCxnSpPr/>
+          <p:nvPr/>
+        </p:nvCxnSpPr>
+        <p:spPr>
+          <a:xfrm>
+            <a:off x="6217904" y="1804411"/>
             <a:ext cx="5468098" cy="0"/>
           </a:xfrm>
           <a:prstGeom prst="line">
@@ -5296,20 +4706,671 @@
             </a:solidFill>
           </a:ln>
         </p:spPr>
+      </p:cxnSp>
+      <p:sp>
+        <p:nvSpPr>
+          <p:cNvPr id="9" name="Dial 1 dot"/>
+          <p:cNvSpPr/>
+          <p:nvPr/>
+        </p:nvSpPr>
+        <p:spPr>
+          <a:xfrm>
+            <a:off x="9307105" y="1722115"/>
+            <a:ext cx="164591" cy="164591"/>
+          </a:xfrm>
+          <a:prstGeom prst="ellipse">
+            <a:avLst/>
+          </a:prstGeom>
+          <a:solidFill>
+            <a:schemeClr val="accent3"/>
+          </a:solidFill>
+          <a:ln>
+            <a:noFill/>
+          </a:ln>
+          <a:effectLst/>
+        </p:spPr>
         <p:style>
-          <a:lnRef idx="2">
+          <a:lnRef idx="1">
             <a:schemeClr val="accent1"/>
           </a:lnRef>
-          <a:fillRef idx="0">
+          <a:fillRef idx="3">
             <a:schemeClr val="accent1"/>
           </a:fillRef>
-          <a:effectRef idx="1">
+          <a:effectRef idx="2">
             <a:schemeClr val="accent1"/>
           </a:effectRef>
           <a:fontRef idx="minor">
-            <a:schemeClr val="tx1"/>
+            <a:schemeClr val="lt1"/>
           </a:fontRef>
         </p:style>
+        <p:txBody>
+          <a:bodyPr rtlCol="0" anchor="ctr"/>
+          <a:lstStyle/>
+          <a:p>
+            <a:pPr algn="ctr"/>
+          </a:p>
+        </p:txBody>
+      </p:sp>
+      <p:sp>
+        <p:nvSpPr>
+          <p:cNvPr id="10" name="Dial 2 left"/>
+          <p:cNvSpPr txBox="1"/>
+          <p:nvPr/>
+        </p:nvSpPr>
+        <p:spPr>
+          <a:xfrm>
+            <a:off x="6217904" y="2182362"/>
+            <a:ext cx="2682233" cy="243839"/>
+          </a:xfrm>
+          <a:prstGeom prst="rect">
+            <a:avLst/>
+          </a:prstGeom>
+          <a:noFill/>
+        </p:spPr>
+        <p:txBody>
+          <a:bodyPr wrap="square" lIns="0" rIns="0" tIns="0" bIns="0" anchor="t">
+            <a:spAutoFit/>
+          </a:bodyPr>
+          <a:lstStyle/>
+          <a:p>
+            <a:pPr algn="l"/>
+            <a:r>
+              <a:rPr sz="1000" b="1" spc="160">
+                <a:solidFill>
+                  <a:schemeClr val="tx1"/>
+                </a:solidFill>
+              </a:rPr>
+              <a:t>FUN</a:t>
+            </a:r>
+          </a:p>
+        </p:txBody>
+      </p:sp>
+      <p:sp>
+        <p:nvSpPr>
+          <p:cNvPr id="11" name="Dial 2 right"/>
+          <p:cNvSpPr txBox="1"/>
+          <p:nvPr/>
+        </p:nvSpPr>
+        <p:spPr>
+          <a:xfrm>
+            <a:off x="9003769" y="2182362"/>
+            <a:ext cx="2682233" cy="243839"/>
+          </a:xfrm>
+          <a:prstGeom prst="rect">
+            <a:avLst/>
+          </a:prstGeom>
+          <a:noFill/>
+        </p:spPr>
+        <p:txBody>
+          <a:bodyPr wrap="square" lIns="0" rIns="0" tIns="0" bIns="0" anchor="t">
+            <a:spAutoFit/>
+          </a:bodyPr>
+          <a:lstStyle/>
+          <a:p>
+            <a:pPr algn="r"/>
+            <a:r>
+              <a:rPr sz="1000" b="1" spc="160">
+                <a:solidFill>
+                  <a:schemeClr val="tx1"/>
+                </a:solidFill>
+              </a:rPr>
+              <a:t>SERIOUS</a:t>
+            </a:r>
+          </a:p>
+        </p:txBody>
+      </p:sp>
+      <p:cxnSp>
+        <p:nvCxnSpPr>
+          <p:cNvPr id="12" name="Dial 2 line"/>
+          <p:cNvCxnSpPr/>
+          <p:nvPr/>
+        </p:nvCxnSpPr>
+        <p:spPr>
+          <a:xfrm>
+            <a:off x="6217904" y="2572505"/>
+            <a:ext cx="5468098" cy="0"/>
+          </a:xfrm>
+          <a:prstGeom prst="line">
+            <a:avLst/>
+          </a:prstGeom>
+          <a:ln w="9525">
+            <a:solidFill>
+              <a:schemeClr val="tx1"/>
+            </a:solidFill>
+          </a:ln>
+        </p:spPr>
+      </p:cxnSp>
+      <p:sp>
+        <p:nvSpPr>
+          <p:cNvPr id="13" name="Dial 2 dot"/>
+          <p:cNvSpPr/>
+          <p:nvPr/>
+        </p:nvSpPr>
+        <p:spPr>
+          <a:xfrm>
+            <a:off x="9416467" y="2490209"/>
+            <a:ext cx="164591" cy="164591"/>
+          </a:xfrm>
+          <a:prstGeom prst="ellipse">
+            <a:avLst/>
+          </a:prstGeom>
+          <a:solidFill>
+            <a:schemeClr val="accent4"/>
+          </a:solidFill>
+          <a:ln>
+            <a:noFill/>
+          </a:ln>
+          <a:effectLst/>
+        </p:spPr>
+        <p:style>
+          <a:lnRef idx="1">
+            <a:schemeClr val="accent1"/>
+          </a:lnRef>
+          <a:fillRef idx="3">
+            <a:schemeClr val="accent1"/>
+          </a:fillRef>
+          <a:effectRef idx="2">
+            <a:schemeClr val="accent1"/>
+          </a:effectRef>
+          <a:fontRef idx="minor">
+            <a:schemeClr val="lt1"/>
+          </a:fontRef>
+        </p:style>
+        <p:txBody>
+          <a:bodyPr rtlCol="0" anchor="ctr"/>
+          <a:lstStyle/>
+          <a:p>
+            <a:pPr algn="ctr"/>
+          </a:p>
+        </p:txBody>
+      </p:sp>
+      <p:sp>
+        <p:nvSpPr>
+          <p:cNvPr id="14" name="Dial 3 left"/>
+          <p:cNvSpPr txBox="1"/>
+          <p:nvPr/>
+        </p:nvSpPr>
+        <p:spPr>
+          <a:xfrm>
+            <a:off x="6217904" y="2950456"/>
+            <a:ext cx="2682233" cy="243839"/>
+          </a:xfrm>
+          <a:prstGeom prst="rect">
+            <a:avLst/>
+          </a:prstGeom>
+          <a:noFill/>
+        </p:spPr>
+        <p:txBody>
+          <a:bodyPr wrap="square" lIns="0" rIns="0" tIns="0" bIns="0" anchor="t">
+            <a:spAutoFit/>
+          </a:bodyPr>
+          <a:lstStyle/>
+          <a:p>
+            <a:pPr algn="l"/>
+            <a:r>
+              <a:rPr sz="1000" b="1" spc="160">
+                <a:solidFill>
+                  <a:schemeClr val="tx1"/>
+                </a:solidFill>
+              </a:rPr>
+              <a:t>REALISTIC</a:t>
+            </a:r>
+          </a:p>
+        </p:txBody>
+      </p:sp>
+      <p:sp>
+        <p:nvSpPr>
+          <p:cNvPr id="15" name="Dial 3 right"/>
+          <p:cNvSpPr txBox="1"/>
+          <p:nvPr/>
+        </p:nvSpPr>
+        <p:spPr>
+          <a:xfrm>
+            <a:off x="9003769" y="2950456"/>
+            <a:ext cx="2682233" cy="243839"/>
+          </a:xfrm>
+          <a:prstGeom prst="rect">
+            <a:avLst/>
+          </a:prstGeom>
+          <a:noFill/>
+        </p:spPr>
+        <p:txBody>
+          <a:bodyPr wrap="square" lIns="0" rIns="0" tIns="0" bIns="0" anchor="t">
+            <a:spAutoFit/>
+          </a:bodyPr>
+          <a:lstStyle/>
+          <a:p>
+            <a:pPr algn="r"/>
+            <a:r>
+              <a:rPr sz="1000" b="1" spc="160">
+                <a:solidFill>
+                  <a:schemeClr val="tx1"/>
+                </a:solidFill>
+              </a:rPr>
+              <a:t>IDEALISTIC</a:t>
+            </a:r>
+          </a:p>
+        </p:txBody>
+      </p:sp>
+      <p:cxnSp>
+        <p:nvCxnSpPr>
+          <p:cNvPr id="16" name="Dial 3 line"/>
+          <p:cNvCxnSpPr/>
+          <p:nvPr/>
+        </p:nvCxnSpPr>
+        <p:spPr>
+          <a:xfrm>
+            <a:off x="6217904" y="3340599"/>
+            <a:ext cx="5468098" cy="0"/>
+          </a:xfrm>
+          <a:prstGeom prst="line">
+            <a:avLst/>
+          </a:prstGeom>
+          <a:ln w="9525">
+            <a:solidFill>
+              <a:schemeClr val="tx1"/>
+            </a:solidFill>
+          </a:ln>
+        </p:spPr>
+      </p:cxnSp>
+      <p:sp>
+        <p:nvSpPr>
+          <p:cNvPr id="17" name="Dial 3 dot"/>
+          <p:cNvSpPr/>
+          <p:nvPr/>
+        </p:nvSpPr>
+        <p:spPr>
+          <a:xfrm>
+            <a:off x="10072639" y="3258303"/>
+            <a:ext cx="164591" cy="164591"/>
+          </a:xfrm>
+          <a:prstGeom prst="ellipse">
+            <a:avLst/>
+          </a:prstGeom>
+          <a:solidFill>
+            <a:schemeClr val="accent1"/>
+          </a:solidFill>
+          <a:ln>
+            <a:noFill/>
+          </a:ln>
+          <a:effectLst/>
+        </p:spPr>
+        <p:style>
+          <a:lnRef idx="1">
+            <a:schemeClr val="accent1"/>
+          </a:lnRef>
+          <a:fillRef idx="3">
+            <a:schemeClr val="accent1"/>
+          </a:fillRef>
+          <a:effectRef idx="2">
+            <a:schemeClr val="accent1"/>
+          </a:effectRef>
+          <a:fontRef idx="minor">
+            <a:schemeClr val="lt1"/>
+          </a:fontRef>
+        </p:style>
+        <p:txBody>
+          <a:bodyPr rtlCol="0" anchor="ctr"/>
+          <a:lstStyle/>
+          <a:p>
+            <a:pPr algn="ctr"/>
+          </a:p>
+        </p:txBody>
+      </p:sp>
+      <p:sp>
+        <p:nvSpPr>
+          <p:cNvPr id="18" name="Dial 4 left"/>
+          <p:cNvSpPr txBox="1"/>
+          <p:nvPr/>
+        </p:nvSpPr>
+        <p:spPr>
+          <a:xfrm>
+            <a:off x="6217904" y="3718550"/>
+            <a:ext cx="2682233" cy="243839"/>
+          </a:xfrm>
+          <a:prstGeom prst="rect">
+            <a:avLst/>
+          </a:prstGeom>
+          <a:noFill/>
+        </p:spPr>
+        <p:txBody>
+          <a:bodyPr wrap="square" lIns="0" rIns="0" tIns="0" bIns="0" anchor="t">
+            <a:spAutoFit/>
+          </a:bodyPr>
+          <a:lstStyle/>
+          <a:p>
+            <a:pPr algn="l"/>
+            <a:r>
+              <a:rPr sz="1000" b="1" spc="160">
+                <a:solidFill>
+                  <a:schemeClr val="tx1"/>
+                </a:solidFill>
+              </a:rPr>
+              <a:t>APPROACHABLE</a:t>
+            </a:r>
+          </a:p>
+        </p:txBody>
+      </p:sp>
+      <p:sp>
+        <p:nvSpPr>
+          <p:cNvPr id="19" name="Dial 4 right"/>
+          <p:cNvSpPr txBox="1"/>
+          <p:nvPr/>
+        </p:nvSpPr>
+        <p:spPr>
+          <a:xfrm>
+            <a:off x="9003769" y="3718550"/>
+            <a:ext cx="2682233" cy="243839"/>
+          </a:xfrm>
+          <a:prstGeom prst="rect">
+            <a:avLst/>
+          </a:prstGeom>
+          <a:noFill/>
+        </p:spPr>
+        <p:txBody>
+          <a:bodyPr wrap="square" lIns="0" rIns="0" tIns="0" bIns="0" anchor="t">
+            <a:spAutoFit/>
+          </a:bodyPr>
+          <a:lstStyle/>
+          <a:p>
+            <a:pPr algn="r"/>
+            <a:r>
+              <a:rPr sz="1000" b="1" spc="160">
+                <a:solidFill>
+                  <a:schemeClr val="tx1"/>
+                </a:solidFill>
+              </a:rPr>
+              <a:t>EXCLUSIVE</a:t>
+            </a:r>
+          </a:p>
+        </p:txBody>
+      </p:sp>
+      <p:cxnSp>
+        <p:nvCxnSpPr>
+          <p:cNvPr id="20" name="Dial 4 line"/>
+          <p:cNvCxnSpPr/>
+          <p:nvPr/>
+        </p:nvCxnSpPr>
+        <p:spPr>
+          <a:xfrm>
+            <a:off x="6217904" y="4108693"/>
+            <a:ext cx="5468098" cy="0"/>
+          </a:xfrm>
+          <a:prstGeom prst="line">
+            <a:avLst/>
+          </a:prstGeom>
+          <a:ln w="9525">
+            <a:solidFill>
+              <a:schemeClr val="tx1"/>
+            </a:solidFill>
+          </a:ln>
+        </p:spPr>
+      </p:cxnSp>
+      <p:sp>
+        <p:nvSpPr>
+          <p:cNvPr id="21" name="Dial 4 dot"/>
+          <p:cNvSpPr/>
+          <p:nvPr/>
+        </p:nvSpPr>
+        <p:spPr>
+          <a:xfrm>
+            <a:off x="9361786" y="4026397"/>
+            <a:ext cx="164591" cy="164591"/>
+          </a:xfrm>
+          <a:prstGeom prst="ellipse">
+            <a:avLst/>
+          </a:prstGeom>
+          <a:solidFill>
+            <a:schemeClr val="accent2"/>
+          </a:solidFill>
+          <a:ln>
+            <a:noFill/>
+          </a:ln>
+          <a:effectLst/>
+        </p:spPr>
+        <p:style>
+          <a:lnRef idx="1">
+            <a:schemeClr val="accent1"/>
+          </a:lnRef>
+          <a:fillRef idx="3">
+            <a:schemeClr val="accent1"/>
+          </a:fillRef>
+          <a:effectRef idx="2">
+            <a:schemeClr val="accent1"/>
+          </a:effectRef>
+          <a:fontRef idx="minor">
+            <a:schemeClr val="lt1"/>
+          </a:fontRef>
+        </p:style>
+        <p:txBody>
+          <a:bodyPr rtlCol="0" anchor="ctr"/>
+          <a:lstStyle/>
+          <a:p>
+            <a:pPr algn="ctr"/>
+          </a:p>
+        </p:txBody>
+      </p:sp>
+      <p:sp>
+        <p:nvSpPr>
+          <p:cNvPr id="22" name="Dial 5 left"/>
+          <p:cNvSpPr txBox="1"/>
+          <p:nvPr/>
+        </p:nvSpPr>
+        <p:spPr>
+          <a:xfrm>
+            <a:off x="6217904" y="4486644"/>
+            <a:ext cx="2682233" cy="243839"/>
+          </a:xfrm>
+          <a:prstGeom prst="rect">
+            <a:avLst/>
+          </a:prstGeom>
+          <a:noFill/>
+        </p:spPr>
+        <p:txBody>
+          <a:bodyPr wrap="square" lIns="0" rIns="0" tIns="0" bIns="0" anchor="t">
+            <a:spAutoFit/>
+          </a:bodyPr>
+          <a:lstStyle/>
+          <a:p>
+            <a:pPr algn="l"/>
+            <a:r>
+              <a:rPr sz="1000" b="1" spc="160">
+                <a:solidFill>
+                  <a:schemeClr val="tx1"/>
+                </a:solidFill>
+              </a:rPr>
+              <a:t>TRADITIONAL</a:t>
+            </a:r>
+          </a:p>
+        </p:txBody>
+      </p:sp>
+      <p:sp>
+        <p:nvSpPr>
+          <p:cNvPr id="23" name="Dial 5 right"/>
+          <p:cNvSpPr txBox="1"/>
+          <p:nvPr/>
+        </p:nvSpPr>
+        <p:spPr>
+          <a:xfrm>
+            <a:off x="9003769" y="4486644"/>
+            <a:ext cx="2682233" cy="243839"/>
+          </a:xfrm>
+          <a:prstGeom prst="rect">
+            <a:avLst/>
+          </a:prstGeom>
+          <a:noFill/>
+        </p:spPr>
+        <p:txBody>
+          <a:bodyPr wrap="square" lIns="0" rIns="0" tIns="0" bIns="0" anchor="t">
+            <a:spAutoFit/>
+          </a:bodyPr>
+          <a:lstStyle/>
+          <a:p>
+            <a:pPr algn="r"/>
+            <a:r>
+              <a:rPr sz="1000" b="1" spc="160">
+                <a:solidFill>
+                  <a:schemeClr val="tx1"/>
+                </a:solidFill>
+              </a:rPr>
+              <a:t>NONTRADITIONAL</a:t>
+            </a:r>
+          </a:p>
+        </p:txBody>
+      </p:sp>
+      <p:cxnSp>
+        <p:nvCxnSpPr>
+          <p:cNvPr id="24" name="Dial 5 line"/>
+          <p:cNvCxnSpPr/>
+          <p:nvPr/>
+        </p:nvCxnSpPr>
+        <p:spPr>
+          <a:xfrm>
+            <a:off x="6217904" y="4876787"/>
+            <a:ext cx="5468098" cy="0"/>
+          </a:xfrm>
+          <a:prstGeom prst="line">
+            <a:avLst/>
+          </a:prstGeom>
+          <a:ln w="9525">
+            <a:solidFill>
+              <a:schemeClr val="tx1"/>
+            </a:solidFill>
+          </a:ln>
+        </p:spPr>
+      </p:cxnSp>
+      <p:sp>
+        <p:nvSpPr>
+          <p:cNvPr id="25" name="Dial 5 dot"/>
+          <p:cNvSpPr/>
+          <p:nvPr/>
+        </p:nvSpPr>
+        <p:spPr>
+          <a:xfrm>
+            <a:off x="9908596" y="4794492"/>
+            <a:ext cx="164591" cy="164591"/>
+          </a:xfrm>
+          <a:prstGeom prst="ellipse">
+            <a:avLst/>
+          </a:prstGeom>
+          <a:solidFill>
+            <a:schemeClr val="accent3"/>
+          </a:solidFill>
+          <a:ln>
+            <a:noFill/>
+          </a:ln>
+          <a:effectLst/>
+        </p:spPr>
+        <p:style>
+          <a:lnRef idx="1">
+            <a:schemeClr val="accent1"/>
+          </a:lnRef>
+          <a:fillRef idx="3">
+            <a:schemeClr val="accent1"/>
+          </a:fillRef>
+          <a:effectRef idx="2">
+            <a:schemeClr val="accent1"/>
+          </a:effectRef>
+          <a:fontRef idx="minor">
+            <a:schemeClr val="lt1"/>
+          </a:fontRef>
+        </p:style>
+        <p:txBody>
+          <a:bodyPr rtlCol="0" anchor="ctr"/>
+          <a:lstStyle/>
+          <a:p>
+            <a:pPr algn="ctr"/>
+          </a:p>
+        </p:txBody>
+      </p:sp>
+      <p:sp>
+        <p:nvSpPr>
+          <p:cNvPr id="26" name="Dial 6 left"/>
+          <p:cNvSpPr txBox="1"/>
+          <p:nvPr/>
+        </p:nvSpPr>
+        <p:spPr>
+          <a:xfrm>
+            <a:off x="6217904" y="5254738"/>
+            <a:ext cx="2682233" cy="243839"/>
+          </a:xfrm>
+          <a:prstGeom prst="rect">
+            <a:avLst/>
+          </a:prstGeom>
+          <a:noFill/>
+        </p:spPr>
+        <p:txBody>
+          <a:bodyPr wrap="square" lIns="0" rIns="0" tIns="0" bIns="0" anchor="t">
+            <a:spAutoFit/>
+          </a:bodyPr>
+          <a:lstStyle/>
+          <a:p>
+            <a:pPr algn="l"/>
+            <a:r>
+              <a:rPr sz="1000" b="1" spc="160">
+                <a:solidFill>
+                  <a:schemeClr val="tx1"/>
+                </a:solidFill>
+              </a:rPr>
+              <a:t>FRIENDLY</a:t>
+            </a:r>
+          </a:p>
+        </p:txBody>
+      </p:sp>
+      <p:sp>
+        <p:nvSpPr>
+          <p:cNvPr id="27" name="Dial 6 right"/>
+          <p:cNvSpPr txBox="1"/>
+          <p:nvPr/>
+        </p:nvSpPr>
+        <p:spPr>
+          <a:xfrm>
+            <a:off x="9003769" y="5254738"/>
+            <a:ext cx="2682233" cy="243839"/>
+          </a:xfrm>
+          <a:prstGeom prst="rect">
+            <a:avLst/>
+          </a:prstGeom>
+          <a:noFill/>
+        </p:spPr>
+        <p:txBody>
+          <a:bodyPr wrap="square" lIns="0" rIns="0" tIns="0" bIns="0" anchor="t">
+            <a:spAutoFit/>
+          </a:bodyPr>
+          <a:lstStyle/>
+          <a:p>
+            <a:pPr algn="r"/>
+            <a:r>
+              <a:rPr sz="1000" b="1" spc="160">
+                <a:solidFill>
+                  <a:schemeClr val="tx1"/>
+                </a:solidFill>
+              </a:rPr>
+              <a:t>PROFESSIONAL</a:t>
+            </a:r>
+          </a:p>
+        </p:txBody>
+      </p:sp>
+      <p:cxnSp>
+        <p:nvCxnSpPr>
+          <p:cNvPr id="28" name="Dial 6 line"/>
+          <p:cNvCxnSpPr/>
+          <p:nvPr/>
+        </p:nvCxnSpPr>
+        <p:spPr>
+          <a:xfrm>
+            <a:off x="6217904" y="5644881"/>
+            <a:ext cx="5468098" cy="0"/>
+          </a:xfrm>
+          <a:prstGeom prst="line">
+            <a:avLst/>
+          </a:prstGeom>
+          <a:ln w="9525">
+            <a:solidFill>
+              <a:schemeClr val="tx1"/>
+            </a:solidFill>
+          </a:ln>
+        </p:spPr>
       </p:cxnSp>
       <p:sp>
         <p:nvSpPr>
@@ -5427,20 +5488,6 @@
             </a:solidFill>
           </a:ln>
         </p:spPr>
-        <p:style>
-          <a:lnRef idx="2">
-            <a:schemeClr val="accent1"/>
-          </a:lnRef>
-          <a:fillRef idx="0">
-            <a:schemeClr val="accent1"/>
-          </a:fillRef>
-          <a:effectRef idx="1">
-            <a:schemeClr val="accent1"/>
-          </a:effectRef>
-          <a:fontRef idx="minor">
-            <a:schemeClr val="tx1"/>
-          </a:fontRef>
-        </p:style>
       </p:cxnSp>
       <p:sp>
         <p:nvSpPr>
@@ -5569,20 +5616,6 @@
             </a:solidFill>
           </a:ln>
         </p:spPr>
-        <p:style>
-          <a:lnRef idx="2">
-            <a:schemeClr val="accent1"/>
-          </a:lnRef>
-          <a:fillRef idx="0">
-            <a:schemeClr val="accent1"/>
-          </a:fillRef>
-          <a:effectRef idx="1">
-            <a:schemeClr val="accent1"/>
-          </a:effectRef>
-          <a:fontRef idx="minor">
-            <a:schemeClr val="tx1"/>
-          </a:fontRef>
-        </p:style>
       </p:cxnSp>
       <p:sp>
         <p:nvSpPr>
@@ -5706,20 +5739,6 @@
             </a:solidFill>
           </a:ln>
         </p:spPr>
-        <p:style>
-          <a:lnRef idx="2">
-            <a:schemeClr val="accent1"/>
-          </a:lnRef>
-          <a:fillRef idx="0">
-            <a:schemeClr val="accent1"/>
-          </a:fillRef>
-          <a:effectRef idx="1">
-            <a:schemeClr val="accent1"/>
-          </a:effectRef>
-          <a:fontRef idx="minor">
-            <a:schemeClr val="tx1"/>
-          </a:fontRef>
-        </p:style>
       </p:cxnSp>
       <p:sp>
         <p:nvSpPr>
@@ -5730,7 +5749,7 @@
         <p:spPr>
           <a:xfrm>
             <a:off x="6217904" y="3901430"/>
-            <a:ext cx="1731259" cy="731518"/>
+            <a:ext cx="1828795" cy="731518"/>
           </a:xfrm>
           <a:prstGeom prst="rect">
             <a:avLst/>
@@ -5749,7 +5768,7 @@
               </a:lnSpc>
             </a:pPr>
             <a:r>
-              <a:rPr sz="1800" b="1">
+              <a:rPr sz="1600" b="1">
                 <a:solidFill>
                   <a:schemeClr val="tx1"/>
                 </a:solidFill>
@@ -5802,7 +5821,7 @@
         <p:spPr>
           <a:xfrm>
             <a:off x="8119851" y="3901430"/>
-            <a:ext cx="1731259" cy="731518"/>
+            <a:ext cx="1828795" cy="731518"/>
           </a:xfrm>
           <a:prstGeom prst="rect">
             <a:avLst/>
@@ -5821,7 +5840,7 @@
               </a:lnSpc>
             </a:pPr>
             <a:r>
-              <a:rPr sz="1800" b="1">
+              <a:rPr sz="1600" b="1">
                 <a:solidFill>
                   <a:schemeClr val="tx1"/>
                 </a:solidFill>
@@ -5874,7 +5893,7 @@
         <p:spPr>
           <a:xfrm>
             <a:off x="10021798" y="3901430"/>
-            <a:ext cx="1731259" cy="731518"/>
+            <a:ext cx="1828795" cy="731518"/>
           </a:xfrm>
           <a:prstGeom prst="rect">
             <a:avLst/>
@@ -5893,7 +5912,7 @@
               </a:lnSpc>
             </a:pPr>
             <a:r>
-              <a:rPr sz="1800" b="1">
+              <a:rPr sz="1600" b="1">
                 <a:solidFill>
                   <a:schemeClr val="tx1"/>
                 </a:solidFill>
@@ -6009,20 +6028,6 @@
             </a:solidFill>
           </a:ln>
         </p:spPr>
-        <p:style>
-          <a:lnRef idx="2">
-            <a:schemeClr val="accent1"/>
-          </a:lnRef>
-          <a:fillRef idx="0">
-            <a:schemeClr val="accent1"/>
-          </a:fillRef>
-          <a:effectRef idx="1">
-            <a:schemeClr val="accent1"/>
-          </a:effectRef>
-          <a:fontRef idx="minor">
-            <a:schemeClr val="tx1"/>
-          </a:fontRef>
-        </p:style>
       </p:cxnSp>
       <p:sp>
         <p:nvSpPr>
@@ -6167,20 +6172,6 @@
             </a:solidFill>
           </a:ln>
         </p:spPr>
-        <p:style>
-          <a:lnRef idx="2">
-            <a:schemeClr val="accent1"/>
-          </a:lnRef>
-          <a:fillRef idx="0">
-            <a:schemeClr val="accent1"/>
-          </a:fillRef>
-          <a:effectRef idx="1">
-            <a:schemeClr val="accent1"/>
-          </a:effectRef>
-          <a:fontRef idx="minor">
-            <a:schemeClr val="tx1"/>
-          </a:fontRef>
-        </p:style>
       </p:cxnSp>
       <p:sp>
         <p:nvSpPr>
@@ -6236,20 +6227,6 @@
             </a:solidFill>
           </a:ln>
         </p:spPr>
-        <p:style>
-          <a:lnRef idx="2">
-            <a:schemeClr val="accent1"/>
-          </a:lnRef>
-          <a:fillRef idx="0">
-            <a:schemeClr val="accent1"/>
-          </a:fillRef>
-          <a:effectRef idx="1">
-            <a:schemeClr val="accent1"/>
-          </a:effectRef>
-          <a:fontRef idx="minor">
-            <a:schemeClr val="tx1"/>
-          </a:fontRef>
-        </p:style>
       </p:cxnSp>
       <p:sp>
         <p:nvSpPr>
@@ -6918,20 +6895,6 @@
             </a:solidFill>
           </a:ln>
         </p:spPr>
-        <p:style>
-          <a:lnRef idx="2">
-            <a:schemeClr val="accent1"/>
-          </a:lnRef>
-          <a:fillRef idx="0">
-            <a:schemeClr val="accent1"/>
-          </a:fillRef>
-          <a:effectRef idx="1">
-            <a:schemeClr val="accent1"/>
-          </a:effectRef>
-          <a:fontRef idx="minor">
-            <a:schemeClr val="tx1"/>
-          </a:fontRef>
-        </p:style>
       </p:cxnSp>
       <p:cxnSp>
         <p:nvCxnSpPr>
@@ -6953,20 +6916,6 @@
             </a:solidFill>
           </a:ln>
         </p:spPr>
-        <p:style>
-          <a:lnRef idx="2">
-            <a:schemeClr val="accent1"/>
-          </a:lnRef>
-          <a:fillRef idx="0">
-            <a:schemeClr val="accent1"/>
-          </a:fillRef>
-          <a:effectRef idx="1">
-            <a:schemeClr val="accent1"/>
-          </a:effectRef>
-          <a:fontRef idx="minor">
-            <a:schemeClr val="tx1"/>
-          </a:fontRef>
-        </p:style>
       </p:cxnSp>
       <p:sp>
         <p:nvSpPr>
@@ -7124,20 +7073,6 @@
             </a:solidFill>
           </a:ln>
         </p:spPr>
-        <p:style>
-          <a:lnRef idx="2">
-            <a:schemeClr val="accent1"/>
-          </a:lnRef>
-          <a:fillRef idx="0">
-            <a:schemeClr val="accent1"/>
-          </a:fillRef>
-          <a:effectRef idx="1">
-            <a:schemeClr val="accent1"/>
-          </a:effectRef>
-          <a:fontRef idx="minor">
-            <a:schemeClr val="tx1"/>
-          </a:fontRef>
-        </p:style>
       </p:cxnSp>
       <p:cxnSp>
         <p:nvCxnSpPr>
@@ -7159,20 +7094,6 @@
             </a:solidFill>
           </a:ln>
         </p:spPr>
-        <p:style>
-          <a:lnRef idx="2">
-            <a:schemeClr val="accent1"/>
-          </a:lnRef>
-          <a:fillRef idx="0">
-            <a:schemeClr val="accent1"/>
-          </a:fillRef>
-          <a:effectRef idx="1">
-            <a:schemeClr val="accent1"/>
-          </a:effectRef>
-          <a:fontRef idx="minor">
-            <a:schemeClr val="tx1"/>
-          </a:fontRef>
-        </p:style>
       </p:cxnSp>
       <p:sp>
         <p:nvSpPr>
@@ -7283,20 +7204,6 @@
             </a:solidFill>
           </a:ln>
         </p:spPr>
-        <p:style>
-          <a:lnRef idx="2">
-            <a:schemeClr val="accent1"/>
-          </a:lnRef>
-          <a:fillRef idx="0">
-            <a:schemeClr val="accent1"/>
-          </a:fillRef>
-          <a:effectRef idx="1">
-            <a:schemeClr val="accent1"/>
-          </a:effectRef>
-          <a:fontRef idx="minor">
-            <a:schemeClr val="tx1"/>
-          </a:fontRef>
-        </p:style>
       </p:cxnSp>
       <p:sp>
         <p:nvSpPr>
@@ -8045,20 +7952,6 @@
             </a:solidFill>
           </a:ln>
         </p:spPr>
-        <p:style>
-          <a:lnRef idx="2">
-            <a:schemeClr val="accent1"/>
-          </a:lnRef>
-          <a:fillRef idx="0">
-            <a:schemeClr val="accent1"/>
-          </a:fillRef>
-          <a:effectRef idx="1">
-            <a:schemeClr val="accent1"/>
-          </a:effectRef>
-          <a:fontRef idx="minor">
-            <a:schemeClr val="tx1"/>
-          </a:fontRef>
-        </p:style>
       </p:cxnSp>
       <p:sp>
         <p:nvSpPr>
@@ -8809,20 +8702,6 @@
             </a:solidFill>
           </a:ln>
         </p:spPr>
-        <p:style>
-          <a:lnRef idx="2">
-            <a:schemeClr val="accent1"/>
-          </a:lnRef>
-          <a:fillRef idx="0">
-            <a:schemeClr val="accent1"/>
-          </a:fillRef>
-          <a:effectRef idx="1">
-            <a:schemeClr val="accent1"/>
-          </a:effectRef>
-          <a:fontRef idx="minor">
-            <a:schemeClr val="tx1"/>
-          </a:fontRef>
-        </p:style>
       </p:cxnSp>
       <p:sp>
         <p:nvSpPr>
@@ -8949,20 +8828,6 @@
             </a:solidFill>
           </a:ln>
         </p:spPr>
-        <p:style>
-          <a:lnRef idx="2">
-            <a:schemeClr val="accent1"/>
-          </a:lnRef>
-          <a:fillRef idx="0">
-            <a:schemeClr val="accent1"/>
-          </a:fillRef>
-          <a:effectRef idx="1">
-            <a:schemeClr val="accent1"/>
-          </a:effectRef>
-          <a:fontRef idx="minor">
-            <a:schemeClr val="tx1"/>
-          </a:fontRef>
-        </p:style>
       </p:cxnSp>
       <p:sp>
         <p:nvSpPr>
@@ -9096,20 +8961,6 @@
             </a:solidFill>
           </a:ln>
         </p:spPr>
-        <p:style>
-          <a:lnRef idx="2">
-            <a:schemeClr val="accent1"/>
-          </a:lnRef>
-          <a:fillRef idx="0">
-            <a:schemeClr val="accent1"/>
-          </a:fillRef>
-          <a:effectRef idx="1">
-            <a:schemeClr val="accent1"/>
-          </a:effectRef>
-          <a:fontRef idx="minor">
-            <a:schemeClr val="tx1"/>
-          </a:fontRef>
-        </p:style>
       </p:cxnSp>
       <p:sp>
         <p:nvSpPr>
@@ -9243,20 +9094,6 @@
             </a:solidFill>
           </a:ln>
         </p:spPr>
-        <p:style>
-          <a:lnRef idx="2">
-            <a:schemeClr val="accent1"/>
-          </a:lnRef>
-          <a:fillRef idx="0">
-            <a:schemeClr val="accent1"/>
-          </a:fillRef>
-          <a:effectRef idx="1">
-            <a:schemeClr val="accent1"/>
-          </a:effectRef>
-          <a:fontRef idx="minor">
-            <a:schemeClr val="tx1"/>
-          </a:fontRef>
-        </p:style>
       </p:cxnSp>
       <p:sp>
         <p:nvSpPr>
@@ -9390,20 +9227,6 @@
             </a:solidFill>
           </a:ln>
         </p:spPr>
-        <p:style>
-          <a:lnRef idx="2">
-            <a:schemeClr val="accent1"/>
-          </a:lnRef>
-          <a:fillRef idx="0">
-            <a:schemeClr val="accent1"/>
-          </a:fillRef>
-          <a:effectRef idx="1">
-            <a:schemeClr val="accent1"/>
-          </a:effectRef>
-          <a:fontRef idx="minor">
-            <a:schemeClr val="tx1"/>
-          </a:fontRef>
-        </p:style>
       </p:cxnSp>
       <p:sp>
         <p:nvSpPr>
@@ -9589,20 +9412,6 @@
             </a:solidFill>
           </a:ln>
         </p:spPr>
-        <p:style>
-          <a:lnRef idx="2">
-            <a:schemeClr val="accent1"/>
-          </a:lnRef>
-          <a:fillRef idx="0">
-            <a:schemeClr val="accent1"/>
-          </a:fillRef>
-          <a:effectRef idx="1">
-            <a:schemeClr val="accent1"/>
-          </a:effectRef>
-          <a:fontRef idx="minor">
-            <a:schemeClr val="tx1"/>
-          </a:fontRef>
-        </p:style>
       </p:cxnSp>
       <p:sp>
         <p:nvSpPr>
@@ -9697,20 +9506,6 @@
             </a:solidFill>
           </a:ln>
         </p:spPr>
-        <p:style>
-          <a:lnRef idx="2">
-            <a:schemeClr val="accent1"/>
-          </a:lnRef>
-          <a:fillRef idx="0">
-            <a:schemeClr val="accent1"/>
-          </a:fillRef>
-          <a:effectRef idx="1">
-            <a:schemeClr val="accent1"/>
-          </a:effectRef>
-          <a:fontRef idx="minor">
-            <a:schemeClr val="tx1"/>
-          </a:fontRef>
-        </p:style>
       </p:cxnSp>
       <p:sp>
         <p:nvSpPr>
@@ -9801,20 +9596,6 @@
             </a:solidFill>
           </a:ln>
         </p:spPr>
-        <p:style>
-          <a:lnRef idx="2">
-            <a:schemeClr val="accent1"/>
-          </a:lnRef>
-          <a:fillRef idx="0">
-            <a:schemeClr val="accent1"/>
-          </a:fillRef>
-          <a:effectRef idx="1">
-            <a:schemeClr val="accent1"/>
-          </a:effectRef>
-          <a:fontRef idx="minor">
-            <a:schemeClr val="tx1"/>
-          </a:fontRef>
-        </p:style>
       </p:cxnSp>
       <p:sp>
         <p:nvSpPr>
@@ -9870,20 +9651,6 @@
             </a:solidFill>
           </a:ln>
         </p:spPr>
-        <p:style>
-          <a:lnRef idx="2">
-            <a:schemeClr val="accent1"/>
-          </a:lnRef>
-          <a:fillRef idx="0">
-            <a:schemeClr val="accent1"/>
-          </a:fillRef>
-          <a:effectRef idx="1">
-            <a:schemeClr val="accent1"/>
-          </a:effectRef>
-          <a:fontRef idx="minor">
-            <a:schemeClr val="tx1"/>
-          </a:fontRef>
-        </p:style>
       </p:cxnSp>
       <p:sp>
         <p:nvSpPr>
@@ -9939,20 +9706,6 @@
             </a:solidFill>
           </a:ln>
         </p:spPr>
-        <p:style>
-          <a:lnRef idx="2">
-            <a:schemeClr val="accent1"/>
-          </a:lnRef>
-          <a:fillRef idx="0">
-            <a:schemeClr val="accent1"/>
-          </a:fillRef>
-          <a:effectRef idx="1">
-            <a:schemeClr val="accent1"/>
-          </a:effectRef>
-          <a:fontRef idx="minor">
-            <a:schemeClr val="tx1"/>
-          </a:fontRef>
-        </p:style>
       </p:cxnSp>
       <p:sp>
         <p:nvSpPr>
@@ -10008,20 +9761,6 @@
             </a:solidFill>
           </a:ln>
         </p:spPr>
-        <p:style>
-          <a:lnRef idx="2">
-            <a:schemeClr val="accent1"/>
-          </a:lnRef>
-          <a:fillRef idx="0">
-            <a:schemeClr val="accent1"/>
-          </a:fillRef>
-          <a:effectRef idx="1">
-            <a:schemeClr val="accent1"/>
-          </a:effectRef>
-          <a:fontRef idx="minor">
-            <a:schemeClr val="tx1"/>
-          </a:fontRef>
-        </p:style>
       </p:cxnSp>
       <p:sp>
         <p:nvSpPr>
@@ -10112,20 +9851,6 @@
             </a:solidFill>
           </a:ln>
         </p:spPr>
-        <p:style>
-          <a:lnRef idx="2">
-            <a:schemeClr val="accent1"/>
-          </a:lnRef>
-          <a:fillRef idx="0">
-            <a:schemeClr val="accent1"/>
-          </a:fillRef>
-          <a:effectRef idx="1">
-            <a:schemeClr val="accent1"/>
-          </a:effectRef>
-          <a:fontRef idx="minor">
-            <a:schemeClr val="tx1"/>
-          </a:fontRef>
-        </p:style>
       </p:cxnSp>
       <p:sp>
         <p:nvSpPr>
@@ -10181,20 +9906,6 @@
             </a:solidFill>
           </a:ln>
         </p:spPr>
-        <p:style>
-          <a:lnRef idx="2">
-            <a:schemeClr val="accent1"/>
-          </a:lnRef>
-          <a:fillRef idx="0">
-            <a:schemeClr val="accent1"/>
-          </a:fillRef>
-          <a:effectRef idx="1">
-            <a:schemeClr val="accent1"/>
-          </a:effectRef>
-          <a:fontRef idx="minor">
-            <a:schemeClr val="tx1"/>
-          </a:fontRef>
-        </p:style>
       </p:cxnSp>
       <p:sp>
         <p:nvSpPr>
@@ -10250,20 +9961,6 @@
             </a:solidFill>
           </a:ln>
         </p:spPr>
-        <p:style>
-          <a:lnRef idx="2">
-            <a:schemeClr val="accent1"/>
-          </a:lnRef>
-          <a:fillRef idx="0">
-            <a:schemeClr val="accent1"/>
-          </a:fillRef>
-          <a:effectRef idx="1">
-            <a:schemeClr val="accent1"/>
-          </a:effectRef>
-          <a:fontRef idx="minor">
-            <a:schemeClr val="tx1"/>
-          </a:fontRef>
-        </p:style>
       </p:cxnSp>
       <p:sp>
         <p:nvSpPr>
@@ -10319,20 +10016,6 @@
             </a:solidFill>
           </a:ln>
         </p:spPr>
-        <p:style>
-          <a:lnRef idx="2">
-            <a:schemeClr val="accent1"/>
-          </a:lnRef>
-          <a:fillRef idx="0">
-            <a:schemeClr val="accent1"/>
-          </a:fillRef>
-          <a:effectRef idx="1">
-            <a:schemeClr val="accent1"/>
-          </a:effectRef>
-          <a:fontRef idx="minor">
-            <a:schemeClr val="tx1"/>
-          </a:fontRef>
-        </p:style>
       </p:cxnSp>
       <p:sp>
         <p:nvSpPr>
@@ -10423,20 +10106,6 @@
             </a:solidFill>
           </a:ln>
         </p:spPr>
-        <p:style>
-          <a:lnRef idx="2">
-            <a:schemeClr val="accent1"/>
-          </a:lnRef>
-          <a:fillRef idx="0">
-            <a:schemeClr val="accent1"/>
-          </a:fillRef>
-          <a:effectRef idx="1">
-            <a:schemeClr val="accent1"/>
-          </a:effectRef>
-          <a:fontRef idx="minor">
-            <a:schemeClr val="tx1"/>
-          </a:fontRef>
-        </p:style>
       </p:cxnSp>
       <p:sp>
         <p:nvSpPr>
@@ -10492,20 +10161,6 @@
             </a:solidFill>
           </a:ln>
         </p:spPr>
-        <p:style>
-          <a:lnRef idx="2">
-            <a:schemeClr val="accent1"/>
-          </a:lnRef>
-          <a:fillRef idx="0">
-            <a:schemeClr val="accent1"/>
-          </a:fillRef>
-          <a:effectRef idx="1">
-            <a:schemeClr val="accent1"/>
-          </a:effectRef>
-          <a:fontRef idx="minor">
-            <a:schemeClr val="tx1"/>
-          </a:fontRef>
-        </p:style>
       </p:cxnSp>
       <p:sp>
         <p:nvSpPr>
@@ -10561,20 +10216,6 @@
             </a:solidFill>
           </a:ln>
         </p:spPr>
-        <p:style>
-          <a:lnRef idx="2">
-            <a:schemeClr val="accent1"/>
-          </a:lnRef>
-          <a:fillRef idx="0">
-            <a:schemeClr val="accent1"/>
-          </a:fillRef>
-          <a:effectRef idx="1">
-            <a:schemeClr val="accent1"/>
-          </a:effectRef>
-          <a:fontRef idx="minor">
-            <a:schemeClr val="tx1"/>
-          </a:fontRef>
-        </p:style>
       </p:cxnSp>
       <p:sp>
         <p:nvSpPr>
@@ -11826,20 +11467,6 @@
             </a:solidFill>
           </a:ln>
         </p:spPr>
-        <p:style>
-          <a:lnRef idx="2">
-            <a:schemeClr val="accent1"/>
-          </a:lnRef>
-          <a:fillRef idx="0">
-            <a:schemeClr val="accent1"/>
-          </a:fillRef>
-          <a:effectRef idx="1">
-            <a:schemeClr val="accent1"/>
-          </a:effectRef>
-          <a:fontRef idx="minor">
-            <a:schemeClr val="tx1"/>
-          </a:fontRef>
-        </p:style>
       </p:cxnSp>
       <p:sp>
         <p:nvSpPr>
@@ -12415,20 +12042,6 @@
             </a:solidFill>
           </a:ln>
         </p:spPr>
-        <p:style>
-          <a:lnRef idx="2">
-            <a:schemeClr val="accent1"/>
-          </a:lnRef>
-          <a:fillRef idx="0">
-            <a:schemeClr val="accent1"/>
-          </a:fillRef>
-          <a:effectRef idx="1">
-            <a:schemeClr val="accent1"/>
-          </a:effectRef>
-          <a:fontRef idx="minor">
-            <a:schemeClr val="tx1"/>
-          </a:fontRef>
-        </p:style>
       </p:cxnSp>
       <p:sp>
         <p:nvSpPr>
@@ -12625,20 +12238,6 @@
             </a:solidFill>
           </a:ln>
         </p:spPr>
-        <p:style>
-          <a:lnRef idx="2">
-            <a:schemeClr val="accent1"/>
-          </a:lnRef>
-          <a:fillRef idx="0">
-            <a:schemeClr val="accent1"/>
-          </a:fillRef>
-          <a:effectRef idx="1">
-            <a:schemeClr val="accent1"/>
-          </a:effectRef>
-          <a:fontRef idx="minor">
-            <a:schemeClr val="tx1"/>
-          </a:fontRef>
-        </p:style>
       </p:cxnSp>
       <p:sp>
         <p:nvSpPr>
@@ -13057,20 +12656,6 @@
             </a:solidFill>
           </a:ln>
         </p:spPr>
-        <p:style>
-          <a:lnRef idx="2">
-            <a:schemeClr val="accent1"/>
-          </a:lnRef>
-          <a:fillRef idx="0">
-            <a:schemeClr val="accent1"/>
-          </a:fillRef>
-          <a:effectRef idx="1">
-            <a:schemeClr val="accent1"/>
-          </a:effectRef>
-          <a:fontRef idx="minor">
-            <a:schemeClr val="tx1"/>
-          </a:fontRef>
-        </p:style>
       </p:cxnSp>
       <p:sp>
         <p:nvSpPr>
@@ -13251,20 +12836,6 @@
             </a:solidFill>
           </a:ln>
         </p:spPr>
-        <p:style>
-          <a:lnRef idx="2">
-            <a:schemeClr val="accent1"/>
-          </a:lnRef>
-          <a:fillRef idx="0">
-            <a:schemeClr val="accent1"/>
-          </a:fillRef>
-          <a:effectRef idx="1">
-            <a:schemeClr val="accent1"/>
-          </a:effectRef>
-          <a:fontRef idx="minor">
-            <a:schemeClr val="tx1"/>
-          </a:fontRef>
-        </p:style>
       </p:cxnSp>
       <p:sp>
         <p:nvSpPr>
@@ -13529,20 +13100,6 @@
             </a:solidFill>
           </a:ln>
         </p:spPr>
-        <p:style>
-          <a:lnRef idx="2">
-            <a:schemeClr val="accent1"/>
-          </a:lnRef>
-          <a:fillRef idx="0">
-            <a:schemeClr val="accent1"/>
-          </a:fillRef>
-          <a:effectRef idx="1">
-            <a:schemeClr val="accent1"/>
-          </a:effectRef>
-          <a:fontRef idx="minor">
-            <a:schemeClr val="tx1"/>
-          </a:fontRef>
-        </p:style>
       </p:cxnSp>
       <p:sp>
         <p:nvSpPr>
@@ -13653,20 +13210,6 @@
             </a:solidFill>
           </a:ln>
         </p:spPr>
-        <p:style>
-          <a:lnRef idx="2">
-            <a:schemeClr val="accent1"/>
-          </a:lnRef>
-          <a:fillRef idx="0">
-            <a:schemeClr val="accent1"/>
-          </a:fillRef>
-          <a:effectRef idx="1">
-            <a:schemeClr val="accent1"/>
-          </a:effectRef>
-          <a:fontRef idx="minor">
-            <a:schemeClr val="tx1"/>
-          </a:fontRef>
-        </p:style>
       </p:cxnSp>
       <p:sp>
         <p:nvSpPr>
@@ -13794,20 +13337,6 @@
             </a:solidFill>
           </a:ln>
         </p:spPr>
-        <p:style>
-          <a:lnRef idx="2">
-            <a:schemeClr val="accent1"/>
-          </a:lnRef>
-          <a:fillRef idx="0">
-            <a:schemeClr val="accent1"/>
-          </a:fillRef>
-          <a:effectRef idx="1">
-            <a:schemeClr val="accent1"/>
-          </a:effectRef>
-          <a:fontRef idx="minor">
-            <a:schemeClr val="tx1"/>
-          </a:fontRef>
-        </p:style>
       </p:cxnSp>
       <p:sp>
         <p:nvSpPr>
@@ -13935,20 +13464,6 @@
             </a:solidFill>
           </a:ln>
         </p:spPr>
-        <p:style>
-          <a:lnRef idx="2">
-            <a:schemeClr val="accent1"/>
-          </a:lnRef>
-          <a:fillRef idx="0">
-            <a:schemeClr val="accent1"/>
-          </a:fillRef>
-          <a:effectRef idx="1">
-            <a:schemeClr val="accent1"/>
-          </a:effectRef>
-          <a:fontRef idx="minor">
-            <a:schemeClr val="tx1"/>
-          </a:fontRef>
-        </p:style>
       </p:cxnSp>
       <p:sp>
         <p:nvSpPr>
@@ -14128,20 +13643,6 @@
             </a:solidFill>
           </a:ln>
         </p:spPr>
-        <p:style>
-          <a:lnRef idx="2">
-            <a:schemeClr val="accent1"/>
-          </a:lnRef>
-          <a:fillRef idx="0">
-            <a:schemeClr val="accent1"/>
-          </a:fillRef>
-          <a:effectRef idx="1">
-            <a:schemeClr val="accent1"/>
-          </a:effectRef>
-          <a:fontRef idx="minor">
-            <a:schemeClr val="tx1"/>
-          </a:fontRef>
-        </p:style>
       </p:cxnSp>
       <p:sp>
         <p:nvSpPr>
@@ -14270,20 +13771,6 @@
             </a:solidFill>
           </a:ln>
         </p:spPr>
-        <p:style>
-          <a:lnRef idx="2">
-            <a:schemeClr val="accent1"/>
-          </a:lnRef>
-          <a:fillRef idx="0">
-            <a:schemeClr val="accent1"/>
-          </a:fillRef>
-          <a:effectRef idx="1">
-            <a:schemeClr val="accent1"/>
-          </a:effectRef>
-          <a:fontRef idx="minor">
-            <a:schemeClr val="tx1"/>
-          </a:fontRef>
-        </p:style>
       </p:cxnSp>
       <p:sp>
         <p:nvSpPr>
@@ -14339,20 +13826,6 @@
             </a:solidFill>
           </a:ln>
         </p:spPr>
-        <p:style>
-          <a:lnRef idx="2">
-            <a:schemeClr val="accent1"/>
-          </a:lnRef>
-          <a:fillRef idx="0">
-            <a:schemeClr val="accent1"/>
-          </a:fillRef>
-          <a:effectRef idx="1">
-            <a:schemeClr val="accent1"/>
-          </a:effectRef>
-          <a:fontRef idx="minor">
-            <a:schemeClr val="tx1"/>
-          </a:fontRef>
-        </p:style>
       </p:cxnSp>
       <p:sp>
         <p:nvSpPr>
@@ -14408,20 +13881,6 @@
             </a:solidFill>
           </a:ln>
         </p:spPr>
-        <p:style>
-          <a:lnRef idx="2">
-            <a:schemeClr val="accent1"/>
-          </a:lnRef>
-          <a:fillRef idx="0">
-            <a:schemeClr val="accent1"/>
-          </a:fillRef>
-          <a:effectRef idx="1">
-            <a:schemeClr val="accent1"/>
-          </a:effectRef>
-          <a:fontRef idx="minor">
-            <a:schemeClr val="tx1"/>
-          </a:fontRef>
-        </p:style>
       </p:cxnSp>
       <p:sp>
         <p:nvSpPr>

</xml_diff>

<commit_message>
Logo on every slide: HTML toggle (L / no-logo class), PPTX logo layouts with no-logo twins
Co-Authored-By: Claude Sonnet 5.5 <noreply@anthropic.com>
</commit_message>
<xml_diff>
--- a/templates/Shift-Projects-Template.pptx
+++ b/templates/Shift-Projects-Template.pptx
@@ -1900,6 +1900,199 @@
       </p:sp>
       <p:sp>
         <p:nvSpPr>
+          <p:cNvPr id="4" name="Shift icon"/>
+          <p:cNvSpPr/>
+          <p:nvPr/>
+        </p:nvSpPr>
+        <p:spPr>
+          <a:xfrm>
+            <a:off x="11271475" y="475486"/>
+            <a:ext cx="414526" cy="345883"/>
+          </a:xfrm>
+          <a:custGeom>
+            <a:avLst/>
+            <a:gdLst/>
+            <a:ahLst/>
+            <a:cxnLst/>
+            <a:rect l="0" t="0" r="r" b="b"/>
+            <a:pathLst>
+              <a:path w="31100" h="25950">
+                <a:moveTo>
+                  <a:pt x="23195" y="5625"/>
+                </a:moveTo>
+                <a:lnTo>
+                  <a:pt x="18380" y="5613"/>
+                </a:lnTo>
+                <a:cubicBezTo>
+                  <a:pt x="17807" y="5612"/>
+                  <a:pt x="17285" y="5945"/>
+                  <a:pt x="17045" y="6466"/>
+                </a:cubicBezTo>
+                <a:lnTo>
+                  <a:pt x="15815" y="9133"/>
+                </a:lnTo>
+                <a:cubicBezTo>
+                  <a:pt x="15453" y="9916"/>
+                  <a:pt x="14668" y="10418"/>
+                  <a:pt x="13805" y="10416"/>
+                </a:cubicBezTo>
+                <a:lnTo>
+                  <a:pt x="7799" y="10400"/>
+                </a:lnTo>
+                <a:cubicBezTo>
+                  <a:pt x="6310" y="10397"/>
+                  <a:pt x="5108" y="9154"/>
+                  <a:pt x="5168" y="7652"/>
+                </a:cubicBezTo>
+                <a:cubicBezTo>
+                  <a:pt x="5226" y="6223"/>
+                  <a:pt x="6448" y="5117"/>
+                  <a:pt x="7878" y="5120"/>
+                </a:cubicBezTo>
+                <a:lnTo>
+                  <a:pt x="17523" y="5145"/>
+                </a:lnTo>
+                <a:cubicBezTo>
+                  <a:pt x="17780" y="5145"/>
+                  <a:pt x="18015" y="4996"/>
+                  <a:pt x="18122" y="4762"/>
+                </a:cubicBezTo>
+                <a:lnTo>
+                  <a:pt x="20314" y="9"/>
+                </a:lnTo>
+                <a:lnTo>
+                  <a:pt x="7924" y="7"/>
+                </a:lnTo>
+                <a:cubicBezTo>
+                  <a:pt x="3655" y="-4"/>
+                  <a:pt x="105" y="3396"/>
+                  <a:pt x="53" y="7664"/>
+                </a:cubicBezTo>
+                <a:cubicBezTo>
+                  <a:pt x="0" y="11975"/>
+                  <a:pt x="3486" y="15504"/>
+                  <a:pt x="7787" y="15514"/>
+                </a:cubicBezTo>
+                <a:lnTo>
+                  <a:pt x="12364" y="15525"/>
+                </a:lnTo>
+                <a:cubicBezTo>
+                  <a:pt x="12847" y="15527"/>
+                  <a:pt x="13287" y="15246"/>
+                  <a:pt x="13490" y="14807"/>
+                </a:cubicBezTo>
+                <a:lnTo>
+                  <a:pt x="14781" y="12006"/>
+                </a:lnTo>
+                <a:cubicBezTo>
+                  <a:pt x="15143" y="11222"/>
+                  <a:pt x="15928" y="10721"/>
+                  <a:pt x="16791" y="10723"/>
+                </a:cubicBezTo>
+                <a:lnTo>
+                  <a:pt x="23236" y="10739"/>
+                </a:lnTo>
+                <a:cubicBezTo>
+                  <a:pt x="24665" y="10743"/>
+                  <a:pt x="25882" y="11855"/>
+                  <a:pt x="25933" y="13284"/>
+                </a:cubicBezTo>
+                <a:cubicBezTo>
+                  <a:pt x="25986" y="14786"/>
+                  <a:pt x="24777" y="16023"/>
+                  <a:pt x="23288" y="16020"/>
+                </a:cubicBezTo>
+                <a:lnTo>
+                  <a:pt x="13392" y="15995"/>
+                </a:lnTo>
+                <a:cubicBezTo>
+                  <a:pt x="12940" y="15994"/>
+                  <a:pt x="12530" y="16256"/>
+                  <a:pt x="12341" y="16666"/>
+                </a:cubicBezTo>
+                <a:lnTo>
+                  <a:pt x="10940" y="19703"/>
+                </a:lnTo>
+                <a:cubicBezTo>
+                  <a:pt x="10621" y="20395"/>
+                  <a:pt x="9927" y="20838"/>
+                  <a:pt x="9164" y="20836"/>
+                </a:cubicBezTo>
+                <a:lnTo>
+                  <a:pt x="3836" y="20823"/>
+                </a:lnTo>
+                <a:cubicBezTo>
+                  <a:pt x="3526" y="20822"/>
+                  <a:pt x="3245" y="21002"/>
+                  <a:pt x="3115" y="21283"/>
+                </a:cubicBezTo>
+                <a:lnTo>
+                  <a:pt x="968" y="25929"/>
+                </a:lnTo>
+                <a:lnTo>
+                  <a:pt x="6622" y="25943"/>
+                </a:lnTo>
+                <a:cubicBezTo>
+                  <a:pt x="7672" y="25946"/>
+                  <a:pt x="8628" y="25336"/>
+                  <a:pt x="9069" y="24382"/>
+                </a:cubicBezTo>
+                <a:lnTo>
+                  <a:pt x="10057" y="22238"/>
+                </a:lnTo>
+                <a:cubicBezTo>
+                  <a:pt x="10376" y="21545"/>
+                  <a:pt x="11069" y="21127"/>
+                  <a:pt x="11831" y="21129"/>
+                </a:cubicBezTo>
+                <a:lnTo>
+                  <a:pt x="23275" y="21129"/>
+                </a:lnTo>
+                <a:cubicBezTo>
+                  <a:pt x="27590" y="21139"/>
+                  <a:pt x="31100" y="17611"/>
+                  <a:pt x="31047" y="13282"/>
+                </a:cubicBezTo>
+                <a:cubicBezTo>
+                  <a:pt x="30995" y="9026"/>
+                  <a:pt x="27452" y="5636"/>
+                  <a:pt x="23195" y="5625"/>
+                </a:cubicBezTo>
+              </a:path>
+            </a:pathLst>
+          </a:custGeom>
+          <a:solidFill>
+            <a:schemeClr val="tx1"/>
+          </a:solidFill>
+          <a:ln>
+            <a:noFill/>
+          </a:ln>
+          <a:effectLst/>
+        </p:spPr>
+        <p:style>
+          <a:lnRef idx="1">
+            <a:schemeClr val="accent1"/>
+          </a:lnRef>
+          <a:fillRef idx="3">
+            <a:schemeClr val="accent1"/>
+          </a:fillRef>
+          <a:effectRef idx="2">
+            <a:schemeClr val="accent1"/>
+          </a:effectRef>
+          <a:fontRef idx="minor">
+            <a:schemeClr val="lt1"/>
+          </a:fontRef>
+        </p:style>
+        <p:txBody>
+          <a:bodyPr rtlCol="0" anchor="ctr"/>
+          <a:lstStyle/>
+          <a:p>
+            <a:pPr algn="ctr"/>
+          </a:p>
+        </p:txBody>
+      </p:sp>
+      <p:sp>
+        <p:nvSpPr>
           <p:cNvPr id="4" name="Slide number"/>
           <p:cNvSpPr txBox="1"/>
           <p:nvPr/>
@@ -1936,6 +2129,146 @@
     <p:extLst>
       <p:ext uri="{BB962C8B-B14F-4D97-AF65-F5344CB8AC3E}">
         <p14:creationId xmlns:p14="http://schemas.microsoft.com/office/powerpoint/2010/main" val="3168075583"/>
+      </p:ext>
+    </p:extLst>
+  </p:cSld>
+  <p:clrMapOvr>
+    <a:masterClrMapping/>
+  </p:clrMapOvr>
+</p:sldLayout>
+</file>
+
+<file path=ppt/slideLayouts/slideLayout10.xml><?xml version="1.0" encoding="utf-8"?>
+<p:sldLayout xmlns:a="http://schemas.openxmlformats.org/drawingml/2006/main" xmlns:r="http://schemas.openxmlformats.org/officeDocument/2006/relationships" xmlns:p="http://schemas.openxmlformats.org/presentationml/2006/main" type="vertTx" preserve="1">
+  <p:cSld name="Shift - Washed Black (no logo)">
+    <p:bg>
+      <p:bgPr>
+        <a:solidFill>
+          <a:schemeClr val="tx1"/>
+        </a:solidFill>
+        <a:effectLst/>
+      </p:bgPr>
+    </p:bg>
+    <p:spTree>
+      <p:nvGrpSpPr>
+        <p:cNvPr id="1" name=""/>
+        <p:cNvGrpSpPr/>
+        <p:nvPr/>
+      </p:nvGrpSpPr>
+      <p:grpSpPr>
+        <a:xfrm>
+          <a:off x="0" y="0"/>
+          <a:ext cx="0" cy="0"/>
+          <a:chOff x="0" y="0"/>
+          <a:chExt cx="0" cy="0"/>
+        </a:xfrm>
+      </p:grpSpPr>
+      <p:sp>
+        <p:nvSpPr>
+          <p:cNvPr id="4" name="Footer company"/>
+          <p:cNvSpPr txBox="1"/>
+          <p:nvPr/>
+        </p:nvSpPr>
+        <p:spPr>
+          <a:xfrm>
+            <a:off x="505966" y="6291056"/>
+            <a:ext cx="2194554" cy="243839"/>
+          </a:xfrm>
+          <a:prstGeom prst="rect">
+            <a:avLst/>
+          </a:prstGeom>
+          <a:noFill/>
+        </p:spPr>
+        <p:txBody>
+          <a:bodyPr wrap="square" lIns="0" rIns="0" tIns="0" bIns="0" anchor="t">
+            <a:spAutoFit/>
+          </a:bodyPr>
+          <a:lstStyle/>
+          <a:p>
+            <a:pPr algn="l"/>
+            <a:r>
+              <a:rPr sz="1000" b="1" spc="160">
+                <a:solidFill>
+                  <a:schemeClr val="bg1"/>
+                </a:solidFill>
+              </a:rPr>
+              <a:t>SHIFT PROJECTS</a:t>
+            </a:r>
+          </a:p>
+        </p:txBody>
+      </p:sp>
+      <p:sp>
+        <p:nvSpPr>
+          <p:cNvPr id="4" name="Footer deck title"/>
+          <p:cNvSpPr txBox="1"/>
+          <p:nvPr/>
+        </p:nvSpPr>
+        <p:spPr>
+          <a:xfrm>
+            <a:off x="2810248" y="6291056"/>
+            <a:ext cx="4876787" cy="243839"/>
+          </a:xfrm>
+          <a:prstGeom prst="rect">
+            <a:avLst/>
+          </a:prstGeom>
+          <a:noFill/>
+        </p:spPr>
+        <p:txBody>
+          <a:bodyPr wrap="square" lIns="0" rIns="0" tIns="0" bIns="0" anchor="t">
+            <a:spAutoFit/>
+          </a:bodyPr>
+          <a:lstStyle/>
+          <a:p>
+            <a:pPr algn="l"/>
+            <a:r>
+              <a:rPr sz="1000" b="1" spc="160">
+                <a:solidFill>
+                  <a:schemeClr val="bg1"/>
+                </a:solidFill>
+              </a:rPr>
+              <a:t>DECK TITLE</a:t>
+            </a:r>
+          </a:p>
+        </p:txBody>
+      </p:sp>
+      <p:sp>
+        <p:nvSpPr>
+          <p:cNvPr id="4" name="Slide number"/>
+          <p:cNvSpPr txBox="1"/>
+          <p:nvPr/>
+        </p:nvSpPr>
+        <p:spPr>
+          <a:xfrm>
+            <a:off x="9753575" y="6291056"/>
+            <a:ext cx="1932427" cy="243839"/>
+          </a:xfrm>
+          <a:prstGeom prst="rect">
+            <a:avLst/>
+          </a:prstGeom>
+          <a:noFill/>
+        </p:spPr>
+        <p:txBody>
+          <a:bodyPr wrap="square" lIns="0" rIns="0" tIns="0" bIns="0" anchor="t">
+            <a:spAutoFit/>
+          </a:bodyPr>
+          <a:lstStyle/>
+          <a:p>
+            <a:pPr algn="r"/>
+            <a:fld id="{B6F15528-21DE-4FAA-801E-634DDDAF4B2B}" type="slidenum">
+              <a:rPr lang="en-US" sz="1000" b="1" spc="160">
+                <a:solidFill>
+                  <a:schemeClr val="bg1"/>
+                </a:solidFill>
+              </a:rPr>
+              <a:t>‹#›</a:t>
+            </a:fld>
+          </a:p>
+        </p:txBody>
+      </p:sp>
+    </p:spTree>
+    <p:extLst>
+      <p:ext uri="{BB962C8B-B14F-4D97-AF65-F5344CB8AC3E}">
+        <p14:creationId xmlns:p14="http://schemas.microsoft.com/office/powerpoint/2010/main" val="2910927964"/>
       </p:ext>
     </p:extLst>
   </p:cSld>
@@ -2035,6 +2368,199 @@
               </a:rPr>
               <a:t>DECK TITLE</a:t>
             </a:r>
+          </a:p>
+        </p:txBody>
+      </p:sp>
+      <p:sp>
+        <p:nvSpPr>
+          <p:cNvPr id="4" name="Shift icon"/>
+          <p:cNvSpPr/>
+          <p:nvPr/>
+        </p:nvSpPr>
+        <p:spPr>
+          <a:xfrm>
+            <a:off x="11271475" y="475486"/>
+            <a:ext cx="414526" cy="345883"/>
+          </a:xfrm>
+          <a:custGeom>
+            <a:avLst/>
+            <a:gdLst/>
+            <a:ahLst/>
+            <a:cxnLst/>
+            <a:rect l="0" t="0" r="r" b="b"/>
+            <a:pathLst>
+              <a:path w="31100" h="25950">
+                <a:moveTo>
+                  <a:pt x="23195" y="5625"/>
+                </a:moveTo>
+                <a:lnTo>
+                  <a:pt x="18380" y="5613"/>
+                </a:lnTo>
+                <a:cubicBezTo>
+                  <a:pt x="17807" y="5612"/>
+                  <a:pt x="17285" y="5945"/>
+                  <a:pt x="17045" y="6466"/>
+                </a:cubicBezTo>
+                <a:lnTo>
+                  <a:pt x="15815" y="9133"/>
+                </a:lnTo>
+                <a:cubicBezTo>
+                  <a:pt x="15453" y="9916"/>
+                  <a:pt x="14668" y="10418"/>
+                  <a:pt x="13805" y="10416"/>
+                </a:cubicBezTo>
+                <a:lnTo>
+                  <a:pt x="7799" y="10400"/>
+                </a:lnTo>
+                <a:cubicBezTo>
+                  <a:pt x="6310" y="10397"/>
+                  <a:pt x="5108" y="9154"/>
+                  <a:pt x="5168" y="7652"/>
+                </a:cubicBezTo>
+                <a:cubicBezTo>
+                  <a:pt x="5226" y="6223"/>
+                  <a:pt x="6448" y="5117"/>
+                  <a:pt x="7878" y="5120"/>
+                </a:cubicBezTo>
+                <a:lnTo>
+                  <a:pt x="17523" y="5145"/>
+                </a:lnTo>
+                <a:cubicBezTo>
+                  <a:pt x="17780" y="5145"/>
+                  <a:pt x="18015" y="4996"/>
+                  <a:pt x="18122" y="4762"/>
+                </a:cubicBezTo>
+                <a:lnTo>
+                  <a:pt x="20314" y="9"/>
+                </a:lnTo>
+                <a:lnTo>
+                  <a:pt x="7924" y="7"/>
+                </a:lnTo>
+                <a:cubicBezTo>
+                  <a:pt x="3655" y="-4"/>
+                  <a:pt x="105" y="3396"/>
+                  <a:pt x="53" y="7664"/>
+                </a:cubicBezTo>
+                <a:cubicBezTo>
+                  <a:pt x="0" y="11975"/>
+                  <a:pt x="3486" y="15504"/>
+                  <a:pt x="7787" y="15514"/>
+                </a:cubicBezTo>
+                <a:lnTo>
+                  <a:pt x="12364" y="15525"/>
+                </a:lnTo>
+                <a:cubicBezTo>
+                  <a:pt x="12847" y="15527"/>
+                  <a:pt x="13287" y="15246"/>
+                  <a:pt x="13490" y="14807"/>
+                </a:cubicBezTo>
+                <a:lnTo>
+                  <a:pt x="14781" y="12006"/>
+                </a:lnTo>
+                <a:cubicBezTo>
+                  <a:pt x="15143" y="11222"/>
+                  <a:pt x="15928" y="10721"/>
+                  <a:pt x="16791" y="10723"/>
+                </a:cubicBezTo>
+                <a:lnTo>
+                  <a:pt x="23236" y="10739"/>
+                </a:lnTo>
+                <a:cubicBezTo>
+                  <a:pt x="24665" y="10743"/>
+                  <a:pt x="25882" y="11855"/>
+                  <a:pt x="25933" y="13284"/>
+                </a:cubicBezTo>
+                <a:cubicBezTo>
+                  <a:pt x="25986" y="14786"/>
+                  <a:pt x="24777" y="16023"/>
+                  <a:pt x="23288" y="16020"/>
+                </a:cubicBezTo>
+                <a:lnTo>
+                  <a:pt x="13392" y="15995"/>
+                </a:lnTo>
+                <a:cubicBezTo>
+                  <a:pt x="12940" y="15994"/>
+                  <a:pt x="12530" y="16256"/>
+                  <a:pt x="12341" y="16666"/>
+                </a:cubicBezTo>
+                <a:lnTo>
+                  <a:pt x="10940" y="19703"/>
+                </a:lnTo>
+                <a:cubicBezTo>
+                  <a:pt x="10621" y="20395"/>
+                  <a:pt x="9927" y="20838"/>
+                  <a:pt x="9164" y="20836"/>
+                </a:cubicBezTo>
+                <a:lnTo>
+                  <a:pt x="3836" y="20823"/>
+                </a:lnTo>
+                <a:cubicBezTo>
+                  <a:pt x="3526" y="20822"/>
+                  <a:pt x="3245" y="21002"/>
+                  <a:pt x="3115" y="21283"/>
+                </a:cubicBezTo>
+                <a:lnTo>
+                  <a:pt x="968" y="25929"/>
+                </a:lnTo>
+                <a:lnTo>
+                  <a:pt x="6622" y="25943"/>
+                </a:lnTo>
+                <a:cubicBezTo>
+                  <a:pt x="7672" y="25946"/>
+                  <a:pt x="8628" y="25336"/>
+                  <a:pt x="9069" y="24382"/>
+                </a:cubicBezTo>
+                <a:lnTo>
+                  <a:pt x="10057" y="22238"/>
+                </a:lnTo>
+                <a:cubicBezTo>
+                  <a:pt x="10376" y="21545"/>
+                  <a:pt x="11069" y="21127"/>
+                  <a:pt x="11831" y="21129"/>
+                </a:cubicBezTo>
+                <a:lnTo>
+                  <a:pt x="23275" y="21129"/>
+                </a:lnTo>
+                <a:cubicBezTo>
+                  <a:pt x="27590" y="21139"/>
+                  <a:pt x="31100" y="17611"/>
+                  <a:pt x="31047" y="13282"/>
+                </a:cubicBezTo>
+                <a:cubicBezTo>
+                  <a:pt x="30995" y="9026"/>
+                  <a:pt x="27452" y="5636"/>
+                  <a:pt x="23195" y="5625"/>
+                </a:cubicBezTo>
+              </a:path>
+            </a:pathLst>
+          </a:custGeom>
+          <a:solidFill>
+            <a:schemeClr val="tx1"/>
+          </a:solidFill>
+          <a:ln>
+            <a:noFill/>
+          </a:ln>
+          <a:effectLst/>
+        </p:spPr>
+        <p:style>
+          <a:lnRef idx="1">
+            <a:schemeClr val="accent1"/>
+          </a:lnRef>
+          <a:fillRef idx="3">
+            <a:schemeClr val="accent1"/>
+          </a:fillRef>
+          <a:effectRef idx="2">
+            <a:schemeClr val="accent1"/>
+          </a:effectRef>
+          <a:fontRef idx="minor">
+            <a:schemeClr val="lt1"/>
+          </a:fontRef>
+        </p:style>
+        <p:txBody>
+          <a:bodyPr rtlCol="0" anchor="ctr"/>
+          <a:lstStyle/>
+          <a:p>
+            <a:pPr algn="ctr"/>
           </a:p>
         </p:txBody>
       </p:sp>
@@ -2180,6 +2706,199 @@
       </p:sp>
       <p:sp>
         <p:nvSpPr>
+          <p:cNvPr id="4" name="Shift icon"/>
+          <p:cNvSpPr/>
+          <p:nvPr/>
+        </p:nvSpPr>
+        <p:spPr>
+          <a:xfrm>
+            <a:off x="11271475" y="475486"/>
+            <a:ext cx="414526" cy="345883"/>
+          </a:xfrm>
+          <a:custGeom>
+            <a:avLst/>
+            <a:gdLst/>
+            <a:ahLst/>
+            <a:cxnLst/>
+            <a:rect l="0" t="0" r="r" b="b"/>
+            <a:pathLst>
+              <a:path w="31100" h="25950">
+                <a:moveTo>
+                  <a:pt x="23195" y="5625"/>
+                </a:moveTo>
+                <a:lnTo>
+                  <a:pt x="18380" y="5613"/>
+                </a:lnTo>
+                <a:cubicBezTo>
+                  <a:pt x="17807" y="5612"/>
+                  <a:pt x="17285" y="5945"/>
+                  <a:pt x="17045" y="6466"/>
+                </a:cubicBezTo>
+                <a:lnTo>
+                  <a:pt x="15815" y="9133"/>
+                </a:lnTo>
+                <a:cubicBezTo>
+                  <a:pt x="15453" y="9916"/>
+                  <a:pt x="14668" y="10418"/>
+                  <a:pt x="13805" y="10416"/>
+                </a:cubicBezTo>
+                <a:lnTo>
+                  <a:pt x="7799" y="10400"/>
+                </a:lnTo>
+                <a:cubicBezTo>
+                  <a:pt x="6310" y="10397"/>
+                  <a:pt x="5108" y="9154"/>
+                  <a:pt x="5168" y="7652"/>
+                </a:cubicBezTo>
+                <a:cubicBezTo>
+                  <a:pt x="5226" y="6223"/>
+                  <a:pt x="6448" y="5117"/>
+                  <a:pt x="7878" y="5120"/>
+                </a:cubicBezTo>
+                <a:lnTo>
+                  <a:pt x="17523" y="5145"/>
+                </a:lnTo>
+                <a:cubicBezTo>
+                  <a:pt x="17780" y="5145"/>
+                  <a:pt x="18015" y="4996"/>
+                  <a:pt x="18122" y="4762"/>
+                </a:cubicBezTo>
+                <a:lnTo>
+                  <a:pt x="20314" y="9"/>
+                </a:lnTo>
+                <a:lnTo>
+                  <a:pt x="7924" y="7"/>
+                </a:lnTo>
+                <a:cubicBezTo>
+                  <a:pt x="3655" y="-4"/>
+                  <a:pt x="105" y="3396"/>
+                  <a:pt x="53" y="7664"/>
+                </a:cubicBezTo>
+                <a:cubicBezTo>
+                  <a:pt x="0" y="11975"/>
+                  <a:pt x="3486" y="15504"/>
+                  <a:pt x="7787" y="15514"/>
+                </a:cubicBezTo>
+                <a:lnTo>
+                  <a:pt x="12364" y="15525"/>
+                </a:lnTo>
+                <a:cubicBezTo>
+                  <a:pt x="12847" y="15527"/>
+                  <a:pt x="13287" y="15246"/>
+                  <a:pt x="13490" y="14807"/>
+                </a:cubicBezTo>
+                <a:lnTo>
+                  <a:pt x="14781" y="12006"/>
+                </a:lnTo>
+                <a:cubicBezTo>
+                  <a:pt x="15143" y="11222"/>
+                  <a:pt x="15928" y="10721"/>
+                  <a:pt x="16791" y="10723"/>
+                </a:cubicBezTo>
+                <a:lnTo>
+                  <a:pt x="23236" y="10739"/>
+                </a:lnTo>
+                <a:cubicBezTo>
+                  <a:pt x="24665" y="10743"/>
+                  <a:pt x="25882" y="11855"/>
+                  <a:pt x="25933" y="13284"/>
+                </a:cubicBezTo>
+                <a:cubicBezTo>
+                  <a:pt x="25986" y="14786"/>
+                  <a:pt x="24777" y="16023"/>
+                  <a:pt x="23288" y="16020"/>
+                </a:cubicBezTo>
+                <a:lnTo>
+                  <a:pt x="13392" y="15995"/>
+                </a:lnTo>
+                <a:cubicBezTo>
+                  <a:pt x="12940" y="15994"/>
+                  <a:pt x="12530" y="16256"/>
+                  <a:pt x="12341" y="16666"/>
+                </a:cubicBezTo>
+                <a:lnTo>
+                  <a:pt x="10940" y="19703"/>
+                </a:lnTo>
+                <a:cubicBezTo>
+                  <a:pt x="10621" y="20395"/>
+                  <a:pt x="9927" y="20838"/>
+                  <a:pt x="9164" y="20836"/>
+                </a:cubicBezTo>
+                <a:lnTo>
+                  <a:pt x="3836" y="20823"/>
+                </a:lnTo>
+                <a:cubicBezTo>
+                  <a:pt x="3526" y="20822"/>
+                  <a:pt x="3245" y="21002"/>
+                  <a:pt x="3115" y="21283"/>
+                </a:cubicBezTo>
+                <a:lnTo>
+                  <a:pt x="968" y="25929"/>
+                </a:lnTo>
+                <a:lnTo>
+                  <a:pt x="6622" y="25943"/>
+                </a:lnTo>
+                <a:cubicBezTo>
+                  <a:pt x="7672" y="25946"/>
+                  <a:pt x="8628" y="25336"/>
+                  <a:pt x="9069" y="24382"/>
+                </a:cubicBezTo>
+                <a:lnTo>
+                  <a:pt x="10057" y="22238"/>
+                </a:lnTo>
+                <a:cubicBezTo>
+                  <a:pt x="10376" y="21545"/>
+                  <a:pt x="11069" y="21127"/>
+                  <a:pt x="11831" y="21129"/>
+                </a:cubicBezTo>
+                <a:lnTo>
+                  <a:pt x="23275" y="21129"/>
+                </a:lnTo>
+                <a:cubicBezTo>
+                  <a:pt x="27590" y="21139"/>
+                  <a:pt x="31100" y="17611"/>
+                  <a:pt x="31047" y="13282"/>
+                </a:cubicBezTo>
+                <a:cubicBezTo>
+                  <a:pt x="30995" y="9026"/>
+                  <a:pt x="27452" y="5636"/>
+                  <a:pt x="23195" y="5625"/>
+                </a:cubicBezTo>
+              </a:path>
+            </a:pathLst>
+          </a:custGeom>
+          <a:solidFill>
+            <a:schemeClr val="tx1"/>
+          </a:solidFill>
+          <a:ln>
+            <a:noFill/>
+          </a:ln>
+          <a:effectLst/>
+        </p:spPr>
+        <p:style>
+          <a:lnRef idx="1">
+            <a:schemeClr val="accent1"/>
+          </a:lnRef>
+          <a:fillRef idx="3">
+            <a:schemeClr val="accent1"/>
+          </a:fillRef>
+          <a:effectRef idx="2">
+            <a:schemeClr val="accent1"/>
+          </a:effectRef>
+          <a:fontRef idx="minor">
+            <a:schemeClr val="lt1"/>
+          </a:fontRef>
+        </p:style>
+        <p:txBody>
+          <a:bodyPr rtlCol="0" anchor="ctr"/>
+          <a:lstStyle/>
+          <a:p>
+            <a:pPr algn="ctr"/>
+          </a:p>
+        </p:txBody>
+      </p:sp>
+      <p:sp>
+        <p:nvSpPr>
           <p:cNvPr id="4" name="Slide number"/>
           <p:cNvSpPr txBox="1"/>
           <p:nvPr/>
@@ -2320,6 +3039,199 @@
       </p:sp>
       <p:sp>
         <p:nvSpPr>
+          <p:cNvPr id="4" name="Shift icon"/>
+          <p:cNvSpPr/>
+          <p:nvPr/>
+        </p:nvSpPr>
+        <p:spPr>
+          <a:xfrm>
+            <a:off x="11271475" y="475486"/>
+            <a:ext cx="414526" cy="345883"/>
+          </a:xfrm>
+          <a:custGeom>
+            <a:avLst/>
+            <a:gdLst/>
+            <a:ahLst/>
+            <a:cxnLst/>
+            <a:rect l="0" t="0" r="r" b="b"/>
+            <a:pathLst>
+              <a:path w="31100" h="25950">
+                <a:moveTo>
+                  <a:pt x="23195" y="5625"/>
+                </a:moveTo>
+                <a:lnTo>
+                  <a:pt x="18380" y="5613"/>
+                </a:lnTo>
+                <a:cubicBezTo>
+                  <a:pt x="17807" y="5612"/>
+                  <a:pt x="17285" y="5945"/>
+                  <a:pt x="17045" y="6466"/>
+                </a:cubicBezTo>
+                <a:lnTo>
+                  <a:pt x="15815" y="9133"/>
+                </a:lnTo>
+                <a:cubicBezTo>
+                  <a:pt x="15453" y="9916"/>
+                  <a:pt x="14668" y="10418"/>
+                  <a:pt x="13805" y="10416"/>
+                </a:cubicBezTo>
+                <a:lnTo>
+                  <a:pt x="7799" y="10400"/>
+                </a:lnTo>
+                <a:cubicBezTo>
+                  <a:pt x="6310" y="10397"/>
+                  <a:pt x="5108" y="9154"/>
+                  <a:pt x="5168" y="7652"/>
+                </a:cubicBezTo>
+                <a:cubicBezTo>
+                  <a:pt x="5226" y="6223"/>
+                  <a:pt x="6448" y="5117"/>
+                  <a:pt x="7878" y="5120"/>
+                </a:cubicBezTo>
+                <a:lnTo>
+                  <a:pt x="17523" y="5145"/>
+                </a:lnTo>
+                <a:cubicBezTo>
+                  <a:pt x="17780" y="5145"/>
+                  <a:pt x="18015" y="4996"/>
+                  <a:pt x="18122" y="4762"/>
+                </a:cubicBezTo>
+                <a:lnTo>
+                  <a:pt x="20314" y="9"/>
+                </a:lnTo>
+                <a:lnTo>
+                  <a:pt x="7924" y="7"/>
+                </a:lnTo>
+                <a:cubicBezTo>
+                  <a:pt x="3655" y="-4"/>
+                  <a:pt x="105" y="3396"/>
+                  <a:pt x="53" y="7664"/>
+                </a:cubicBezTo>
+                <a:cubicBezTo>
+                  <a:pt x="0" y="11975"/>
+                  <a:pt x="3486" y="15504"/>
+                  <a:pt x="7787" y="15514"/>
+                </a:cubicBezTo>
+                <a:lnTo>
+                  <a:pt x="12364" y="15525"/>
+                </a:lnTo>
+                <a:cubicBezTo>
+                  <a:pt x="12847" y="15527"/>
+                  <a:pt x="13287" y="15246"/>
+                  <a:pt x="13490" y="14807"/>
+                </a:cubicBezTo>
+                <a:lnTo>
+                  <a:pt x="14781" y="12006"/>
+                </a:lnTo>
+                <a:cubicBezTo>
+                  <a:pt x="15143" y="11222"/>
+                  <a:pt x="15928" y="10721"/>
+                  <a:pt x="16791" y="10723"/>
+                </a:cubicBezTo>
+                <a:lnTo>
+                  <a:pt x="23236" y="10739"/>
+                </a:lnTo>
+                <a:cubicBezTo>
+                  <a:pt x="24665" y="10743"/>
+                  <a:pt x="25882" y="11855"/>
+                  <a:pt x="25933" y="13284"/>
+                </a:cubicBezTo>
+                <a:cubicBezTo>
+                  <a:pt x="25986" y="14786"/>
+                  <a:pt x="24777" y="16023"/>
+                  <a:pt x="23288" y="16020"/>
+                </a:cubicBezTo>
+                <a:lnTo>
+                  <a:pt x="13392" y="15995"/>
+                </a:lnTo>
+                <a:cubicBezTo>
+                  <a:pt x="12940" y="15994"/>
+                  <a:pt x="12530" y="16256"/>
+                  <a:pt x="12341" y="16666"/>
+                </a:cubicBezTo>
+                <a:lnTo>
+                  <a:pt x="10940" y="19703"/>
+                </a:lnTo>
+                <a:cubicBezTo>
+                  <a:pt x="10621" y="20395"/>
+                  <a:pt x="9927" y="20838"/>
+                  <a:pt x="9164" y="20836"/>
+                </a:cubicBezTo>
+                <a:lnTo>
+                  <a:pt x="3836" y="20823"/>
+                </a:lnTo>
+                <a:cubicBezTo>
+                  <a:pt x="3526" y="20822"/>
+                  <a:pt x="3245" y="21002"/>
+                  <a:pt x="3115" y="21283"/>
+                </a:cubicBezTo>
+                <a:lnTo>
+                  <a:pt x="968" y="25929"/>
+                </a:lnTo>
+                <a:lnTo>
+                  <a:pt x="6622" y="25943"/>
+                </a:lnTo>
+                <a:cubicBezTo>
+                  <a:pt x="7672" y="25946"/>
+                  <a:pt x="8628" y="25336"/>
+                  <a:pt x="9069" y="24382"/>
+                </a:cubicBezTo>
+                <a:lnTo>
+                  <a:pt x="10057" y="22238"/>
+                </a:lnTo>
+                <a:cubicBezTo>
+                  <a:pt x="10376" y="21545"/>
+                  <a:pt x="11069" y="21127"/>
+                  <a:pt x="11831" y="21129"/>
+                </a:cubicBezTo>
+                <a:lnTo>
+                  <a:pt x="23275" y="21129"/>
+                </a:lnTo>
+                <a:cubicBezTo>
+                  <a:pt x="27590" y="21139"/>
+                  <a:pt x="31100" y="17611"/>
+                  <a:pt x="31047" y="13282"/>
+                </a:cubicBezTo>
+                <a:cubicBezTo>
+                  <a:pt x="30995" y="9026"/>
+                  <a:pt x="27452" y="5636"/>
+                  <a:pt x="23195" y="5625"/>
+                </a:cubicBezTo>
+              </a:path>
+            </a:pathLst>
+          </a:custGeom>
+          <a:solidFill>
+            <a:schemeClr val="tx1"/>
+          </a:solidFill>
+          <a:ln>
+            <a:noFill/>
+          </a:ln>
+          <a:effectLst/>
+        </p:spPr>
+        <p:style>
+          <a:lnRef idx="1">
+            <a:schemeClr val="accent1"/>
+          </a:lnRef>
+          <a:fillRef idx="3">
+            <a:schemeClr val="accent1"/>
+          </a:fillRef>
+          <a:effectRef idx="2">
+            <a:schemeClr val="accent1"/>
+          </a:effectRef>
+          <a:fontRef idx="minor">
+            <a:schemeClr val="lt1"/>
+          </a:fontRef>
+        </p:style>
+        <p:txBody>
+          <a:bodyPr rtlCol="0" anchor="ctr"/>
+          <a:lstStyle/>
+          <a:p>
+            <a:pPr algn="ctr"/>
+          </a:p>
+        </p:txBody>
+      </p:sp>
+      <p:sp>
+        <p:nvSpPr>
           <p:cNvPr id="4" name="Slide number"/>
           <p:cNvSpPr txBox="1"/>
           <p:nvPr/>
@@ -2460,6 +3372,199 @@
       </p:sp>
       <p:sp>
         <p:nvSpPr>
+          <p:cNvPr id="4" name="Shift icon"/>
+          <p:cNvSpPr/>
+          <p:nvPr/>
+        </p:nvSpPr>
+        <p:spPr>
+          <a:xfrm>
+            <a:off x="11271475" y="475486"/>
+            <a:ext cx="414526" cy="345883"/>
+          </a:xfrm>
+          <a:custGeom>
+            <a:avLst/>
+            <a:gdLst/>
+            <a:ahLst/>
+            <a:cxnLst/>
+            <a:rect l="0" t="0" r="r" b="b"/>
+            <a:pathLst>
+              <a:path w="31100" h="25950">
+                <a:moveTo>
+                  <a:pt x="23195" y="5625"/>
+                </a:moveTo>
+                <a:lnTo>
+                  <a:pt x="18380" y="5613"/>
+                </a:lnTo>
+                <a:cubicBezTo>
+                  <a:pt x="17807" y="5612"/>
+                  <a:pt x="17285" y="5945"/>
+                  <a:pt x="17045" y="6466"/>
+                </a:cubicBezTo>
+                <a:lnTo>
+                  <a:pt x="15815" y="9133"/>
+                </a:lnTo>
+                <a:cubicBezTo>
+                  <a:pt x="15453" y="9916"/>
+                  <a:pt x="14668" y="10418"/>
+                  <a:pt x="13805" y="10416"/>
+                </a:cubicBezTo>
+                <a:lnTo>
+                  <a:pt x="7799" y="10400"/>
+                </a:lnTo>
+                <a:cubicBezTo>
+                  <a:pt x="6310" y="10397"/>
+                  <a:pt x="5108" y="9154"/>
+                  <a:pt x="5168" y="7652"/>
+                </a:cubicBezTo>
+                <a:cubicBezTo>
+                  <a:pt x="5226" y="6223"/>
+                  <a:pt x="6448" y="5117"/>
+                  <a:pt x="7878" y="5120"/>
+                </a:cubicBezTo>
+                <a:lnTo>
+                  <a:pt x="17523" y="5145"/>
+                </a:lnTo>
+                <a:cubicBezTo>
+                  <a:pt x="17780" y="5145"/>
+                  <a:pt x="18015" y="4996"/>
+                  <a:pt x="18122" y="4762"/>
+                </a:cubicBezTo>
+                <a:lnTo>
+                  <a:pt x="20314" y="9"/>
+                </a:lnTo>
+                <a:lnTo>
+                  <a:pt x="7924" y="7"/>
+                </a:lnTo>
+                <a:cubicBezTo>
+                  <a:pt x="3655" y="-4"/>
+                  <a:pt x="105" y="3396"/>
+                  <a:pt x="53" y="7664"/>
+                </a:cubicBezTo>
+                <a:cubicBezTo>
+                  <a:pt x="0" y="11975"/>
+                  <a:pt x="3486" y="15504"/>
+                  <a:pt x="7787" y="15514"/>
+                </a:cubicBezTo>
+                <a:lnTo>
+                  <a:pt x="12364" y="15525"/>
+                </a:lnTo>
+                <a:cubicBezTo>
+                  <a:pt x="12847" y="15527"/>
+                  <a:pt x="13287" y="15246"/>
+                  <a:pt x="13490" y="14807"/>
+                </a:cubicBezTo>
+                <a:lnTo>
+                  <a:pt x="14781" y="12006"/>
+                </a:lnTo>
+                <a:cubicBezTo>
+                  <a:pt x="15143" y="11222"/>
+                  <a:pt x="15928" y="10721"/>
+                  <a:pt x="16791" y="10723"/>
+                </a:cubicBezTo>
+                <a:lnTo>
+                  <a:pt x="23236" y="10739"/>
+                </a:lnTo>
+                <a:cubicBezTo>
+                  <a:pt x="24665" y="10743"/>
+                  <a:pt x="25882" y="11855"/>
+                  <a:pt x="25933" y="13284"/>
+                </a:cubicBezTo>
+                <a:cubicBezTo>
+                  <a:pt x="25986" y="14786"/>
+                  <a:pt x="24777" y="16023"/>
+                  <a:pt x="23288" y="16020"/>
+                </a:cubicBezTo>
+                <a:lnTo>
+                  <a:pt x="13392" y="15995"/>
+                </a:lnTo>
+                <a:cubicBezTo>
+                  <a:pt x="12940" y="15994"/>
+                  <a:pt x="12530" y="16256"/>
+                  <a:pt x="12341" y="16666"/>
+                </a:cubicBezTo>
+                <a:lnTo>
+                  <a:pt x="10940" y="19703"/>
+                </a:lnTo>
+                <a:cubicBezTo>
+                  <a:pt x="10621" y="20395"/>
+                  <a:pt x="9927" y="20838"/>
+                  <a:pt x="9164" y="20836"/>
+                </a:cubicBezTo>
+                <a:lnTo>
+                  <a:pt x="3836" y="20823"/>
+                </a:lnTo>
+                <a:cubicBezTo>
+                  <a:pt x="3526" y="20822"/>
+                  <a:pt x="3245" y="21002"/>
+                  <a:pt x="3115" y="21283"/>
+                </a:cubicBezTo>
+                <a:lnTo>
+                  <a:pt x="968" y="25929"/>
+                </a:lnTo>
+                <a:lnTo>
+                  <a:pt x="6622" y="25943"/>
+                </a:lnTo>
+                <a:cubicBezTo>
+                  <a:pt x="7672" y="25946"/>
+                  <a:pt x="8628" y="25336"/>
+                  <a:pt x="9069" y="24382"/>
+                </a:cubicBezTo>
+                <a:lnTo>
+                  <a:pt x="10057" y="22238"/>
+                </a:lnTo>
+                <a:cubicBezTo>
+                  <a:pt x="10376" y="21545"/>
+                  <a:pt x="11069" y="21127"/>
+                  <a:pt x="11831" y="21129"/>
+                </a:cubicBezTo>
+                <a:lnTo>
+                  <a:pt x="23275" y="21129"/>
+                </a:lnTo>
+                <a:cubicBezTo>
+                  <a:pt x="27590" y="21139"/>
+                  <a:pt x="31100" y="17611"/>
+                  <a:pt x="31047" y="13282"/>
+                </a:cubicBezTo>
+                <a:cubicBezTo>
+                  <a:pt x="30995" y="9026"/>
+                  <a:pt x="27452" y="5636"/>
+                  <a:pt x="23195" y="5625"/>
+                </a:cubicBezTo>
+              </a:path>
+            </a:pathLst>
+          </a:custGeom>
+          <a:solidFill>
+            <a:schemeClr val="bg1"/>
+          </a:solidFill>
+          <a:ln>
+            <a:noFill/>
+          </a:ln>
+          <a:effectLst/>
+        </p:spPr>
+        <p:style>
+          <a:lnRef idx="1">
+            <a:schemeClr val="accent1"/>
+          </a:lnRef>
+          <a:fillRef idx="3">
+            <a:schemeClr val="accent1"/>
+          </a:fillRef>
+          <a:effectRef idx="2">
+            <a:schemeClr val="accent1"/>
+          </a:effectRef>
+          <a:fontRef idx="minor">
+            <a:schemeClr val="lt1"/>
+          </a:fontRef>
+        </p:style>
+        <p:txBody>
+          <a:bodyPr rtlCol="0" anchor="ctr"/>
+          <a:lstStyle/>
+          <a:p>
+            <a:pPr algn="ctr"/>
+          </a:p>
+        </p:txBody>
+      </p:sp>
+      <p:sp>
+        <p:nvSpPr>
           <p:cNvPr id="4" name="Slide number"/>
           <p:cNvSpPr txBox="1"/>
           <p:nvPr/>
@@ -2496,6 +3601,566 @@
     <p:extLst>
       <p:ext uri="{BB962C8B-B14F-4D97-AF65-F5344CB8AC3E}">
         <p14:creationId xmlns:p14="http://schemas.microsoft.com/office/powerpoint/2010/main" val="990158736"/>
+      </p:ext>
+    </p:extLst>
+  </p:cSld>
+  <p:clrMapOvr>
+    <a:masterClrMapping/>
+  </p:clrMapOvr>
+</p:sldLayout>
+</file>
+
+<file path=ppt/slideLayouts/slideLayout6.xml><?xml version="1.0" encoding="utf-8"?>
+<p:sldLayout xmlns:a="http://schemas.openxmlformats.org/drawingml/2006/main" xmlns:r="http://schemas.openxmlformats.org/officeDocument/2006/relationships" xmlns:p="http://schemas.openxmlformats.org/presentationml/2006/main" type="titleOnly" preserve="1">
+  <p:cSld name="Shift - Cream (no logo)">
+    <p:bg>
+      <p:bgPr>
+        <a:solidFill>
+          <a:schemeClr val="bg1"/>
+        </a:solidFill>
+        <a:effectLst/>
+      </p:bgPr>
+    </p:bg>
+    <p:spTree>
+      <p:nvGrpSpPr>
+        <p:cNvPr id="1" name=""/>
+        <p:cNvGrpSpPr/>
+        <p:nvPr/>
+      </p:nvGrpSpPr>
+      <p:grpSpPr>
+        <a:xfrm>
+          <a:off x="0" y="0"/>
+          <a:ext cx="0" cy="0"/>
+          <a:chOff x="0" y="0"/>
+          <a:chExt cx="0" cy="0"/>
+        </a:xfrm>
+      </p:grpSpPr>
+      <p:sp>
+        <p:nvSpPr>
+          <p:cNvPr id="4" name="Footer company"/>
+          <p:cNvSpPr txBox="1"/>
+          <p:nvPr/>
+        </p:nvSpPr>
+        <p:spPr>
+          <a:xfrm>
+            <a:off x="505966" y="6291056"/>
+            <a:ext cx="2194554" cy="243839"/>
+          </a:xfrm>
+          <a:prstGeom prst="rect">
+            <a:avLst/>
+          </a:prstGeom>
+          <a:noFill/>
+        </p:spPr>
+        <p:txBody>
+          <a:bodyPr wrap="square" lIns="0" rIns="0" tIns="0" bIns="0" anchor="t">
+            <a:spAutoFit/>
+          </a:bodyPr>
+          <a:lstStyle/>
+          <a:p>
+            <a:pPr algn="l"/>
+            <a:r>
+              <a:rPr sz="1000" b="1" spc="160">
+                <a:solidFill>
+                  <a:schemeClr val="tx1"/>
+                </a:solidFill>
+              </a:rPr>
+              <a:t>SHIFT PROJECTS</a:t>
+            </a:r>
+          </a:p>
+        </p:txBody>
+      </p:sp>
+      <p:sp>
+        <p:nvSpPr>
+          <p:cNvPr id="4" name="Footer deck title"/>
+          <p:cNvSpPr txBox="1"/>
+          <p:nvPr/>
+        </p:nvSpPr>
+        <p:spPr>
+          <a:xfrm>
+            <a:off x="2810248" y="6291056"/>
+            <a:ext cx="4876787" cy="243839"/>
+          </a:xfrm>
+          <a:prstGeom prst="rect">
+            <a:avLst/>
+          </a:prstGeom>
+          <a:noFill/>
+        </p:spPr>
+        <p:txBody>
+          <a:bodyPr wrap="square" lIns="0" rIns="0" tIns="0" bIns="0" anchor="t">
+            <a:spAutoFit/>
+          </a:bodyPr>
+          <a:lstStyle/>
+          <a:p>
+            <a:pPr algn="l"/>
+            <a:r>
+              <a:rPr sz="1000" b="1" spc="160">
+                <a:solidFill>
+                  <a:schemeClr val="tx1"/>
+                </a:solidFill>
+              </a:rPr>
+              <a:t>DECK TITLE</a:t>
+            </a:r>
+          </a:p>
+        </p:txBody>
+      </p:sp>
+      <p:sp>
+        <p:nvSpPr>
+          <p:cNvPr id="4" name="Slide number"/>
+          <p:cNvSpPr txBox="1"/>
+          <p:nvPr/>
+        </p:nvSpPr>
+        <p:spPr>
+          <a:xfrm>
+            <a:off x="9753575" y="6291056"/>
+            <a:ext cx="1932427" cy="243839"/>
+          </a:xfrm>
+          <a:prstGeom prst="rect">
+            <a:avLst/>
+          </a:prstGeom>
+          <a:noFill/>
+        </p:spPr>
+        <p:txBody>
+          <a:bodyPr wrap="square" lIns="0" rIns="0" tIns="0" bIns="0" anchor="t">
+            <a:spAutoFit/>
+          </a:bodyPr>
+          <a:lstStyle/>
+          <a:p>
+            <a:pPr algn="r"/>
+            <a:fld id="{B6F15528-21DE-4FAA-801E-634DDDAF4B2B}" type="slidenum">
+              <a:rPr lang="en-US" sz="1000" b="1" spc="160">
+                <a:solidFill>
+                  <a:schemeClr val="tx1"/>
+                </a:solidFill>
+              </a:rPr>
+              <a:t>‹#›</a:t>
+            </a:fld>
+          </a:p>
+        </p:txBody>
+      </p:sp>
+    </p:spTree>
+    <p:extLst>
+      <p:ext uri="{BB962C8B-B14F-4D97-AF65-F5344CB8AC3E}">
+        <p14:creationId xmlns:p14="http://schemas.microsoft.com/office/powerpoint/2010/main" val="727027711"/>
+      </p:ext>
+    </p:extLst>
+  </p:cSld>
+  <p:clrMapOvr>
+    <a:masterClrMapping/>
+  </p:clrMapOvr>
+</p:sldLayout>
+</file>
+
+<file path=ppt/slideLayouts/slideLayout7.xml><?xml version="1.0" encoding="utf-8"?>
+<p:sldLayout xmlns:a="http://schemas.openxmlformats.org/drawingml/2006/main" xmlns:r="http://schemas.openxmlformats.org/officeDocument/2006/relationships" xmlns:p="http://schemas.openxmlformats.org/presentationml/2006/main" type="blank" preserve="1">
+  <p:cSld name="Shift - Lumber (no logo)">
+    <p:bg>
+      <p:bgPr>
+        <a:solidFill>
+          <a:schemeClr val="accent1"/>
+        </a:solidFill>
+        <a:effectLst/>
+      </p:bgPr>
+    </p:bg>
+    <p:spTree>
+      <p:nvGrpSpPr>
+        <p:cNvPr id="1" name=""/>
+        <p:cNvGrpSpPr/>
+        <p:nvPr/>
+      </p:nvGrpSpPr>
+      <p:grpSpPr>
+        <a:xfrm>
+          <a:off x="0" y="0"/>
+          <a:ext cx="0" cy="0"/>
+          <a:chOff x="0" y="0"/>
+          <a:chExt cx="0" cy="0"/>
+        </a:xfrm>
+      </p:grpSpPr>
+      <p:sp>
+        <p:nvSpPr>
+          <p:cNvPr id="4" name="Footer company"/>
+          <p:cNvSpPr txBox="1"/>
+          <p:nvPr/>
+        </p:nvSpPr>
+        <p:spPr>
+          <a:xfrm>
+            <a:off x="505966" y="6291056"/>
+            <a:ext cx="2194554" cy="243839"/>
+          </a:xfrm>
+          <a:prstGeom prst="rect">
+            <a:avLst/>
+          </a:prstGeom>
+          <a:noFill/>
+        </p:spPr>
+        <p:txBody>
+          <a:bodyPr wrap="square" lIns="0" rIns="0" tIns="0" bIns="0" anchor="t">
+            <a:spAutoFit/>
+          </a:bodyPr>
+          <a:lstStyle/>
+          <a:p>
+            <a:pPr algn="l"/>
+            <a:r>
+              <a:rPr sz="1000" b="1" spc="160">
+                <a:solidFill>
+                  <a:schemeClr val="tx1"/>
+                </a:solidFill>
+              </a:rPr>
+              <a:t>SHIFT PROJECTS</a:t>
+            </a:r>
+          </a:p>
+        </p:txBody>
+      </p:sp>
+      <p:sp>
+        <p:nvSpPr>
+          <p:cNvPr id="4" name="Footer deck title"/>
+          <p:cNvSpPr txBox="1"/>
+          <p:nvPr/>
+        </p:nvSpPr>
+        <p:spPr>
+          <a:xfrm>
+            <a:off x="2810248" y="6291056"/>
+            <a:ext cx="4876787" cy="243839"/>
+          </a:xfrm>
+          <a:prstGeom prst="rect">
+            <a:avLst/>
+          </a:prstGeom>
+          <a:noFill/>
+        </p:spPr>
+        <p:txBody>
+          <a:bodyPr wrap="square" lIns="0" rIns="0" tIns="0" bIns="0" anchor="t">
+            <a:spAutoFit/>
+          </a:bodyPr>
+          <a:lstStyle/>
+          <a:p>
+            <a:pPr algn="l"/>
+            <a:r>
+              <a:rPr sz="1000" b="1" spc="160">
+                <a:solidFill>
+                  <a:schemeClr val="tx1"/>
+                </a:solidFill>
+              </a:rPr>
+              <a:t>DECK TITLE</a:t>
+            </a:r>
+          </a:p>
+        </p:txBody>
+      </p:sp>
+      <p:sp>
+        <p:nvSpPr>
+          <p:cNvPr id="4" name="Slide number"/>
+          <p:cNvSpPr txBox="1"/>
+          <p:nvPr/>
+        </p:nvSpPr>
+        <p:spPr>
+          <a:xfrm>
+            <a:off x="9753575" y="6291056"/>
+            <a:ext cx="1932427" cy="243839"/>
+          </a:xfrm>
+          <a:prstGeom prst="rect">
+            <a:avLst/>
+          </a:prstGeom>
+          <a:noFill/>
+        </p:spPr>
+        <p:txBody>
+          <a:bodyPr wrap="square" lIns="0" rIns="0" tIns="0" bIns="0" anchor="t">
+            <a:spAutoFit/>
+          </a:bodyPr>
+          <a:lstStyle/>
+          <a:p>
+            <a:pPr algn="r"/>
+            <a:fld id="{B6F15528-21DE-4FAA-801E-634DDDAF4B2B}" type="slidenum">
+              <a:rPr lang="en-US" sz="1000" b="1" spc="160">
+                <a:solidFill>
+                  <a:schemeClr val="tx1"/>
+                </a:solidFill>
+              </a:rPr>
+              <a:t>‹#›</a:t>
+            </a:fld>
+          </a:p>
+        </p:txBody>
+      </p:sp>
+    </p:spTree>
+    <p:extLst>
+      <p:ext uri="{BB962C8B-B14F-4D97-AF65-F5344CB8AC3E}">
+        <p14:creationId xmlns:p14="http://schemas.microsoft.com/office/powerpoint/2010/main" val="1212999818"/>
+      </p:ext>
+    </p:extLst>
+  </p:cSld>
+  <p:clrMapOvr>
+    <a:masterClrMapping/>
+  </p:clrMapOvr>
+</p:sldLayout>
+</file>
+
+<file path=ppt/slideLayouts/slideLayout8.xml><?xml version="1.0" encoding="utf-8"?>
+<p:sldLayout xmlns:a="http://schemas.openxmlformats.org/drawingml/2006/main" xmlns:r="http://schemas.openxmlformats.org/officeDocument/2006/relationships" xmlns:p="http://schemas.openxmlformats.org/presentationml/2006/main" type="objTx" preserve="1">
+  <p:cSld name="Shift - Slate (no logo)">
+    <p:bg>
+      <p:bgPr>
+        <a:solidFill>
+          <a:schemeClr val="accent4"/>
+        </a:solidFill>
+        <a:effectLst/>
+      </p:bgPr>
+    </p:bg>
+    <p:spTree>
+      <p:nvGrpSpPr>
+        <p:cNvPr id="1" name=""/>
+        <p:cNvGrpSpPr/>
+        <p:nvPr/>
+      </p:nvGrpSpPr>
+      <p:grpSpPr>
+        <a:xfrm>
+          <a:off x="0" y="0"/>
+          <a:ext cx="0" cy="0"/>
+          <a:chOff x="0" y="0"/>
+          <a:chExt cx="0" cy="0"/>
+        </a:xfrm>
+      </p:grpSpPr>
+      <p:sp>
+        <p:nvSpPr>
+          <p:cNvPr id="4" name="Footer company"/>
+          <p:cNvSpPr txBox="1"/>
+          <p:nvPr/>
+        </p:nvSpPr>
+        <p:spPr>
+          <a:xfrm>
+            <a:off x="505966" y="6291056"/>
+            <a:ext cx="2194554" cy="243839"/>
+          </a:xfrm>
+          <a:prstGeom prst="rect">
+            <a:avLst/>
+          </a:prstGeom>
+          <a:noFill/>
+        </p:spPr>
+        <p:txBody>
+          <a:bodyPr wrap="square" lIns="0" rIns="0" tIns="0" bIns="0" anchor="t">
+            <a:spAutoFit/>
+          </a:bodyPr>
+          <a:lstStyle/>
+          <a:p>
+            <a:pPr algn="l"/>
+            <a:r>
+              <a:rPr sz="1000" b="1" spc="160">
+                <a:solidFill>
+                  <a:schemeClr val="tx1"/>
+                </a:solidFill>
+              </a:rPr>
+              <a:t>SHIFT PROJECTS</a:t>
+            </a:r>
+          </a:p>
+        </p:txBody>
+      </p:sp>
+      <p:sp>
+        <p:nvSpPr>
+          <p:cNvPr id="4" name="Footer deck title"/>
+          <p:cNvSpPr txBox="1"/>
+          <p:nvPr/>
+        </p:nvSpPr>
+        <p:spPr>
+          <a:xfrm>
+            <a:off x="2810248" y="6291056"/>
+            <a:ext cx="4876787" cy="243839"/>
+          </a:xfrm>
+          <a:prstGeom prst="rect">
+            <a:avLst/>
+          </a:prstGeom>
+          <a:noFill/>
+        </p:spPr>
+        <p:txBody>
+          <a:bodyPr wrap="square" lIns="0" rIns="0" tIns="0" bIns="0" anchor="t">
+            <a:spAutoFit/>
+          </a:bodyPr>
+          <a:lstStyle/>
+          <a:p>
+            <a:pPr algn="l"/>
+            <a:r>
+              <a:rPr sz="1000" b="1" spc="160">
+                <a:solidFill>
+                  <a:schemeClr val="tx1"/>
+                </a:solidFill>
+              </a:rPr>
+              <a:t>DECK TITLE</a:t>
+            </a:r>
+          </a:p>
+        </p:txBody>
+      </p:sp>
+      <p:sp>
+        <p:nvSpPr>
+          <p:cNvPr id="4" name="Slide number"/>
+          <p:cNvSpPr txBox="1"/>
+          <p:nvPr/>
+        </p:nvSpPr>
+        <p:spPr>
+          <a:xfrm>
+            <a:off x="9753575" y="6291056"/>
+            <a:ext cx="1932427" cy="243839"/>
+          </a:xfrm>
+          <a:prstGeom prst="rect">
+            <a:avLst/>
+          </a:prstGeom>
+          <a:noFill/>
+        </p:spPr>
+        <p:txBody>
+          <a:bodyPr wrap="square" lIns="0" rIns="0" tIns="0" bIns="0" anchor="t">
+            <a:spAutoFit/>
+          </a:bodyPr>
+          <a:lstStyle/>
+          <a:p>
+            <a:pPr algn="r"/>
+            <a:fld id="{B6F15528-21DE-4FAA-801E-634DDDAF4B2B}" type="slidenum">
+              <a:rPr lang="en-US" sz="1000" b="1" spc="160">
+                <a:solidFill>
+                  <a:schemeClr val="tx1"/>
+                </a:solidFill>
+              </a:rPr>
+              <a:t>‹#›</a:t>
+            </a:fld>
+          </a:p>
+        </p:txBody>
+      </p:sp>
+    </p:spTree>
+    <p:extLst>
+      <p:ext uri="{BB962C8B-B14F-4D97-AF65-F5344CB8AC3E}">
+        <p14:creationId xmlns:p14="http://schemas.microsoft.com/office/powerpoint/2010/main" val="1840726560"/>
+      </p:ext>
+    </p:extLst>
+  </p:cSld>
+  <p:clrMapOvr>
+    <a:masterClrMapping/>
+  </p:clrMapOvr>
+</p:sldLayout>
+</file>
+
+<file path=ppt/slideLayouts/slideLayout9.xml><?xml version="1.0" encoding="utf-8"?>
+<p:sldLayout xmlns:a="http://schemas.openxmlformats.org/drawingml/2006/main" xmlns:r="http://schemas.openxmlformats.org/officeDocument/2006/relationships" xmlns:p="http://schemas.openxmlformats.org/presentationml/2006/main" type="picTx" preserve="1">
+  <p:cSld name="Shift - Olive (no logo)">
+    <p:bg>
+      <p:bgPr>
+        <a:solidFill>
+          <a:schemeClr val="accent2"/>
+        </a:solidFill>
+        <a:effectLst/>
+      </p:bgPr>
+    </p:bg>
+    <p:spTree>
+      <p:nvGrpSpPr>
+        <p:cNvPr id="1" name=""/>
+        <p:cNvGrpSpPr/>
+        <p:nvPr/>
+      </p:nvGrpSpPr>
+      <p:grpSpPr>
+        <a:xfrm>
+          <a:off x="0" y="0"/>
+          <a:ext cx="0" cy="0"/>
+          <a:chOff x="0" y="0"/>
+          <a:chExt cx="0" cy="0"/>
+        </a:xfrm>
+      </p:grpSpPr>
+      <p:sp>
+        <p:nvSpPr>
+          <p:cNvPr id="4" name="Footer company"/>
+          <p:cNvSpPr txBox="1"/>
+          <p:nvPr/>
+        </p:nvSpPr>
+        <p:spPr>
+          <a:xfrm>
+            <a:off x="505966" y="6291056"/>
+            <a:ext cx="2194554" cy="243839"/>
+          </a:xfrm>
+          <a:prstGeom prst="rect">
+            <a:avLst/>
+          </a:prstGeom>
+          <a:noFill/>
+        </p:spPr>
+        <p:txBody>
+          <a:bodyPr wrap="square" lIns="0" rIns="0" tIns="0" bIns="0" anchor="t">
+            <a:spAutoFit/>
+          </a:bodyPr>
+          <a:lstStyle/>
+          <a:p>
+            <a:pPr algn="l"/>
+            <a:r>
+              <a:rPr sz="1000" b="1" spc="160">
+                <a:solidFill>
+                  <a:schemeClr val="tx1"/>
+                </a:solidFill>
+              </a:rPr>
+              <a:t>SHIFT PROJECTS</a:t>
+            </a:r>
+          </a:p>
+        </p:txBody>
+      </p:sp>
+      <p:sp>
+        <p:nvSpPr>
+          <p:cNvPr id="4" name="Footer deck title"/>
+          <p:cNvSpPr txBox="1"/>
+          <p:nvPr/>
+        </p:nvSpPr>
+        <p:spPr>
+          <a:xfrm>
+            <a:off x="2810248" y="6291056"/>
+            <a:ext cx="4876787" cy="243839"/>
+          </a:xfrm>
+          <a:prstGeom prst="rect">
+            <a:avLst/>
+          </a:prstGeom>
+          <a:noFill/>
+        </p:spPr>
+        <p:txBody>
+          <a:bodyPr wrap="square" lIns="0" rIns="0" tIns="0" bIns="0" anchor="t">
+            <a:spAutoFit/>
+          </a:bodyPr>
+          <a:lstStyle/>
+          <a:p>
+            <a:pPr algn="l"/>
+            <a:r>
+              <a:rPr sz="1000" b="1" spc="160">
+                <a:solidFill>
+                  <a:schemeClr val="tx1"/>
+                </a:solidFill>
+              </a:rPr>
+              <a:t>DECK TITLE</a:t>
+            </a:r>
+          </a:p>
+        </p:txBody>
+      </p:sp>
+      <p:sp>
+        <p:nvSpPr>
+          <p:cNvPr id="4" name="Slide number"/>
+          <p:cNvSpPr txBox="1"/>
+          <p:nvPr/>
+        </p:nvSpPr>
+        <p:spPr>
+          <a:xfrm>
+            <a:off x="9753575" y="6291056"/>
+            <a:ext cx="1932427" cy="243839"/>
+          </a:xfrm>
+          <a:prstGeom prst="rect">
+            <a:avLst/>
+          </a:prstGeom>
+          <a:noFill/>
+        </p:spPr>
+        <p:txBody>
+          <a:bodyPr wrap="square" lIns="0" rIns="0" tIns="0" bIns="0" anchor="t">
+            <a:spAutoFit/>
+          </a:bodyPr>
+          <a:lstStyle/>
+          <a:p>
+            <a:pPr algn="r"/>
+            <a:fld id="{B6F15528-21DE-4FAA-801E-634DDDAF4B2B}" type="slidenum">
+              <a:rPr lang="en-US" sz="1000" b="1" spc="160">
+                <a:solidFill>
+                  <a:schemeClr val="tx1"/>
+                </a:solidFill>
+              </a:rPr>
+              <a:t>‹#›</a:t>
+            </a:fld>
+          </a:p>
+        </p:txBody>
+      </p:sp>
+    </p:spTree>
+    <p:extLst>
+      <p:ext uri="{BB962C8B-B14F-4D97-AF65-F5344CB8AC3E}">
+        <p14:creationId xmlns:p14="http://schemas.microsoft.com/office/powerpoint/2010/main" val="3889236939"/>
       </p:ext>
     </p:extLst>
   </p:cSld>
@@ -2755,6 +4420,11 @@
     <p:sldLayoutId id="2147483651" r:id="rId3"/>
     <p:sldLayoutId id="2147483652" r:id="rId4"/>
     <p:sldLayoutId id="2147483653" r:id="rId5"/>
+    <p:sldLayoutId id="2147483654" r:id="rId6"/>
+    <p:sldLayoutId id="2147483655" r:id="rId7"/>
+    <p:sldLayoutId id="2147483656" r:id="rId8"/>
+    <p:sldLayoutId id="2147483657" r:id="rId9"/>
+    <p:sldLayoutId id="2147483658" r:id="rId10"/>
   </p:sldLayoutIdLst>
   <p:txStyles>
     <p:titleStyle>
@@ -3251,199 +4921,6 @@
           </a:p>
         </p:txBody>
       </p:sp>
-      <p:sp>
-        <p:nvSpPr>
-          <p:cNvPr id="4" name="Shift icon"/>
-          <p:cNvSpPr/>
-          <p:nvPr/>
-        </p:nvSpPr>
-        <p:spPr>
-          <a:xfrm>
-            <a:off x="11027636" y="505966"/>
-            <a:ext cx="658366" cy="549344"/>
-          </a:xfrm>
-          <a:custGeom>
-            <a:avLst/>
-            <a:gdLst/>
-            <a:ahLst/>
-            <a:cxnLst/>
-            <a:rect l="0" t="0" r="r" b="b"/>
-            <a:pathLst>
-              <a:path w="31100" h="25950">
-                <a:moveTo>
-                  <a:pt x="23195" y="5625"/>
-                </a:moveTo>
-                <a:lnTo>
-                  <a:pt x="18380" y="5613"/>
-                </a:lnTo>
-                <a:cubicBezTo>
-                  <a:pt x="17807" y="5612"/>
-                  <a:pt x="17285" y="5945"/>
-                  <a:pt x="17045" y="6466"/>
-                </a:cubicBezTo>
-                <a:lnTo>
-                  <a:pt x="15815" y="9133"/>
-                </a:lnTo>
-                <a:cubicBezTo>
-                  <a:pt x="15453" y="9916"/>
-                  <a:pt x="14668" y="10418"/>
-                  <a:pt x="13805" y="10416"/>
-                </a:cubicBezTo>
-                <a:lnTo>
-                  <a:pt x="7799" y="10400"/>
-                </a:lnTo>
-                <a:cubicBezTo>
-                  <a:pt x="6310" y="10397"/>
-                  <a:pt x="5108" y="9154"/>
-                  <a:pt x="5168" y="7652"/>
-                </a:cubicBezTo>
-                <a:cubicBezTo>
-                  <a:pt x="5226" y="6223"/>
-                  <a:pt x="6448" y="5117"/>
-                  <a:pt x="7878" y="5120"/>
-                </a:cubicBezTo>
-                <a:lnTo>
-                  <a:pt x="17523" y="5145"/>
-                </a:lnTo>
-                <a:cubicBezTo>
-                  <a:pt x="17780" y="5145"/>
-                  <a:pt x="18015" y="4996"/>
-                  <a:pt x="18122" y="4762"/>
-                </a:cubicBezTo>
-                <a:lnTo>
-                  <a:pt x="20314" y="9"/>
-                </a:lnTo>
-                <a:lnTo>
-                  <a:pt x="7924" y="7"/>
-                </a:lnTo>
-                <a:cubicBezTo>
-                  <a:pt x="3655" y="-4"/>
-                  <a:pt x="105" y="3396"/>
-                  <a:pt x="53" y="7664"/>
-                </a:cubicBezTo>
-                <a:cubicBezTo>
-                  <a:pt x="0" y="11975"/>
-                  <a:pt x="3486" y="15504"/>
-                  <a:pt x="7787" y="15514"/>
-                </a:cubicBezTo>
-                <a:lnTo>
-                  <a:pt x="12364" y="15525"/>
-                </a:lnTo>
-                <a:cubicBezTo>
-                  <a:pt x="12847" y="15527"/>
-                  <a:pt x="13287" y="15246"/>
-                  <a:pt x="13490" y="14807"/>
-                </a:cubicBezTo>
-                <a:lnTo>
-                  <a:pt x="14781" y="12006"/>
-                </a:lnTo>
-                <a:cubicBezTo>
-                  <a:pt x="15143" y="11222"/>
-                  <a:pt x="15928" y="10721"/>
-                  <a:pt x="16791" y="10723"/>
-                </a:cubicBezTo>
-                <a:lnTo>
-                  <a:pt x="23236" y="10739"/>
-                </a:lnTo>
-                <a:cubicBezTo>
-                  <a:pt x="24665" y="10743"/>
-                  <a:pt x="25882" y="11855"/>
-                  <a:pt x="25933" y="13284"/>
-                </a:cubicBezTo>
-                <a:cubicBezTo>
-                  <a:pt x="25986" y="14786"/>
-                  <a:pt x="24777" y="16023"/>
-                  <a:pt x="23288" y="16020"/>
-                </a:cubicBezTo>
-                <a:lnTo>
-                  <a:pt x="13392" y="15995"/>
-                </a:lnTo>
-                <a:cubicBezTo>
-                  <a:pt x="12940" y="15994"/>
-                  <a:pt x="12530" y="16256"/>
-                  <a:pt x="12341" y="16666"/>
-                </a:cubicBezTo>
-                <a:lnTo>
-                  <a:pt x="10940" y="19703"/>
-                </a:lnTo>
-                <a:cubicBezTo>
-                  <a:pt x="10621" y="20395"/>
-                  <a:pt x="9927" y="20838"/>
-                  <a:pt x="9164" y="20836"/>
-                </a:cubicBezTo>
-                <a:lnTo>
-                  <a:pt x="3836" y="20823"/>
-                </a:lnTo>
-                <a:cubicBezTo>
-                  <a:pt x="3526" y="20822"/>
-                  <a:pt x="3245" y="21002"/>
-                  <a:pt x="3115" y="21283"/>
-                </a:cubicBezTo>
-                <a:lnTo>
-                  <a:pt x="968" y="25929"/>
-                </a:lnTo>
-                <a:lnTo>
-                  <a:pt x="6622" y="25943"/>
-                </a:lnTo>
-                <a:cubicBezTo>
-                  <a:pt x="7672" y="25946"/>
-                  <a:pt x="8628" y="25336"/>
-                  <a:pt x="9069" y="24382"/>
-                </a:cubicBezTo>
-                <a:lnTo>
-                  <a:pt x="10057" y="22238"/>
-                </a:lnTo>
-                <a:cubicBezTo>
-                  <a:pt x="10376" y="21545"/>
-                  <a:pt x="11069" y="21127"/>
-                  <a:pt x="11831" y="21129"/>
-                </a:cubicBezTo>
-                <a:lnTo>
-                  <a:pt x="23275" y="21129"/>
-                </a:lnTo>
-                <a:cubicBezTo>
-                  <a:pt x="27590" y="21139"/>
-                  <a:pt x="31100" y="17611"/>
-                  <a:pt x="31047" y="13282"/>
-                </a:cubicBezTo>
-                <a:cubicBezTo>
-                  <a:pt x="30995" y="9026"/>
-                  <a:pt x="27452" y="5636"/>
-                  <a:pt x="23195" y="5625"/>
-                </a:cubicBezTo>
-              </a:path>
-            </a:pathLst>
-          </a:custGeom>
-          <a:solidFill>
-            <a:schemeClr val="tx1"/>
-          </a:solidFill>
-          <a:ln>
-            <a:noFill/>
-          </a:ln>
-          <a:effectLst/>
-        </p:spPr>
-        <p:style>
-          <a:lnRef idx="1">
-            <a:schemeClr val="accent1"/>
-          </a:lnRef>
-          <a:fillRef idx="3">
-            <a:schemeClr val="accent1"/>
-          </a:fillRef>
-          <a:effectRef idx="2">
-            <a:schemeClr val="accent1"/>
-          </a:effectRef>
-          <a:fontRef idx="minor">
-            <a:schemeClr val="lt1"/>
-          </a:fontRef>
-        </p:style>
-        <p:txBody>
-          <a:bodyPr rtlCol="0" anchor="ctr"/>
-          <a:lstStyle/>
-          <a:p>
-            <a:pPr algn="ctr"/>
-          </a:p>
-        </p:txBody>
-      </p:sp>
     </p:spTree>
   </p:cSld>
   <p:clrMapOvr>
@@ -4263,199 +5740,6 @@
           </a:p>
         </p:txBody>
       </p:sp>
-      <p:sp>
-        <p:nvSpPr>
-          <p:cNvPr id="8" name="Shift icon"/>
-          <p:cNvSpPr/>
-          <p:nvPr/>
-        </p:nvSpPr>
-        <p:spPr>
-          <a:xfrm>
-            <a:off x="10893524" y="5303506"/>
-            <a:ext cx="792478" cy="661247"/>
-          </a:xfrm>
-          <a:custGeom>
-            <a:avLst/>
-            <a:gdLst/>
-            <a:ahLst/>
-            <a:cxnLst/>
-            <a:rect l="0" t="0" r="r" b="b"/>
-            <a:pathLst>
-              <a:path w="31100" h="25950">
-                <a:moveTo>
-                  <a:pt x="23195" y="5625"/>
-                </a:moveTo>
-                <a:lnTo>
-                  <a:pt x="18380" y="5613"/>
-                </a:lnTo>
-                <a:cubicBezTo>
-                  <a:pt x="17807" y="5612"/>
-                  <a:pt x="17285" y="5945"/>
-                  <a:pt x="17045" y="6466"/>
-                </a:cubicBezTo>
-                <a:lnTo>
-                  <a:pt x="15815" y="9133"/>
-                </a:lnTo>
-                <a:cubicBezTo>
-                  <a:pt x="15453" y="9916"/>
-                  <a:pt x="14668" y="10418"/>
-                  <a:pt x="13805" y="10416"/>
-                </a:cubicBezTo>
-                <a:lnTo>
-                  <a:pt x="7799" y="10400"/>
-                </a:lnTo>
-                <a:cubicBezTo>
-                  <a:pt x="6310" y="10397"/>
-                  <a:pt x="5108" y="9154"/>
-                  <a:pt x="5168" y="7652"/>
-                </a:cubicBezTo>
-                <a:cubicBezTo>
-                  <a:pt x="5226" y="6223"/>
-                  <a:pt x="6448" y="5117"/>
-                  <a:pt x="7878" y="5120"/>
-                </a:cubicBezTo>
-                <a:lnTo>
-                  <a:pt x="17523" y="5145"/>
-                </a:lnTo>
-                <a:cubicBezTo>
-                  <a:pt x="17780" y="5145"/>
-                  <a:pt x="18015" y="4996"/>
-                  <a:pt x="18122" y="4762"/>
-                </a:cubicBezTo>
-                <a:lnTo>
-                  <a:pt x="20314" y="9"/>
-                </a:lnTo>
-                <a:lnTo>
-                  <a:pt x="7924" y="7"/>
-                </a:lnTo>
-                <a:cubicBezTo>
-                  <a:pt x="3655" y="-4"/>
-                  <a:pt x="105" y="3396"/>
-                  <a:pt x="53" y="7664"/>
-                </a:cubicBezTo>
-                <a:cubicBezTo>
-                  <a:pt x="0" y="11975"/>
-                  <a:pt x="3486" y="15504"/>
-                  <a:pt x="7787" y="15514"/>
-                </a:cubicBezTo>
-                <a:lnTo>
-                  <a:pt x="12364" y="15525"/>
-                </a:lnTo>
-                <a:cubicBezTo>
-                  <a:pt x="12847" y="15527"/>
-                  <a:pt x="13287" y="15246"/>
-                  <a:pt x="13490" y="14807"/>
-                </a:cubicBezTo>
-                <a:lnTo>
-                  <a:pt x="14781" y="12006"/>
-                </a:lnTo>
-                <a:cubicBezTo>
-                  <a:pt x="15143" y="11222"/>
-                  <a:pt x="15928" y="10721"/>
-                  <a:pt x="16791" y="10723"/>
-                </a:cubicBezTo>
-                <a:lnTo>
-                  <a:pt x="23236" y="10739"/>
-                </a:lnTo>
-                <a:cubicBezTo>
-                  <a:pt x="24665" y="10743"/>
-                  <a:pt x="25882" y="11855"/>
-                  <a:pt x="25933" y="13284"/>
-                </a:cubicBezTo>
-                <a:cubicBezTo>
-                  <a:pt x="25986" y="14786"/>
-                  <a:pt x="24777" y="16023"/>
-                  <a:pt x="23288" y="16020"/>
-                </a:cubicBezTo>
-                <a:lnTo>
-                  <a:pt x="13392" y="15995"/>
-                </a:lnTo>
-                <a:cubicBezTo>
-                  <a:pt x="12940" y="15994"/>
-                  <a:pt x="12530" y="16256"/>
-                  <a:pt x="12341" y="16666"/>
-                </a:cubicBezTo>
-                <a:lnTo>
-                  <a:pt x="10940" y="19703"/>
-                </a:lnTo>
-                <a:cubicBezTo>
-                  <a:pt x="10621" y="20395"/>
-                  <a:pt x="9927" y="20838"/>
-                  <a:pt x="9164" y="20836"/>
-                </a:cubicBezTo>
-                <a:lnTo>
-                  <a:pt x="3836" y="20823"/>
-                </a:lnTo>
-                <a:cubicBezTo>
-                  <a:pt x="3526" y="20822"/>
-                  <a:pt x="3245" y="21002"/>
-                  <a:pt x="3115" y="21283"/>
-                </a:cubicBezTo>
-                <a:lnTo>
-                  <a:pt x="968" y="25929"/>
-                </a:lnTo>
-                <a:lnTo>
-                  <a:pt x="6622" y="25943"/>
-                </a:lnTo>
-                <a:cubicBezTo>
-                  <a:pt x="7672" y="25946"/>
-                  <a:pt x="8628" y="25336"/>
-                  <a:pt x="9069" y="24382"/>
-                </a:cubicBezTo>
-                <a:lnTo>
-                  <a:pt x="10057" y="22238"/>
-                </a:lnTo>
-                <a:cubicBezTo>
-                  <a:pt x="10376" y="21545"/>
-                  <a:pt x="11069" y="21127"/>
-                  <a:pt x="11831" y="21129"/>
-                </a:cubicBezTo>
-                <a:lnTo>
-                  <a:pt x="23275" y="21129"/>
-                </a:lnTo>
-                <a:cubicBezTo>
-                  <a:pt x="27590" y="21139"/>
-                  <a:pt x="31100" y="17611"/>
-                  <a:pt x="31047" y="13282"/>
-                </a:cubicBezTo>
-                <a:cubicBezTo>
-                  <a:pt x="30995" y="9026"/>
-                  <a:pt x="27452" y="5636"/>
-                  <a:pt x="23195" y="5625"/>
-                </a:cubicBezTo>
-              </a:path>
-            </a:pathLst>
-          </a:custGeom>
-          <a:solidFill>
-            <a:schemeClr val="tx1"/>
-          </a:solidFill>
-          <a:ln>
-            <a:noFill/>
-          </a:ln>
-          <a:effectLst/>
-        </p:spPr>
-        <p:style>
-          <a:lnRef idx="1">
-            <a:schemeClr val="accent1"/>
-          </a:lnRef>
-          <a:fillRef idx="3">
-            <a:schemeClr val="accent1"/>
-          </a:fillRef>
-          <a:effectRef idx="2">
-            <a:schemeClr val="accent1"/>
-          </a:effectRef>
-          <a:fontRef idx="minor">
-            <a:schemeClr val="lt1"/>
-          </a:fontRef>
-        </p:style>
-        <p:txBody>
-          <a:bodyPr rtlCol="0" anchor="ctr"/>
-          <a:lstStyle/>
-          <a:p>
-            <a:pPr algn="ctr"/>
-          </a:p>
-        </p:txBody>
-      </p:sp>
     </p:spTree>
   </p:cSld>
   <p:clrMapOvr>
@@ -10374,200 +11658,7 @@
       </p:sp>
       <p:sp>
         <p:nvSpPr>
-          <p:cNvPr id="4" name="Shift icon"/>
-          <p:cNvSpPr/>
-          <p:nvPr/>
-        </p:nvSpPr>
-        <p:spPr>
-          <a:xfrm>
-            <a:off x="7010382" y="4693908"/>
-            <a:ext cx="853437" cy="712112"/>
-          </a:xfrm>
-          <a:custGeom>
-            <a:avLst/>
-            <a:gdLst/>
-            <a:ahLst/>
-            <a:cxnLst/>
-            <a:rect l="0" t="0" r="r" b="b"/>
-            <a:pathLst>
-              <a:path w="31100" h="25950">
-                <a:moveTo>
-                  <a:pt x="23195" y="5625"/>
-                </a:moveTo>
-                <a:lnTo>
-                  <a:pt x="18380" y="5613"/>
-                </a:lnTo>
-                <a:cubicBezTo>
-                  <a:pt x="17807" y="5612"/>
-                  <a:pt x="17285" y="5945"/>
-                  <a:pt x="17045" y="6466"/>
-                </a:cubicBezTo>
-                <a:lnTo>
-                  <a:pt x="15815" y="9133"/>
-                </a:lnTo>
-                <a:cubicBezTo>
-                  <a:pt x="15453" y="9916"/>
-                  <a:pt x="14668" y="10418"/>
-                  <a:pt x="13805" y="10416"/>
-                </a:cubicBezTo>
-                <a:lnTo>
-                  <a:pt x="7799" y="10400"/>
-                </a:lnTo>
-                <a:cubicBezTo>
-                  <a:pt x="6310" y="10397"/>
-                  <a:pt x="5108" y="9154"/>
-                  <a:pt x="5168" y="7652"/>
-                </a:cubicBezTo>
-                <a:cubicBezTo>
-                  <a:pt x="5226" y="6223"/>
-                  <a:pt x="6448" y="5117"/>
-                  <a:pt x="7878" y="5120"/>
-                </a:cubicBezTo>
-                <a:lnTo>
-                  <a:pt x="17523" y="5145"/>
-                </a:lnTo>
-                <a:cubicBezTo>
-                  <a:pt x="17780" y="5145"/>
-                  <a:pt x="18015" y="4996"/>
-                  <a:pt x="18122" y="4762"/>
-                </a:cubicBezTo>
-                <a:lnTo>
-                  <a:pt x="20314" y="9"/>
-                </a:lnTo>
-                <a:lnTo>
-                  <a:pt x="7924" y="7"/>
-                </a:lnTo>
-                <a:cubicBezTo>
-                  <a:pt x="3655" y="-4"/>
-                  <a:pt x="105" y="3396"/>
-                  <a:pt x="53" y="7664"/>
-                </a:cubicBezTo>
-                <a:cubicBezTo>
-                  <a:pt x="0" y="11975"/>
-                  <a:pt x="3486" y="15504"/>
-                  <a:pt x="7787" y="15514"/>
-                </a:cubicBezTo>
-                <a:lnTo>
-                  <a:pt x="12364" y="15525"/>
-                </a:lnTo>
-                <a:cubicBezTo>
-                  <a:pt x="12847" y="15527"/>
-                  <a:pt x="13287" y="15246"/>
-                  <a:pt x="13490" y="14807"/>
-                </a:cubicBezTo>
-                <a:lnTo>
-                  <a:pt x="14781" y="12006"/>
-                </a:lnTo>
-                <a:cubicBezTo>
-                  <a:pt x="15143" y="11222"/>
-                  <a:pt x="15928" y="10721"/>
-                  <a:pt x="16791" y="10723"/>
-                </a:cubicBezTo>
-                <a:lnTo>
-                  <a:pt x="23236" y="10739"/>
-                </a:lnTo>
-                <a:cubicBezTo>
-                  <a:pt x="24665" y="10743"/>
-                  <a:pt x="25882" y="11855"/>
-                  <a:pt x="25933" y="13284"/>
-                </a:cubicBezTo>
-                <a:cubicBezTo>
-                  <a:pt x="25986" y="14786"/>
-                  <a:pt x="24777" y="16023"/>
-                  <a:pt x="23288" y="16020"/>
-                </a:cubicBezTo>
-                <a:lnTo>
-                  <a:pt x="13392" y="15995"/>
-                </a:lnTo>
-                <a:cubicBezTo>
-                  <a:pt x="12940" y="15994"/>
-                  <a:pt x="12530" y="16256"/>
-                  <a:pt x="12341" y="16666"/>
-                </a:cubicBezTo>
-                <a:lnTo>
-                  <a:pt x="10940" y="19703"/>
-                </a:lnTo>
-                <a:cubicBezTo>
-                  <a:pt x="10621" y="20395"/>
-                  <a:pt x="9927" y="20838"/>
-                  <a:pt x="9164" y="20836"/>
-                </a:cubicBezTo>
-                <a:lnTo>
-                  <a:pt x="3836" y="20823"/>
-                </a:lnTo>
-                <a:cubicBezTo>
-                  <a:pt x="3526" y="20822"/>
-                  <a:pt x="3245" y="21002"/>
-                  <a:pt x="3115" y="21283"/>
-                </a:cubicBezTo>
-                <a:lnTo>
-                  <a:pt x="968" y="25929"/>
-                </a:lnTo>
-                <a:lnTo>
-                  <a:pt x="6622" y="25943"/>
-                </a:lnTo>
-                <a:cubicBezTo>
-                  <a:pt x="7672" y="25946"/>
-                  <a:pt x="8628" y="25336"/>
-                  <a:pt x="9069" y="24382"/>
-                </a:cubicBezTo>
-                <a:lnTo>
-                  <a:pt x="10057" y="22238"/>
-                </a:lnTo>
-                <a:cubicBezTo>
-                  <a:pt x="10376" y="21545"/>
-                  <a:pt x="11069" y="21127"/>
-                  <a:pt x="11831" y="21129"/>
-                </a:cubicBezTo>
-                <a:lnTo>
-                  <a:pt x="23275" y="21129"/>
-                </a:lnTo>
-                <a:cubicBezTo>
-                  <a:pt x="27590" y="21139"/>
-                  <a:pt x="31100" y="17611"/>
-                  <a:pt x="31047" y="13282"/>
-                </a:cubicBezTo>
-                <a:cubicBezTo>
-                  <a:pt x="30995" y="9026"/>
-                  <a:pt x="27452" y="5636"/>
-                  <a:pt x="23195" y="5625"/>
-                </a:cubicBezTo>
-              </a:path>
-            </a:pathLst>
-          </a:custGeom>
-          <a:solidFill>
-            <a:schemeClr val="tx1"/>
-          </a:solidFill>
-          <a:ln>
-            <a:noFill/>
-          </a:ln>
-          <a:effectLst/>
-        </p:spPr>
-        <p:style>
-          <a:lnRef idx="1">
-            <a:schemeClr val="accent1"/>
-          </a:lnRef>
-          <a:fillRef idx="3">
-            <a:schemeClr val="accent1"/>
-          </a:fillRef>
-          <a:effectRef idx="2">
-            <a:schemeClr val="accent1"/>
-          </a:effectRef>
-          <a:fontRef idx="minor">
-            <a:schemeClr val="lt1"/>
-          </a:fontRef>
-        </p:style>
-        <p:txBody>
-          <a:bodyPr rtlCol="0" anchor="ctr"/>
-          <a:lstStyle/>
-          <a:p>
-            <a:pPr algn="ctr"/>
-          </a:p>
-        </p:txBody>
-      </p:sp>
-      <p:sp>
-        <p:nvSpPr>
-          <p:cNvPr id="5" name="Shift wordmark (stacked)"/>
+          <p:cNvPr id="4" name="Shift wordmark (stacked)"/>
           <p:cNvSpPr/>
           <p:nvPr/>
         </p:nvSpPr>
@@ -11368,8 +12459,8 @@
         </p:nvSpPr>
         <p:spPr>
           <a:xfrm>
-            <a:off x="8534378" y="438910"/>
-            <a:ext cx="3151624" cy="1706875"/>
+            <a:off x="7071342" y="438910"/>
+            <a:ext cx="3718550" cy="1706875"/>
           </a:xfrm>
           <a:prstGeom prst="rect">
             <a:avLst/>

</xml_diff>